<commit_message>
System Design vi: address review of sd-14-017 and sd-14-020 (compat ChangeCipherSpec, per-direction keys, signed-JWT scope), refresh mobile check and decks
Co-Authored-By: Claude Sonnet 5.5 <noreply@anthropic.com>
Claude-Session: https://claude.ai/code/session_01WnjciXNJBLEd8jy3HrG49S
</commit_message>
<xml_diff>
--- a/system-design-101/vi/lessons/sd-14-017/slides/sd-14-017.pptx
+++ b/system-design-101/vi/lessons/sd-14-017/slides/sd-14-017.pptx
@@ -9783,14 +9783,14 @@
       </p:sp>
       <p:sp>
         <p:nvSpPr>
-          <p:cNvPr id="9" name="Connector line-1792334558633-107725509"/>
+          <p:cNvPr id="9" name="Connector line-1792337874396-918032160"/>
           <p:cNvSpPr/>
           <p:nvPr/>
         </p:nvSpPr>
         <p:spPr>
           <a:xfrm>
             <a:off x="10477500" y="1790700"/>
-            <a:ext cx="0" cy="6381750"/>
+            <a:ext cx="0" cy="6457950"/>
           </a:xfrm>
           <a:prstGeom prst="line">
             <a:avLst/>
@@ -9808,14 +9808,14 @@
       </p:sp>
       <p:sp>
         <p:nvSpPr>
-          <p:cNvPr id="10" name="Connector line-1792334558633-669123561"/>
+          <p:cNvPr id="10" name="Connector line-1792337874396-845132759"/>
           <p:cNvSpPr/>
           <p:nvPr/>
         </p:nvSpPr>
         <p:spPr>
           <a:xfrm>
             <a:off x="15430500" y="1790700"/>
-            <a:ext cx="0" cy="6381750"/>
+            <a:ext cx="0" cy="6457950"/>
           </a:xfrm>
           <a:prstGeom prst="line">
             <a:avLst/>
@@ -9947,7 +9947,7 @@
         </p:nvSpPr>
         <p:spPr>
           <a:xfrm>
-            <a:off x="8858250" y="2038350"/>
+            <a:off x="8858250" y="2000250"/>
             <a:ext cx="8229600" cy="4038600"/>
           </a:xfrm>
           <a:prstGeom prst="roundRect">
@@ -9978,7 +9978,7 @@
         </p:nvSpPr>
         <p:spPr>
           <a:xfrm>
-            <a:off x="9144000" y="2209800"/>
+            <a:off x="9144000" y="2171700"/>
             <a:ext cx="5715000" cy="285750"/>
           </a:xfrm>
           <a:prstGeom prst="rect">
@@ -10050,7 +10050,7 @@
         </p:nvSpPr>
         <p:spPr>
           <a:xfrm>
-            <a:off x="11049000" y="2667000"/>
+            <a:off x="11049000" y="2628900"/>
             <a:ext cx="3810000" cy="419100"/>
           </a:xfrm>
           <a:prstGeom prst="rect">
@@ -10083,13 +10083,13 @@
       </p:sp>
       <p:sp>
         <p:nvSpPr>
-          <p:cNvPr id="16" name="Connector line-1792334558646-288079640"/>
-          <p:cNvSpPr/>
-          <p:nvPr/>
-        </p:nvSpPr>
-        <p:spPr>
-          <a:xfrm>
-            <a:off x="10553700" y="3219450"/>
+          <p:cNvPr id="16" name="Connector line-1792337874406-759141858"/>
+          <p:cNvSpPr/>
+          <p:nvPr/>
+        </p:nvSpPr>
+        <p:spPr>
+          <a:xfrm>
+            <a:off x="10553700" y="3181350"/>
             <a:ext cx="4800600" cy="0"/>
           </a:xfrm>
           <a:prstGeom prst="line">
@@ -10114,7 +10114,7 @@
         </p:nvSpPr>
         <p:spPr>
           <a:xfrm>
-            <a:off x="10668000" y="3371850"/>
+            <a:off x="10668000" y="3333750"/>
             <a:ext cx="4572000" cy="666750"/>
           </a:xfrm>
           <a:prstGeom prst="rect">
@@ -10286,7 +10286,7 @@
         </p:nvSpPr>
         <p:spPr>
           <a:xfrm>
-            <a:off x="11049000" y="4457700"/>
+            <a:off x="11049000" y="4419600"/>
             <a:ext cx="3810000" cy="419100"/>
           </a:xfrm>
           <a:prstGeom prst="rect">
@@ -10319,13 +10319,13 @@
       </p:sp>
       <p:sp>
         <p:nvSpPr>
-          <p:cNvPr id="19" name="Connector line-1792334558655-520212034"/>
+          <p:cNvPr id="19" name="Connector line-1792337874410-66819178"/>
           <p:cNvSpPr/>
           <p:nvPr/>
         </p:nvSpPr>
         <p:spPr>
           <a:xfrm flipH="1">
-            <a:off x="10553700" y="5010150"/>
+            <a:off x="10553700" y="4972050"/>
             <a:ext cx="4800600" cy="0"/>
           </a:xfrm>
           <a:prstGeom prst="line">
@@ -10350,7 +10350,7 @@
         </p:nvSpPr>
         <p:spPr>
           <a:xfrm>
-            <a:off x="10668000" y="5162550"/>
+            <a:off x="10668000" y="5124450"/>
             <a:ext cx="4572000" cy="666750"/>
           </a:xfrm>
           <a:prstGeom prst="rect">
@@ -10500,12 +10500,12 @@
         </p:nvSpPr>
         <p:spPr>
           <a:xfrm>
-            <a:off x="8858250" y="6362700"/>
-            <a:ext cx="8229600" cy="1809750"/>
+            <a:off x="8858250" y="6191250"/>
+            <a:ext cx="8229600" cy="2152650"/>
           </a:xfrm>
           <a:prstGeom prst="roundRect">
             <a:avLst>
-              <a:gd name="adj" fmla="val 11579"/>
+              <a:gd name="adj" fmla="val 9735"/>
             </a:avLst>
           </a:prstGeom>
           <a:solidFill>
@@ -10531,7 +10531,7 @@
         </p:nvSpPr>
         <p:spPr>
           <a:xfrm>
-            <a:off x="9144000" y="6534150"/>
+            <a:off x="9144000" y="6343650"/>
             <a:ext cx="5715000" cy="285750"/>
           </a:xfrm>
           <a:prstGeom prst="rect">
@@ -10592,7 +10592,7 @@
         </p:nvSpPr>
         <p:spPr>
           <a:xfrm>
-            <a:off x="9372600" y="6896100"/>
+            <a:off x="9372600" y="6838950"/>
             <a:ext cx="381000" cy="323850"/>
           </a:xfrm>
           <a:custGeom>
@@ -10641,7 +10641,7 @@
         </p:nvSpPr>
         <p:spPr>
           <a:xfrm>
-            <a:off x="9258300" y="7200900"/>
+            <a:off x="9258300" y="7143750"/>
             <a:ext cx="609600" cy="495300"/>
           </a:xfrm>
           <a:prstGeom prst="roundRect">
@@ -10663,8 +10663,8 @@
         </p:nvSpPr>
         <p:spPr>
           <a:xfrm>
-            <a:off x="10191750" y="7010400"/>
-            <a:ext cx="6667500" cy="952500"/>
+            <a:off x="10191750" y="6705600"/>
+            <a:ext cx="6762750" cy="800100"/>
           </a:xfrm>
           <a:prstGeom prst="rect">
             <a:avLst/>
@@ -10673,17 +10673,17 @@
           <a:ln/>
         </p:spPr>
         <p:txBody>
-          <a:bodyPr wrap="square" lIns="0" tIns="13764" rIns="0" bIns="-13764" rtlCol="0" anchor="t"/>
+          <a:bodyPr wrap="square" lIns="0" tIns="16764" rIns="0" bIns="-16764" rtlCol="0" anchor="t"/>
           <a:lstStyle/>
           <a:p>
             <a:pPr algn="l" indent="0" marL="0">
               <a:lnSpc>
-                <a:spcPts val="3315"/>
+                <a:spcPts val="3000"/>
               </a:lnSpc>
               <a:buNone/>
             </a:pPr>
             <a:r>
-              <a:rPr lang="en-US" sz="2550" b="1" dirty="0" spc="-92" kern="0">
+              <a:rPr lang="en-US" sz="2400" b="1" dirty="0" spc="5" kern="0">
                 <a:solidFill>
                   <a:srgbClr val="3DD6A0"/>
                 </a:solidFill>
@@ -10691,10 +10691,10 @@
                 <a:ea typeface="Be Vietnam Pro" pitchFamily="34" charset="-122"/>
                 <a:cs typeface="Be Vietnam Pro" pitchFamily="34" charset="-120"/>
               </a:rPr>
-              <a:t>Từ</a:t>
-            </a:r>
-            <a:r>
-              <a:rPr lang="en-US" sz="2550" b="1" dirty="0" spc="-6" kern="0">
+              <a:t>Sau</a:t>
+            </a:r>
+            <a:r>
+              <a:rPr lang="en-US" sz="2400" b="1" dirty="0" spc="-6" kern="0">
                 <a:solidFill>
                   <a:srgbClr val="3DD6A0"/>
                 </a:solidFill>
@@ -10702,10 +10702,21 @@
                 <a:ea typeface="Be Vietnam Pro" pitchFamily="34" charset="-122"/>
                 <a:cs typeface="Be Vietnam Pro" pitchFamily="34" charset="-120"/>
               </a:rPr>
+              <a:t> ServerHello,</a:t>
+            </a:r>
+            <a:r>
+              <a:rPr lang="en-US" sz="2400" b="1" dirty="0" spc="-9" kern="0">
+                <a:solidFill>
+                  <a:srgbClr val="3DD6A0"/>
+                </a:solidFill>
+                <a:latin typeface="Be Vietnam Pro" pitchFamily="34" charset="0"/>
+                <a:ea typeface="Be Vietnam Pro" pitchFamily="34" charset="-122"/>
+                <a:cs typeface="Be Vietnam Pro" pitchFamily="34" charset="-120"/>
+              </a:rPr>
               <a:t> thông</a:t>
             </a:r>
             <a:r>
-              <a:rPr lang="en-US" sz="2550" b="1" dirty="0" spc="12" kern="0">
+              <a:rPr lang="en-US" sz="2400" b="1" dirty="0" spc="12" kern="0">
                 <a:solidFill>
                   <a:srgbClr val="3DD6A0"/>
                 </a:solidFill>
@@ -10716,7 +10727,7 @@
               <a:t> điệp</a:t>
             </a:r>
             <a:r>
-              <a:rPr lang="en-US" sz="2550" b="1" dirty="0" spc="-32" kern="0">
+              <a:rPr lang="en-US" sz="2400" b="1" dirty="0" spc="-6" kern="0">
                 <a:solidFill>
                   <a:srgbClr val="3DD6A0"/>
                 </a:solidFill>
@@ -10724,10 +10735,10 @@
                 <a:ea typeface="Be Vietnam Pro" pitchFamily="34" charset="-122"/>
                 <a:cs typeface="Be Vietnam Pro" pitchFamily="34" charset="-120"/>
               </a:rPr>
-              <a:t> kế</a:t>
-            </a:r>
-            <a:r>
-              <a:rPr lang="en-US" sz="2550" b="1" dirty="0" spc="-1" kern="0">
+              <a:t> bắt</a:t>
+            </a:r>
+            <a:r>
+              <a:rPr lang="en-US" sz="2400" b="1" dirty="0" spc="-11" kern="0">
                 <a:solidFill>
                   <a:srgbClr val="3DD6A0"/>
                 </a:solidFill>
@@ -10735,19 +10746,19 @@
                 <a:ea typeface="Be Vietnam Pro" pitchFamily="34" charset="-122"/>
                 <a:cs typeface="Be Vietnam Pro" pitchFamily="34" charset="-120"/>
               </a:rPr>
-              <a:t> tiếp,</a:t>
-            </a:r>
-            <a:endParaRPr lang="en-US" sz="2550" dirty="0"/>
+              <a:t> tay</a:t>
+            </a:r>
+            <a:endParaRPr lang="en-US" sz="2400" dirty="0"/>
           </a:p>
           <a:p>
             <a:pPr algn="l" indent="0" marL="0">
               <a:lnSpc>
-                <a:spcPts val="3315"/>
+                <a:spcPts val="3000"/>
               </a:lnSpc>
               <a:buNone/>
             </a:pPr>
             <a:r>
-              <a:rPr lang="en-US" sz="2550" b="1" dirty="0" spc="-3" kern="0">
+              <a:rPr lang="en-US" sz="2400" b="1" dirty="0" spc="-7" kern="0">
                 <a:solidFill>
                   <a:srgbClr val="3DD6A0"/>
                 </a:solidFill>
@@ -10755,10 +10766,10 @@
                 <a:ea typeface="Be Vietnam Pro" pitchFamily="34" charset="-122"/>
                 <a:cs typeface="Be Vietnam Pro" pitchFamily="34" charset="-120"/>
               </a:rPr>
-              <a:t>mọi</a:t>
-            </a:r>
-            <a:r>
-              <a:rPr lang="en-US" sz="2550" b="1" dirty="0" spc="-1" kern="0">
+              <a:t>có</a:t>
+            </a:r>
+            <a:r>
+              <a:rPr lang="en-US" sz="2400" b="1" dirty="0" spc="-3" kern="0">
                 <a:solidFill>
                   <a:srgbClr val="3DD6A0"/>
                 </a:solidFill>
@@ -10766,10 +10777,10 @@
                 <a:ea typeface="Be Vietnam Pro" pitchFamily="34" charset="-122"/>
                 <a:cs typeface="Be Vietnam Pro" pitchFamily="34" charset="-120"/>
               </a:rPr>
-              <a:t> thứ</a:t>
-            </a:r>
-            <a:r>
-              <a:rPr lang="en-US" sz="2550" b="1" dirty="0" spc="6" kern="0">
+              <a:t> nội</a:t>
+            </a:r>
+            <a:r>
+              <a:rPr lang="en-US" sz="2400" b="1" dirty="0" spc="-4" kern="0">
                 <a:solidFill>
                   <a:srgbClr val="3DD6A0"/>
                 </a:solidFill>
@@ -10777,10 +10788,21 @@
                 <a:ea typeface="Be Vietnam Pro" pitchFamily="34" charset="-122"/>
                 <a:cs typeface="Be Vietnam Pro" pitchFamily="34" charset="-120"/>
               </a:rPr>
+              <a:t> dung</a:t>
+            </a:r>
+            <a:r>
+              <a:rPr lang="en-US" sz="2400" b="1" dirty="0" spc="10" kern="0">
+                <a:solidFill>
+                  <a:srgbClr val="3DD6A0"/>
+                </a:solidFill>
+                <a:latin typeface="Be Vietnam Pro" pitchFamily="34" charset="0"/>
+                <a:ea typeface="Be Vietnam Pro" pitchFamily="34" charset="-122"/>
+                <a:cs typeface="Be Vietnam Pro" pitchFamily="34" charset="-120"/>
+              </a:rPr>
               <a:t> đã</a:t>
             </a:r>
             <a:r>
-              <a:rPr lang="en-US" sz="2550" b="1" dirty="0" spc="-5" kern="0">
+              <a:rPr lang="en-US" sz="2400" b="1" dirty="0" spc="-3" kern="0">
                 <a:solidFill>
                   <a:srgbClr val="3DD6A0"/>
                 </a:solidFill>
@@ -10791,7 +10813,7 @@
               <a:t> mã</a:t>
             </a:r>
             <a:r>
-              <a:rPr lang="en-US" sz="2550" b="1" dirty="0" spc="-6" kern="0">
+              <a:rPr lang="en-US" sz="2400" b="1" dirty="0" spc="-4" kern="0">
                 <a:solidFill>
                   <a:srgbClr val="3DD6A0"/>
                 </a:solidFill>
@@ -10801,19 +10823,213 @@
               </a:rPr>
               <a:t> hóa</a:t>
             </a:r>
-            <a:endParaRPr lang="en-US" sz="2550" dirty="0"/>
+            <a:endParaRPr lang="en-US" sz="2400" dirty="0"/>
           </a:p>
         </p:txBody>
       </p:sp>
       <p:sp>
         <p:nvSpPr>
-          <p:cNvPr id="26" name="Connector line-1792334558676-964419906"/>
-          <p:cNvSpPr/>
-          <p:nvPr/>
-        </p:nvSpPr>
-        <p:spPr>
-          <a:xfrm>
-            <a:off x="9144000" y="8534400"/>
+          <p:cNvPr id="26" name="Text 24"/>
+          <p:cNvSpPr/>
+          <p:nvPr/>
+        </p:nvSpPr>
+        <p:spPr>
+          <a:xfrm>
+            <a:off x="10191750" y="7581900"/>
+            <a:ext cx="6762750" cy="628650"/>
+          </a:xfrm>
+          <a:prstGeom prst="rect">
+            <a:avLst/>
+          </a:prstGeom>
+          <a:noFill/>
+          <a:ln/>
+        </p:spPr>
+        <p:txBody>
+          <a:bodyPr wrap="square" lIns="0" tIns="9716" rIns="0" bIns="-9716" rtlCol="0" anchor="t"/>
+          <a:lstStyle/>
+          <a:p>
+            <a:pPr algn="l" indent="0" marL="0">
+              <a:lnSpc>
+                <a:spcPts val="2340"/>
+              </a:lnSpc>
+              <a:buNone/>
+            </a:pPr>
+            <a:r>
+              <a:rPr lang="en-US" sz="1800" dirty="0" spc="-4" kern="0">
+                <a:solidFill>
+                  <a:srgbClr val="9A98A0"/>
+                </a:solidFill>
+                <a:latin typeface="Be Vietnam Pro" pitchFamily="34" charset="0"/>
+                <a:ea typeface="Be Vietnam Pro" pitchFamily="34" charset="-122"/>
+                <a:cs typeface="Be Vietnam Pro" pitchFamily="34" charset="-120"/>
+              </a:rPr>
+              <a:t>Còn</a:t>
+            </a:r>
+            <a:r>
+              <a:rPr lang="en-US" sz="1800" dirty="0" spc="-6" kern="0">
+                <a:solidFill>
+                  <a:srgbClr val="9A98A0"/>
+                </a:solidFill>
+                <a:latin typeface="Be Vietnam Pro" pitchFamily="34" charset="0"/>
+                <a:ea typeface="Be Vietnam Pro" pitchFamily="34" charset="-122"/>
+                <a:cs typeface="Be Vietnam Pro" pitchFamily="34" charset="-120"/>
+              </a:rPr>
+              <a:t> thấy</a:t>
+            </a:r>
+            <a:r>
+              <a:rPr lang="en-US" sz="1800" dirty="0" spc="-7" kern="0">
+                <a:solidFill>
+                  <a:srgbClr val="9A98A0"/>
+                </a:solidFill>
+                <a:latin typeface="Be Vietnam Pro" pitchFamily="34" charset="0"/>
+                <a:ea typeface="Be Vietnam Pro" pitchFamily="34" charset="-122"/>
+                <a:cs typeface="Be Vietnam Pro" pitchFamily="34" charset="-120"/>
+              </a:rPr>
+              <a:t> một</a:t>
+            </a:r>
+            <a:r>
+              <a:rPr lang="en-US" sz="1800" dirty="0" spc="-4" kern="0">
+                <a:solidFill>
+                  <a:srgbClr val="9A98A0"/>
+                </a:solidFill>
+                <a:latin typeface="Be Vietnam Pro" pitchFamily="34" charset="0"/>
+                <a:ea typeface="Be Vietnam Pro" pitchFamily="34" charset="-122"/>
+                <a:cs typeface="Be Vietnam Pro" pitchFamily="34" charset="-120"/>
+              </a:rPr>
+              <a:t> bản</a:t>
+            </a:r>
+            <a:r>
+              <a:rPr lang="en-US" sz="1800" dirty="0" spc="-1" kern="0">
+                <a:solidFill>
+                  <a:srgbClr val="9A98A0"/>
+                </a:solidFill>
+                <a:latin typeface="Be Vietnam Pro" pitchFamily="34" charset="0"/>
+                <a:ea typeface="Be Vietnam Pro" pitchFamily="34" charset="-122"/>
+                <a:cs typeface="Be Vietnam Pro" pitchFamily="34" charset="-120"/>
+              </a:rPr>
+              <a:t> ghi</a:t>
+            </a:r>
+            <a:r>
+              <a:rPr lang="en-US" sz="1800" dirty="0" spc="-3" kern="0">
+                <a:solidFill>
+                  <a:srgbClr val="9A98A0"/>
+                </a:solidFill>
+                <a:latin typeface="Be Vietnam Pro" pitchFamily="34" charset="0"/>
+                <a:ea typeface="Be Vietnam Pro" pitchFamily="34" charset="-122"/>
+                <a:cs typeface="Be Vietnam Pro" pitchFamily="34" charset="-120"/>
+              </a:rPr>
+              <a:t> ChangeCipherSpec</a:t>
+            </a:r>
+            <a:r>
+              <a:rPr lang="en-US" sz="1800" dirty="0" spc="5" kern="0">
+                <a:solidFill>
+                  <a:srgbClr val="9A98A0"/>
+                </a:solidFill>
+                <a:latin typeface="Be Vietnam Pro" pitchFamily="34" charset="0"/>
+                <a:ea typeface="Be Vietnam Pro" pitchFamily="34" charset="-122"/>
+                <a:cs typeface="Be Vietnam Pro" pitchFamily="34" charset="-120"/>
+              </a:rPr>
+              <a:t> 1</a:t>
+            </a:r>
+            <a:r>
+              <a:rPr lang="en-US" sz="1800" dirty="0" spc="-11" kern="0">
+                <a:solidFill>
+                  <a:srgbClr val="9A98A0"/>
+                </a:solidFill>
+                <a:latin typeface="Be Vietnam Pro" pitchFamily="34" charset="0"/>
+                <a:ea typeface="Be Vietnam Pro" pitchFamily="34" charset="-122"/>
+                <a:cs typeface="Be Vietnam Pro" pitchFamily="34" charset="-120"/>
+              </a:rPr>
+              <a:t> byte,</a:t>
+            </a:r>
+            <a:endParaRPr lang="en-US" sz="1800" dirty="0"/>
+          </a:p>
+          <a:p>
+            <a:pPr algn="l" indent="0" marL="0">
+              <a:lnSpc>
+                <a:spcPts val="2340"/>
+              </a:lnSpc>
+              <a:buNone/>
+            </a:pPr>
+            <a:r>
+              <a:rPr lang="en-US" sz="1800" dirty="0" spc="-3" kern="0">
+                <a:solidFill>
+                  <a:srgbClr val="9A98A0"/>
+                </a:solidFill>
+                <a:latin typeface="Be Vietnam Pro" pitchFamily="34" charset="0"/>
+                <a:ea typeface="Be Vietnam Pro" pitchFamily="34" charset="-122"/>
+                <a:cs typeface="Be Vietnam Pro" pitchFamily="34" charset="-120"/>
+              </a:rPr>
+              <a:t>không</a:t>
+            </a:r>
+            <a:r>
+              <a:rPr lang="en-US" sz="1800" dirty="0" spc="1" kern="0">
+                <a:solidFill>
+                  <a:srgbClr val="9A98A0"/>
+                </a:solidFill>
+                <a:latin typeface="Be Vietnam Pro" pitchFamily="34" charset="0"/>
+                <a:ea typeface="Be Vietnam Pro" pitchFamily="34" charset="-122"/>
+                <a:cs typeface="Be Vietnam Pro" pitchFamily="34" charset="-120"/>
+              </a:rPr>
+              <a:t> có</a:t>
+            </a:r>
+            <a:r>
+              <a:rPr lang="en-US" sz="1800" dirty="0" spc="-1" kern="0">
+                <a:solidFill>
+                  <a:srgbClr val="9A98A0"/>
+                </a:solidFill>
+                <a:latin typeface="Be Vietnam Pro" pitchFamily="34" charset="0"/>
+                <a:ea typeface="Be Vietnam Pro" pitchFamily="34" charset="-122"/>
+                <a:cs typeface="Be Vietnam Pro" pitchFamily="34" charset="-120"/>
+              </a:rPr>
+              <a:t> nội</a:t>
+            </a:r>
+            <a:r>
+              <a:rPr lang="en-US" sz="1800" dirty="0" spc="-4" kern="0">
+                <a:solidFill>
+                  <a:srgbClr val="9A98A0"/>
+                </a:solidFill>
+                <a:latin typeface="Be Vietnam Pro" pitchFamily="34" charset="0"/>
+                <a:ea typeface="Be Vietnam Pro" pitchFamily="34" charset="-122"/>
+                <a:cs typeface="Be Vietnam Pro" pitchFamily="34" charset="-120"/>
+              </a:rPr>
+              <a:t> dung</a:t>
+            </a:r>
+            <a:r>
+              <a:rPr lang="en-US" sz="1800" dirty="0" spc="-12" kern="0">
+                <a:solidFill>
+                  <a:srgbClr val="9A98A0"/>
+                </a:solidFill>
+                <a:latin typeface="Be Vietnam Pro" pitchFamily="34" charset="0"/>
+                <a:ea typeface="Be Vietnam Pro" pitchFamily="34" charset="-122"/>
+                <a:cs typeface="Be Vietnam Pro" pitchFamily="34" charset="-120"/>
+              </a:rPr>
+              <a:t> bắt</a:t>
+            </a:r>
+            <a:r>
+              <a:rPr lang="en-US" sz="1800" dirty="0" spc="-15" kern="0">
+                <a:solidFill>
+                  <a:srgbClr val="9A98A0"/>
+                </a:solidFill>
+                <a:latin typeface="Be Vietnam Pro" pitchFamily="34" charset="0"/>
+                <a:ea typeface="Be Vietnam Pro" pitchFamily="34" charset="-122"/>
+                <a:cs typeface="Be Vietnam Pro" pitchFamily="34" charset="-120"/>
+              </a:rPr>
+              <a:t> tay</a:t>
+            </a:r>
+            <a:endParaRPr lang="en-US" sz="1800" dirty="0"/>
+          </a:p>
+        </p:txBody>
+      </p:sp>
+      <p:sp>
+        <p:nvSpPr>
+          <p:cNvPr id="27" name="Connector line-1792337874433-477646647"/>
+          <p:cNvSpPr/>
+          <p:nvPr/>
+        </p:nvSpPr>
+        <p:spPr>
+          <a:xfrm>
+            <a:off x="9144000" y="8610600"/>
             <a:ext cx="419100" cy="0"/>
           </a:xfrm>
           <a:prstGeom prst="line">
@@ -10832,13 +11048,13 @@
       </p:sp>
       <p:sp>
         <p:nvSpPr>
-          <p:cNvPr id="27" name="Text 25"/>
-          <p:cNvSpPr/>
-          <p:nvPr/>
-        </p:nvSpPr>
-        <p:spPr>
-          <a:xfrm>
-            <a:off x="9715500" y="8401050"/>
+          <p:cNvPr id="28" name="Text 26"/>
+          <p:cNvSpPr/>
+          <p:nvPr/>
+        </p:nvSpPr>
+        <p:spPr>
+          <a:xfrm>
+            <a:off x="9715500" y="8477250"/>
             <a:ext cx="6667500" cy="285750"/>
           </a:xfrm>
           <a:prstGeom prst="rect">
@@ -10904,7 +11120,7 @@
       </p:sp>
       <p:sp>
         <p:nvSpPr>
-          <p:cNvPr id="28" name="Connector line-1792334558679-192018473"/>
+          <p:cNvPr id="29" name="Connector line-1792337874435-755292798"/>
           <p:cNvSpPr/>
           <p:nvPr/>
         </p:nvSpPr>
@@ -10931,7 +11147,7 @@
       </p:sp>
       <p:sp>
         <p:nvSpPr>
-          <p:cNvPr id="29" name="Shape 27"/>
+          <p:cNvPr id="30" name="Shape 28"/>
           <p:cNvSpPr/>
           <p:nvPr/>
         </p:nvSpPr>
@@ -10951,7 +11167,7 @@
       </p:sp>
       <p:sp>
         <p:nvSpPr>
-          <p:cNvPr id="30" name="Shape 28"/>
+          <p:cNvPr id="31" name="Shape 29"/>
           <p:cNvSpPr/>
           <p:nvPr/>
         </p:nvSpPr>
@@ -10971,7 +11187,7 @@
       </p:sp>
       <p:sp>
         <p:nvSpPr>
-          <p:cNvPr id="31" name="Shape 29"/>
+          <p:cNvPr id="32" name="Shape 30"/>
           <p:cNvSpPr/>
           <p:nvPr/>
         </p:nvSpPr>
@@ -10991,7 +11207,7 @@
       </p:sp>
       <p:sp>
         <p:nvSpPr>
-          <p:cNvPr id="32" name="Shape 30"/>
+          <p:cNvPr id="33" name="Shape 31"/>
           <p:cNvSpPr/>
           <p:nvPr/>
         </p:nvSpPr>
@@ -11016,7 +11232,7 @@
       </p:sp>
       <p:sp>
         <p:nvSpPr>
-          <p:cNvPr id="33" name="Shape 31"/>
+          <p:cNvPr id="34" name="Shape 32"/>
           <p:cNvSpPr/>
           <p:nvPr/>
         </p:nvSpPr>
@@ -11041,7 +11257,7 @@
       </p:sp>
       <p:sp>
         <p:nvSpPr>
-          <p:cNvPr id="34" name="Shape 32"/>
+          <p:cNvPr id="35" name="Shape 33"/>
           <p:cNvSpPr/>
           <p:nvPr/>
         </p:nvSpPr>
@@ -11066,7 +11282,7 @@
       </p:sp>
       <p:sp>
         <p:nvSpPr>
-          <p:cNvPr id="35" name="Shape 33"/>
+          <p:cNvPr id="36" name="Shape 34"/>
           <p:cNvSpPr/>
           <p:nvPr/>
         </p:nvSpPr>
@@ -11091,7 +11307,7 @@
       </p:sp>
       <p:sp>
         <p:nvSpPr>
-          <p:cNvPr id="36" name="Shape 34"/>
+          <p:cNvPr id="37" name="Shape 35"/>
           <p:cNvSpPr/>
           <p:nvPr/>
         </p:nvSpPr>
@@ -11116,7 +11332,7 @@
       </p:sp>
       <p:sp>
         <p:nvSpPr>
-          <p:cNvPr id="37" name="Shape 35"/>
+          <p:cNvPr id="38" name="Shape 36"/>
           <p:cNvSpPr/>
           <p:nvPr/>
         </p:nvSpPr>
@@ -11141,7 +11357,7 @@
       </p:sp>
       <p:sp>
         <p:nvSpPr>
-          <p:cNvPr id="38" name="Shape 36"/>
+          <p:cNvPr id="39" name="Shape 37"/>
           <p:cNvSpPr/>
           <p:nvPr/>
         </p:nvSpPr>
@@ -11166,7 +11382,7 @@
       </p:sp>
       <p:sp>
         <p:nvSpPr>
-          <p:cNvPr id="39" name="Text 37"/>
+          <p:cNvPr id="40" name="Text 38"/>
           <p:cNvSpPr/>
           <p:nvPr/>
         </p:nvSpPr>
@@ -11282,7 +11498,7 @@
       </p:sp>
       <p:sp>
         <p:nvSpPr>
-          <p:cNvPr id="40" name="Shape 38"/>
+          <p:cNvPr id="41" name="Shape 39"/>
           <p:cNvSpPr/>
           <p:nvPr/>
         </p:nvSpPr>
@@ -11306,7 +11522,7 @@
       </p:sp>
       <p:pic>
         <p:nvPicPr>
-          <p:cNvPr id="41" name="Moda image moda-export-watermark-83462f27-ed7e-456d-9f59-86579e97fa02" descr="">    </p:cNvPr>
+          <p:cNvPr id="42" name="Moda image moda-export-watermark-83462f27-ed7e-456d-9f59-86579e97fa02" descr="">    </p:cNvPr>
           <p:cNvPicPr>
             <a:picLocks noChangeAspect="1"/>
           </p:cNvPicPr>
@@ -13952,7 +14168,7 @@
         </p:nvSpPr>
         <p:spPr>
           <a:xfrm>
-            <a:off x="914400" y="2647950"/>
+            <a:off x="914400" y="2590800"/>
             <a:ext cx="12382500" cy="533400"/>
           </a:xfrm>
           <a:prstGeom prst="rect">
@@ -13969,7 +14185,7 @@
               <a:buNone/>
             </a:pPr>
             <a:r>
-              <a:rPr lang="en-US" sz="3000" dirty="0" spc="0" kern="0">
+              <a:rPr lang="en-US" sz="3000" dirty="0" spc="1" kern="0">
                 <a:solidFill>
                   <a:srgbClr val="3DD6A0"/>
                 </a:solidFill>
@@ -13977,10 +14193,10 @@
                 <a:ea typeface="Be Vietnam Pro SemiBold" pitchFamily="34" charset="-122"/>
                 <a:cs typeface="Be Vietnam Pro SemiBold" pitchFamily="34" charset="-120"/>
               </a:rPr>
-              <a:t>Bản</a:t>
-            </a:r>
-            <a:r>
-              <a:rPr lang="en-US" sz="3000" dirty="0" spc="2" kern="0">
+              <a:t>Mỗi chiều</a:t>
+            </a:r>
+            <a:r>
+              <a:rPr lang="en-US" sz="3000" dirty="0" spc="-9" kern="0">
                 <a:solidFill>
                   <a:srgbClr val="3DD6A0"/>
                 </a:solidFill>
@@ -13988,10 +14204,10 @@
                 <a:ea typeface="Be Vietnam Pro SemiBold" pitchFamily="34" charset="-122"/>
                 <a:cs typeface="Be Vietnam Pro SemiBold" pitchFamily="34" charset="-120"/>
               </a:rPr>
-              <a:t> ghi</a:t>
-            </a:r>
-            <a:r>
-              <a:rPr lang="en-US" sz="3000" dirty="0" spc="-3" kern="0">
+              <a:t> một</a:t>
+            </a:r>
+            <a:r>
+              <a:rPr lang="en-US" sz="3000" dirty="0" spc="-2" kern="0">
                 <a:solidFill>
                   <a:srgbClr val="3DD6A0"/>
                 </a:solidFill>
@@ -13999,10 +14215,10 @@
                 <a:ea typeface="Be Vietnam Pro SemiBold" pitchFamily="34" charset="-122"/>
                 <a:cs typeface="Be Vietnam Pro SemiBold" pitchFamily="34" charset="-120"/>
               </a:rPr>
-              <a:t> mã hóa</a:t>
-            </a:r>
-            <a:r>
-              <a:rPr lang="en-US" sz="3000" dirty="0" spc="-4" kern="0">
+              <a:t> khóa</a:t>
+            </a:r>
+            <a:r>
+              <a:rPr lang="en-US" sz="3000" dirty="0" spc="14" kern="0">
                 <a:solidFill>
                   <a:srgbClr val="3DD6A0"/>
                 </a:solidFill>
@@ -14010,10 +14226,10 @@
                 <a:ea typeface="Be Vietnam Pro SemiBold" pitchFamily="34" charset="-122"/>
                 <a:cs typeface="Be Vietnam Pro SemiBold" pitchFamily="34" charset="-120"/>
               </a:rPr>
-              <a:t> bằng</a:t>
-            </a:r>
-            <a:r>
-              <a:rPr lang="en-US" sz="3000" dirty="0" spc="-2" kern="0">
+              <a:t> đối</a:t>
+            </a:r>
+            <a:r>
+              <a:rPr lang="en-US" sz="3000" dirty="0" spc="24" kern="0">
                 <a:solidFill>
                   <a:srgbClr val="3DD6A0"/>
                 </a:solidFill>
@@ -14021,18 +14237,7 @@
                 <a:ea typeface="Be Vietnam Pro SemiBold" pitchFamily="34" charset="-122"/>
                 <a:cs typeface="Be Vietnam Pro SemiBold" pitchFamily="34" charset="-120"/>
               </a:rPr>
-              <a:t> khóa</a:t>
-            </a:r>
-            <a:r>
-              <a:rPr lang="en-US" sz="3000" dirty="0" spc="-5" kern="0">
-                <a:solidFill>
-                  <a:srgbClr val="3DD6A0"/>
-                </a:solidFill>
-                <a:latin typeface="Be Vietnam Pro SemiBold" pitchFamily="34" charset="0"/>
-                <a:ea typeface="Be Vietnam Pro SemiBold" pitchFamily="34" charset="-122"/>
-                <a:cs typeface="Be Vietnam Pro SemiBold" pitchFamily="34" charset="-120"/>
-              </a:rPr>
-              <a:t> phiên</a:t>
+              <a:t> xứng</a:t>
             </a:r>
             <a:endParaRPr lang="en-US" sz="3000" dirty="0"/>
           </a:p>
@@ -14046,12 +14251,12 @@
         </p:nvSpPr>
         <p:spPr>
           <a:xfrm>
-            <a:off x="914400" y="3905250"/>
-            <a:ext cx="2476500" cy="2476500"/>
+            <a:off x="914400" y="3752850"/>
+            <a:ext cx="2476500" cy="2438400"/>
           </a:xfrm>
           <a:prstGeom prst="roundRect">
             <a:avLst>
-              <a:gd name="adj" fmla="val 9231"/>
+              <a:gd name="adj" fmla="val 9375"/>
             </a:avLst>
           </a:prstGeom>
           <a:solidFill>
@@ -14073,7 +14278,7 @@
         </p:nvSpPr>
         <p:spPr>
           <a:xfrm>
-            <a:off x="914400" y="4191000"/>
+            <a:off x="914400" y="3981450"/>
             <a:ext cx="2476500" cy="381000"/>
           </a:xfrm>
           <a:prstGeom prst="rect">
@@ -14106,111 +14311,13 @@
       </p:sp>
       <p:sp>
         <p:nvSpPr>
-          <p:cNvPr id="7" name="Shape 5"/>
-          <p:cNvSpPr/>
-          <p:nvPr/>
-        </p:nvSpPr>
-        <p:spPr>
-          <a:xfrm>
-            <a:off x="1581150" y="4991100"/>
-            <a:ext cx="457200" cy="457200"/>
-          </a:xfrm>
-          <a:prstGeom prst="ellipse">
-            <a:avLst/>
-          </a:prstGeom>
-          <a:noFill/>
-          <a:ln w="66675">
-            <a:solidFill>
-              <a:srgbClr val="3DD6A0"/>
-            </a:solidFill>
-            <a:prstDash val="solid"/>
-          </a:ln>
-        </p:spPr>
-      </p:sp>
-      <p:sp>
-        <p:nvSpPr>
-          <p:cNvPr id="8" name="Connector line-1792334677931-850753672"/>
-          <p:cNvSpPr/>
-          <p:nvPr/>
-        </p:nvSpPr>
-        <p:spPr>
-          <a:xfrm>
-            <a:off x="2038350" y="5219700"/>
-            <a:ext cx="647700" cy="0"/>
-          </a:xfrm>
-          <a:prstGeom prst="line">
-            <a:avLst/>
-          </a:prstGeom>
-          <a:noFill/>
-          <a:ln w="66675">
-            <a:solidFill>
-              <a:srgbClr val="3DD6A0"/>
-            </a:solidFill>
-            <a:prstDash val="solid"/>
-            <a:headEnd type="none"/>
-            <a:tailEnd type="none"/>
-          </a:ln>
-        </p:spPr>
-      </p:sp>
-      <p:sp>
-        <p:nvSpPr>
-          <p:cNvPr id="9" name="Connector line-1792334677931-543616394"/>
-          <p:cNvSpPr/>
-          <p:nvPr/>
-        </p:nvSpPr>
-        <p:spPr>
-          <a:xfrm>
-            <a:off x="2381250" y="5219700"/>
-            <a:ext cx="0" cy="228600"/>
-          </a:xfrm>
-          <a:prstGeom prst="line">
-            <a:avLst/>
-          </a:prstGeom>
-          <a:noFill/>
-          <a:ln w="66675">
-            <a:solidFill>
-              <a:srgbClr val="3DD6A0"/>
-            </a:solidFill>
-            <a:prstDash val="solid"/>
-            <a:headEnd type="none"/>
-            <a:tailEnd type="none"/>
-          </a:ln>
-        </p:spPr>
-      </p:sp>
-      <p:sp>
-        <p:nvSpPr>
-          <p:cNvPr id="10" name="Connector line-1792334677931-616932369"/>
-          <p:cNvSpPr/>
-          <p:nvPr/>
-        </p:nvSpPr>
-        <p:spPr>
-          <a:xfrm>
-            <a:off x="2590800" y="5219700"/>
-            <a:ext cx="0" cy="171450"/>
-          </a:xfrm>
-          <a:prstGeom prst="line">
-            <a:avLst/>
-          </a:prstGeom>
-          <a:noFill/>
-          <a:ln w="66675">
-            <a:solidFill>
-              <a:srgbClr val="3DD6A0"/>
-            </a:solidFill>
-            <a:prstDash val="solid"/>
-            <a:headEnd type="none"/>
-            <a:tailEnd type="none"/>
-          </a:ln>
-        </p:spPr>
-      </p:sp>
-      <p:sp>
-        <p:nvSpPr>
-          <p:cNvPr id="11" name="Text 9"/>
-          <p:cNvSpPr/>
-          <p:nvPr/>
-        </p:nvSpPr>
-        <p:spPr>
-          <a:xfrm>
-            <a:off x="914400" y="5810250"/>
+          <p:cNvPr id="7" name="Text 5"/>
+          <p:cNvSpPr/>
+          <p:nvPr/>
+        </p:nvSpPr>
+        <p:spPr>
+          <a:xfrm>
+            <a:off x="914400" y="4953000"/>
             <a:ext cx="2476500" cy="323850"/>
           </a:xfrm>
           <a:prstGeom prst="rect">
@@ -14227,7 +14334,7 @@
               <a:buNone/>
             </a:pPr>
             <a:r>
-              <a:rPr lang="en-US" sz="1950" dirty="0" spc="-5" kern="0">
+              <a:rPr lang="en-US" sz="1800" dirty="0" spc="-1" kern="0">
                 <a:solidFill>
                   <a:srgbClr val="3DD6A0"/>
                 </a:solidFill>
@@ -14235,10 +14342,10 @@
                 <a:ea typeface="Be Vietnam Pro SemiBold" pitchFamily="34" charset="-122"/>
                 <a:cs typeface="Be Vietnam Pro SemiBold" pitchFamily="34" charset="-120"/>
               </a:rPr>
-              <a:t>khóa</a:t>
-            </a:r>
-            <a:r>
-              <a:rPr lang="en-US" sz="1950" dirty="0" spc="-2" kern="0">
+              <a:t>khóa chiều</a:t>
+            </a:r>
+            <a:r>
+              <a:rPr lang="en-US" sz="1800" dirty="0" spc="22" kern="0">
                 <a:solidFill>
                   <a:srgbClr val="3DD6A0"/>
                 </a:solidFill>
@@ -14246,26 +14353,76 @@
                 <a:ea typeface="Be Vietnam Pro SemiBold" pitchFamily="34" charset="-122"/>
                 <a:cs typeface="Be Vietnam Pro SemiBold" pitchFamily="34" charset="-120"/>
               </a:rPr>
-              <a:t> phiên</a:t>
-            </a:r>
-            <a:endParaRPr lang="en-US" sz="1950" dirty="0"/>
+              <a:t> đi</a:t>
+            </a:r>
+            <a:endParaRPr lang="en-US" sz="1800" dirty="0"/>
           </a:p>
         </p:txBody>
       </p:sp>
       <p:sp>
         <p:nvSpPr>
-          <p:cNvPr id="12" name="Shape 10"/>
-          <p:cNvSpPr/>
-          <p:nvPr/>
-        </p:nvSpPr>
-        <p:spPr>
-          <a:xfrm>
-            <a:off x="14897100" y="3905250"/>
-            <a:ext cx="2476500" cy="2476500"/>
+          <p:cNvPr id="8" name="Text 6"/>
+          <p:cNvSpPr/>
+          <p:nvPr/>
+        </p:nvSpPr>
+        <p:spPr>
+          <a:xfrm>
+            <a:off x="914400" y="5791200"/>
+            <a:ext cx="2476500" cy="323850"/>
+          </a:xfrm>
+          <a:prstGeom prst="rect">
+            <a:avLst/>
+          </a:prstGeom>
+          <a:noFill/>
+          <a:ln/>
+        </p:spPr>
+        <p:txBody>
+          <a:bodyPr wrap="square" lIns="0" tIns="0" rIns="0" bIns="0" rtlCol="0" anchor="t"/>
+          <a:lstStyle/>
+          <a:p>
+            <a:pPr algn="ctr" indent="0" marL="0">
+              <a:buNone/>
+            </a:pPr>
+            <a:r>
+              <a:rPr lang="en-US" sz="1800" dirty="0" spc="-1" kern="0">
+                <a:solidFill>
+                  <a:srgbClr val="3DD6A0"/>
+                </a:solidFill>
+                <a:latin typeface="Be Vietnam Pro SemiBold" pitchFamily="34" charset="0"/>
+                <a:ea typeface="Be Vietnam Pro SemiBold" pitchFamily="34" charset="-122"/>
+                <a:cs typeface="Be Vietnam Pro SemiBold" pitchFamily="34" charset="-120"/>
+              </a:rPr>
+              <a:t>khóa chiều</a:t>
+            </a:r>
+            <a:r>
+              <a:rPr lang="en-US" sz="1800" dirty="0" spc="-17" kern="0">
+                <a:solidFill>
+                  <a:srgbClr val="3DD6A0"/>
+                </a:solidFill>
+                <a:latin typeface="Be Vietnam Pro SemiBold" pitchFamily="34" charset="0"/>
+                <a:ea typeface="Be Vietnam Pro SemiBold" pitchFamily="34" charset="-122"/>
+                <a:cs typeface="Be Vietnam Pro SemiBold" pitchFamily="34" charset="-120"/>
+              </a:rPr>
+              <a:t> về</a:t>
+            </a:r>
+            <a:endParaRPr lang="en-US" sz="1800" dirty="0"/>
+          </a:p>
+        </p:txBody>
+      </p:sp>
+      <p:sp>
+        <p:nvSpPr>
+          <p:cNvPr id="9" name="Shape 7"/>
+          <p:cNvSpPr/>
+          <p:nvPr/>
+        </p:nvSpPr>
+        <p:spPr>
+          <a:xfrm>
+            <a:off x="14897100" y="3752850"/>
+            <a:ext cx="2476500" cy="2438400"/>
           </a:xfrm>
           <a:prstGeom prst="roundRect">
             <a:avLst>
-              <a:gd name="adj" fmla="val 9231"/>
+              <a:gd name="adj" fmla="val 9375"/>
             </a:avLst>
           </a:prstGeom>
           <a:solidFill>
@@ -14281,13 +14438,13 @@
       </p:sp>
       <p:sp>
         <p:nvSpPr>
-          <p:cNvPr id="13" name="Text 11"/>
-          <p:cNvSpPr/>
-          <p:nvPr/>
-        </p:nvSpPr>
-        <p:spPr>
-          <a:xfrm>
-            <a:off x="14897100" y="4191000"/>
+          <p:cNvPr id="10" name="Text 8"/>
+          <p:cNvSpPr/>
+          <p:nvPr/>
+        </p:nvSpPr>
+        <p:spPr>
+          <a:xfrm>
+            <a:off x="14897100" y="3981450"/>
             <a:ext cx="2476500" cy="381000"/>
           </a:xfrm>
           <a:prstGeom prst="rect">
@@ -14331,20 +14488,120 @@
       </p:sp>
       <p:sp>
         <p:nvSpPr>
-          <p:cNvPr id="14" name="Shape 12"/>
-          <p:cNvSpPr/>
-          <p:nvPr/>
-        </p:nvSpPr>
-        <p:spPr>
-          <a:xfrm>
-            <a:off x="15563850" y="4991100"/>
-            <a:ext cx="457200" cy="457200"/>
+          <p:cNvPr id="11" name="Text 9"/>
+          <p:cNvSpPr/>
+          <p:nvPr/>
+        </p:nvSpPr>
+        <p:spPr>
+          <a:xfrm>
+            <a:off x="14897100" y="4953000"/>
+            <a:ext cx="2476500" cy="323850"/>
+          </a:xfrm>
+          <a:prstGeom prst="rect">
+            <a:avLst/>
+          </a:prstGeom>
+          <a:noFill/>
+          <a:ln/>
+        </p:spPr>
+        <p:txBody>
+          <a:bodyPr wrap="square" lIns="0" tIns="0" rIns="0" bIns="0" rtlCol="0" anchor="t"/>
+          <a:lstStyle/>
+          <a:p>
+            <a:pPr algn="ctr" indent="0" marL="0">
+              <a:buNone/>
+            </a:pPr>
+            <a:r>
+              <a:rPr lang="en-US" sz="1800" dirty="0" spc="-1" kern="0">
+                <a:solidFill>
+                  <a:srgbClr val="3DD6A0"/>
+                </a:solidFill>
+                <a:latin typeface="Be Vietnam Pro SemiBold" pitchFamily="34" charset="0"/>
+                <a:ea typeface="Be Vietnam Pro SemiBold" pitchFamily="34" charset="-122"/>
+                <a:cs typeface="Be Vietnam Pro SemiBold" pitchFamily="34" charset="-120"/>
+              </a:rPr>
+              <a:t>khóa chiều</a:t>
+            </a:r>
+            <a:r>
+              <a:rPr lang="en-US" sz="1800" dirty="0" spc="22" kern="0">
+                <a:solidFill>
+                  <a:srgbClr val="3DD6A0"/>
+                </a:solidFill>
+                <a:latin typeface="Be Vietnam Pro SemiBold" pitchFamily="34" charset="0"/>
+                <a:ea typeface="Be Vietnam Pro SemiBold" pitchFamily="34" charset="-122"/>
+                <a:cs typeface="Be Vietnam Pro SemiBold" pitchFamily="34" charset="-120"/>
+              </a:rPr>
+              <a:t> đi</a:t>
+            </a:r>
+            <a:endParaRPr lang="en-US" sz="1800" dirty="0"/>
+          </a:p>
+        </p:txBody>
+      </p:sp>
+      <p:sp>
+        <p:nvSpPr>
+          <p:cNvPr id="12" name="Text 10"/>
+          <p:cNvSpPr/>
+          <p:nvPr/>
+        </p:nvSpPr>
+        <p:spPr>
+          <a:xfrm>
+            <a:off x="14897100" y="5791200"/>
+            <a:ext cx="2476500" cy="323850"/>
+          </a:xfrm>
+          <a:prstGeom prst="rect">
+            <a:avLst/>
+          </a:prstGeom>
+          <a:noFill/>
+          <a:ln/>
+        </p:spPr>
+        <p:txBody>
+          <a:bodyPr wrap="square" lIns="0" tIns="0" rIns="0" bIns="0" rtlCol="0" anchor="t"/>
+          <a:lstStyle/>
+          <a:p>
+            <a:pPr algn="ctr" indent="0" marL="0">
+              <a:buNone/>
+            </a:pPr>
+            <a:r>
+              <a:rPr lang="en-US" sz="1800" dirty="0" spc="-1" kern="0">
+                <a:solidFill>
+                  <a:srgbClr val="3DD6A0"/>
+                </a:solidFill>
+                <a:latin typeface="Be Vietnam Pro SemiBold" pitchFamily="34" charset="0"/>
+                <a:ea typeface="Be Vietnam Pro SemiBold" pitchFamily="34" charset="-122"/>
+                <a:cs typeface="Be Vietnam Pro SemiBold" pitchFamily="34" charset="-120"/>
+              </a:rPr>
+              <a:t>khóa chiều</a:t>
+            </a:r>
+            <a:r>
+              <a:rPr lang="en-US" sz="1800" dirty="0" spc="-17" kern="0">
+                <a:solidFill>
+                  <a:srgbClr val="3DD6A0"/>
+                </a:solidFill>
+                <a:latin typeface="Be Vietnam Pro SemiBold" pitchFamily="34" charset="0"/>
+                <a:ea typeface="Be Vietnam Pro SemiBold" pitchFamily="34" charset="-122"/>
+                <a:cs typeface="Be Vietnam Pro SemiBold" pitchFamily="34" charset="-120"/>
+              </a:rPr>
+              <a:t> về</a:t>
+            </a:r>
+            <a:endParaRPr lang="en-US" sz="1800" dirty="0"/>
+          </a:p>
+        </p:txBody>
+      </p:sp>
+      <p:sp>
+        <p:nvSpPr>
+          <p:cNvPr id="13" name="Shape 11"/>
+          <p:cNvSpPr/>
+          <p:nvPr/>
+        </p:nvSpPr>
+        <p:spPr>
+          <a:xfrm>
+            <a:off x="1724025" y="4591050"/>
+            <a:ext cx="266700" cy="266700"/>
           </a:xfrm>
           <a:prstGeom prst="ellipse">
             <a:avLst/>
           </a:prstGeom>
           <a:noFill/>
-          <a:ln w="66675">
+          <a:ln w="57150">
             <a:solidFill>
               <a:srgbClr val="3DD6A0"/>
             </a:solidFill>
@@ -14354,20 +14611,20 @@
       </p:sp>
       <p:sp>
         <p:nvSpPr>
-          <p:cNvPr id="15" name="Connector line-1792334677935-11387365"/>
-          <p:cNvSpPr/>
-          <p:nvPr/>
-        </p:nvSpPr>
-        <p:spPr>
-          <a:xfrm>
-            <a:off x="16021050" y="5219700"/>
-            <a:ext cx="647700" cy="0"/>
+          <p:cNvPr id="14" name="Connector line-1792337927712-437691173"/>
+          <p:cNvSpPr/>
+          <p:nvPr/>
+        </p:nvSpPr>
+        <p:spPr>
+          <a:xfrm>
+            <a:off x="1990725" y="4724400"/>
+            <a:ext cx="590550" cy="0"/>
           </a:xfrm>
           <a:prstGeom prst="line">
             <a:avLst/>
           </a:prstGeom>
           <a:noFill/>
-          <a:ln w="66675">
+          <a:ln w="57150">
             <a:solidFill>
               <a:srgbClr val="3DD6A0"/>
             </a:solidFill>
@@ -14379,20 +14636,20 @@
       </p:sp>
       <p:sp>
         <p:nvSpPr>
-          <p:cNvPr id="16" name="Connector line-1792334677935-815499618"/>
-          <p:cNvSpPr/>
-          <p:nvPr/>
-        </p:nvSpPr>
-        <p:spPr>
-          <a:xfrm>
-            <a:off x="16363950" y="5219700"/>
-            <a:ext cx="0" cy="228600"/>
+          <p:cNvPr id="15" name="Connector line-1792337927712-94565696"/>
+          <p:cNvSpPr/>
+          <p:nvPr/>
+        </p:nvSpPr>
+        <p:spPr>
+          <a:xfrm>
+            <a:off x="2371725" y="4724400"/>
+            <a:ext cx="0" cy="161925"/>
           </a:xfrm>
           <a:prstGeom prst="line">
             <a:avLst/>
           </a:prstGeom>
           <a:noFill/>
-          <a:ln w="66675">
+          <a:ln w="57150">
             <a:solidFill>
               <a:srgbClr val="3DD6A0"/>
             </a:solidFill>
@@ -14404,20 +14661,20 @@
       </p:sp>
       <p:sp>
         <p:nvSpPr>
-          <p:cNvPr id="17" name="Connector line-1792334677935-154469366"/>
-          <p:cNvSpPr/>
-          <p:nvPr/>
-        </p:nvSpPr>
-        <p:spPr>
-          <a:xfrm>
-            <a:off x="16573500" y="5219700"/>
-            <a:ext cx="0" cy="171450"/>
+          <p:cNvPr id="16" name="Connector line-1792337927713-682730290"/>
+          <p:cNvSpPr/>
+          <p:nvPr/>
+        </p:nvSpPr>
+        <p:spPr>
+          <a:xfrm>
+            <a:off x="2524125" y="4724400"/>
+            <a:ext cx="0" cy="114300"/>
           </a:xfrm>
           <a:prstGeom prst="line">
             <a:avLst/>
           </a:prstGeom>
           <a:noFill/>
-          <a:ln w="66675">
+          <a:ln w="57150">
             <a:solidFill>
               <a:srgbClr val="3DD6A0"/>
             </a:solidFill>
@@ -14429,14 +14686,308 @@
       </p:sp>
       <p:sp>
         <p:nvSpPr>
-          <p:cNvPr id="18" name="Text 16"/>
-          <p:cNvSpPr/>
-          <p:nvPr/>
-        </p:nvSpPr>
-        <p:spPr>
-          <a:xfrm>
-            <a:off x="14897100" y="5810250"/>
-            <a:ext cx="2476500" cy="323850"/>
+          <p:cNvPr id="17" name="Shape 15"/>
+          <p:cNvSpPr/>
+          <p:nvPr/>
+        </p:nvSpPr>
+        <p:spPr>
+          <a:xfrm>
+            <a:off x="1724025" y="5429250"/>
+            <a:ext cx="266700" cy="266700"/>
+          </a:xfrm>
+          <a:prstGeom prst="ellipse">
+            <a:avLst/>
+          </a:prstGeom>
+          <a:noFill/>
+          <a:ln w="57150">
+            <a:solidFill>
+              <a:srgbClr val="3DD6A0"/>
+            </a:solidFill>
+            <a:prstDash val="solid"/>
+          </a:ln>
+        </p:spPr>
+      </p:sp>
+      <p:sp>
+        <p:nvSpPr>
+          <p:cNvPr id="18" name="Connector line-1792337927713-173626067"/>
+          <p:cNvSpPr/>
+          <p:nvPr/>
+        </p:nvSpPr>
+        <p:spPr>
+          <a:xfrm>
+            <a:off x="1990725" y="5562600"/>
+            <a:ext cx="590550" cy="0"/>
+          </a:xfrm>
+          <a:prstGeom prst="line">
+            <a:avLst/>
+          </a:prstGeom>
+          <a:noFill/>
+          <a:ln w="57150">
+            <a:solidFill>
+              <a:srgbClr val="3DD6A0"/>
+            </a:solidFill>
+            <a:prstDash val="solid"/>
+            <a:headEnd type="none"/>
+            <a:tailEnd type="none"/>
+          </a:ln>
+        </p:spPr>
+      </p:sp>
+      <p:sp>
+        <p:nvSpPr>
+          <p:cNvPr id="19" name="Connector line-1792337927713-95702493"/>
+          <p:cNvSpPr/>
+          <p:nvPr/>
+        </p:nvSpPr>
+        <p:spPr>
+          <a:xfrm>
+            <a:off x="2371725" y="5562600"/>
+            <a:ext cx="0" cy="161925"/>
+          </a:xfrm>
+          <a:prstGeom prst="line">
+            <a:avLst/>
+          </a:prstGeom>
+          <a:noFill/>
+          <a:ln w="57150">
+            <a:solidFill>
+              <a:srgbClr val="3DD6A0"/>
+            </a:solidFill>
+            <a:prstDash val="solid"/>
+            <a:headEnd type="none"/>
+            <a:tailEnd type="none"/>
+          </a:ln>
+        </p:spPr>
+      </p:sp>
+      <p:sp>
+        <p:nvSpPr>
+          <p:cNvPr id="20" name="Connector line-1792337927713-652093240"/>
+          <p:cNvSpPr/>
+          <p:nvPr/>
+        </p:nvSpPr>
+        <p:spPr>
+          <a:xfrm>
+            <a:off x="2524125" y="5562600"/>
+            <a:ext cx="0" cy="114300"/>
+          </a:xfrm>
+          <a:prstGeom prst="line">
+            <a:avLst/>
+          </a:prstGeom>
+          <a:noFill/>
+          <a:ln w="57150">
+            <a:solidFill>
+              <a:srgbClr val="3DD6A0"/>
+            </a:solidFill>
+            <a:prstDash val="solid"/>
+            <a:headEnd type="none"/>
+            <a:tailEnd type="none"/>
+          </a:ln>
+        </p:spPr>
+      </p:sp>
+      <p:sp>
+        <p:nvSpPr>
+          <p:cNvPr id="21" name="Shape 19"/>
+          <p:cNvSpPr/>
+          <p:nvPr/>
+        </p:nvSpPr>
+        <p:spPr>
+          <a:xfrm>
+            <a:off x="15706725" y="4591050"/>
+            <a:ext cx="266700" cy="266700"/>
+          </a:xfrm>
+          <a:prstGeom prst="ellipse">
+            <a:avLst/>
+          </a:prstGeom>
+          <a:noFill/>
+          <a:ln w="57150">
+            <a:solidFill>
+              <a:srgbClr val="3DD6A0"/>
+            </a:solidFill>
+            <a:prstDash val="solid"/>
+          </a:ln>
+        </p:spPr>
+      </p:sp>
+      <p:sp>
+        <p:nvSpPr>
+          <p:cNvPr id="22" name="Connector line-1792337927714-31183232"/>
+          <p:cNvSpPr/>
+          <p:nvPr/>
+        </p:nvSpPr>
+        <p:spPr>
+          <a:xfrm>
+            <a:off x="15973425" y="4724400"/>
+            <a:ext cx="590550" cy="0"/>
+          </a:xfrm>
+          <a:prstGeom prst="line">
+            <a:avLst/>
+          </a:prstGeom>
+          <a:noFill/>
+          <a:ln w="57150">
+            <a:solidFill>
+              <a:srgbClr val="3DD6A0"/>
+            </a:solidFill>
+            <a:prstDash val="solid"/>
+            <a:headEnd type="none"/>
+            <a:tailEnd type="none"/>
+          </a:ln>
+        </p:spPr>
+      </p:sp>
+      <p:sp>
+        <p:nvSpPr>
+          <p:cNvPr id="23" name="Connector line-1792337927714-35371574"/>
+          <p:cNvSpPr/>
+          <p:nvPr/>
+        </p:nvSpPr>
+        <p:spPr>
+          <a:xfrm>
+            <a:off x="16354425" y="4724400"/>
+            <a:ext cx="0" cy="161925"/>
+          </a:xfrm>
+          <a:prstGeom prst="line">
+            <a:avLst/>
+          </a:prstGeom>
+          <a:noFill/>
+          <a:ln w="57150">
+            <a:solidFill>
+              <a:srgbClr val="3DD6A0"/>
+            </a:solidFill>
+            <a:prstDash val="solid"/>
+            <a:headEnd type="none"/>
+            <a:tailEnd type="none"/>
+          </a:ln>
+        </p:spPr>
+      </p:sp>
+      <p:sp>
+        <p:nvSpPr>
+          <p:cNvPr id="24" name="Connector line-1792337927714-647557695"/>
+          <p:cNvSpPr/>
+          <p:nvPr/>
+        </p:nvSpPr>
+        <p:spPr>
+          <a:xfrm>
+            <a:off x="16506825" y="4724400"/>
+            <a:ext cx="0" cy="114300"/>
+          </a:xfrm>
+          <a:prstGeom prst="line">
+            <a:avLst/>
+          </a:prstGeom>
+          <a:noFill/>
+          <a:ln w="57150">
+            <a:solidFill>
+              <a:srgbClr val="3DD6A0"/>
+            </a:solidFill>
+            <a:prstDash val="solid"/>
+            <a:headEnd type="none"/>
+            <a:tailEnd type="none"/>
+          </a:ln>
+        </p:spPr>
+      </p:sp>
+      <p:sp>
+        <p:nvSpPr>
+          <p:cNvPr id="25" name="Shape 23"/>
+          <p:cNvSpPr/>
+          <p:nvPr/>
+        </p:nvSpPr>
+        <p:spPr>
+          <a:xfrm>
+            <a:off x="15706725" y="5429250"/>
+            <a:ext cx="266700" cy="266700"/>
+          </a:xfrm>
+          <a:prstGeom prst="ellipse">
+            <a:avLst/>
+          </a:prstGeom>
+          <a:noFill/>
+          <a:ln w="57150">
+            <a:solidFill>
+              <a:srgbClr val="3DD6A0"/>
+            </a:solidFill>
+            <a:prstDash val="solid"/>
+          </a:ln>
+        </p:spPr>
+      </p:sp>
+      <p:sp>
+        <p:nvSpPr>
+          <p:cNvPr id="26" name="Connector line-1792337927714-877388615"/>
+          <p:cNvSpPr/>
+          <p:nvPr/>
+        </p:nvSpPr>
+        <p:spPr>
+          <a:xfrm>
+            <a:off x="15973425" y="5562600"/>
+            <a:ext cx="590550" cy="0"/>
+          </a:xfrm>
+          <a:prstGeom prst="line">
+            <a:avLst/>
+          </a:prstGeom>
+          <a:noFill/>
+          <a:ln w="57150">
+            <a:solidFill>
+              <a:srgbClr val="3DD6A0"/>
+            </a:solidFill>
+            <a:prstDash val="solid"/>
+            <a:headEnd type="none"/>
+            <a:tailEnd type="none"/>
+          </a:ln>
+        </p:spPr>
+      </p:sp>
+      <p:sp>
+        <p:nvSpPr>
+          <p:cNvPr id="27" name="Connector line-1792337927714-45074991"/>
+          <p:cNvSpPr/>
+          <p:nvPr/>
+        </p:nvSpPr>
+        <p:spPr>
+          <a:xfrm>
+            <a:off x="16354425" y="5562600"/>
+            <a:ext cx="0" cy="161925"/>
+          </a:xfrm>
+          <a:prstGeom prst="line">
+            <a:avLst/>
+          </a:prstGeom>
+          <a:noFill/>
+          <a:ln w="57150">
+            <a:solidFill>
+              <a:srgbClr val="3DD6A0"/>
+            </a:solidFill>
+            <a:prstDash val="solid"/>
+            <a:headEnd type="none"/>
+            <a:tailEnd type="none"/>
+          </a:ln>
+        </p:spPr>
+      </p:sp>
+      <p:sp>
+        <p:nvSpPr>
+          <p:cNvPr id="28" name="Connector line-1792337927715-82785367"/>
+          <p:cNvSpPr/>
+          <p:nvPr/>
+        </p:nvSpPr>
+        <p:spPr>
+          <a:xfrm>
+            <a:off x="16506825" y="5562600"/>
+            <a:ext cx="0" cy="114300"/>
+          </a:xfrm>
+          <a:prstGeom prst="line">
+            <a:avLst/>
+          </a:prstGeom>
+          <a:noFill/>
+          <a:ln w="57150">
+            <a:solidFill>
+              <a:srgbClr val="3DD6A0"/>
+            </a:solidFill>
+            <a:prstDash val="solid"/>
+            <a:headEnd type="none"/>
+            <a:tailEnd type="none"/>
+          </a:ln>
+        </p:spPr>
+      </p:sp>
+      <p:sp>
+        <p:nvSpPr>
+          <p:cNvPr id="29" name="Text 27"/>
+          <p:cNvSpPr/>
+          <p:nvPr/>
+        </p:nvSpPr>
+        <p:spPr>
+          <a:xfrm>
+            <a:off x="3771900" y="3390900"/>
+            <a:ext cx="8572500" cy="285750"/>
           </a:xfrm>
           <a:prstGeom prst="rect">
             <a:avLst/>
@@ -14448,56 +14999,6 @@
           <a:bodyPr wrap="square" lIns="0" tIns="0" rIns="0" bIns="0" rtlCol="0" anchor="t"/>
           <a:lstStyle/>
           <a:p>
-            <a:pPr algn="ctr" indent="0" marL="0">
-              <a:buNone/>
-            </a:pPr>
-            <a:r>
-              <a:rPr lang="en-US" sz="1950" dirty="0" spc="-5" kern="0">
-                <a:solidFill>
-                  <a:srgbClr val="3DD6A0"/>
-                </a:solidFill>
-                <a:latin typeface="Be Vietnam Pro SemiBold" pitchFamily="34" charset="0"/>
-                <a:ea typeface="Be Vietnam Pro SemiBold" pitchFamily="34" charset="-122"/>
-                <a:cs typeface="Be Vietnam Pro SemiBold" pitchFamily="34" charset="-120"/>
-              </a:rPr>
-              <a:t>khóa</a:t>
-            </a:r>
-            <a:r>
-              <a:rPr lang="en-US" sz="1950" dirty="0" spc="-2" kern="0">
-                <a:solidFill>
-                  <a:srgbClr val="3DD6A0"/>
-                </a:solidFill>
-                <a:latin typeface="Be Vietnam Pro SemiBold" pitchFamily="34" charset="0"/>
-                <a:ea typeface="Be Vietnam Pro SemiBold" pitchFamily="34" charset="-122"/>
-                <a:cs typeface="Be Vietnam Pro SemiBold" pitchFamily="34" charset="-120"/>
-              </a:rPr>
-              <a:t> phiên</a:t>
-            </a:r>
-            <a:endParaRPr lang="en-US" sz="1950" dirty="0"/>
-          </a:p>
-        </p:txBody>
-      </p:sp>
-      <p:sp>
-        <p:nvSpPr>
-          <p:cNvPr id="19" name="Text 17"/>
-          <p:cNvSpPr/>
-          <p:nvPr/>
-        </p:nvSpPr>
-        <p:spPr>
-          <a:xfrm>
-            <a:off x="3771900" y="3467100"/>
-            <a:ext cx="8572500" cy="285750"/>
-          </a:xfrm>
-          <a:prstGeom prst="rect">
-            <a:avLst/>
-          </a:prstGeom>
-          <a:noFill/>
-          <a:ln/>
-        </p:spPr>
-        <p:txBody>
-          <a:bodyPr wrap="square" lIns="0" tIns="0" rIns="0" bIns="0" rtlCol="0" anchor="t"/>
-          <a:lstStyle/>
-          <a:p>
             <a:pPr algn="l" indent="0" marL="0">
               <a:buNone/>
             </a:pPr>
@@ -14584,18 +15085,18 @@
       </p:sp>
       <p:sp>
         <p:nvSpPr>
-          <p:cNvPr id="20" name="Shape 18"/>
-          <p:cNvSpPr/>
-          <p:nvPr/>
-        </p:nvSpPr>
-        <p:spPr>
-          <a:xfrm>
-            <a:off x="3771900" y="3905250"/>
-            <a:ext cx="10744200" cy="2476500"/>
+          <p:cNvPr id="30" name="Shape 28"/>
+          <p:cNvSpPr/>
+          <p:nvPr/>
+        </p:nvSpPr>
+        <p:spPr>
+          <a:xfrm>
+            <a:off x="3771900" y="3752850"/>
+            <a:ext cx="10744200" cy="2438400"/>
           </a:xfrm>
           <a:prstGeom prst="roundRect">
             <a:avLst>
-              <a:gd name="adj" fmla="val 15385"/>
+              <a:gd name="adj" fmla="val 15625"/>
             </a:avLst>
           </a:prstGeom>
           <a:solidFill>
@@ -14615,14 +15116,14 @@
       </p:sp>
       <p:sp>
         <p:nvSpPr>
-          <p:cNvPr id="21" name="Text 19"/>
-          <p:cNvSpPr/>
-          <p:nvPr/>
-        </p:nvSpPr>
-        <p:spPr>
-          <a:xfrm>
-            <a:off x="4191000" y="4152900"/>
-            <a:ext cx="3810000" cy="381000"/>
+          <p:cNvPr id="31" name="Text 29"/>
+          <p:cNvSpPr/>
+          <p:nvPr/>
+        </p:nvSpPr>
+        <p:spPr>
+          <a:xfrm>
+            <a:off x="4191000" y="3924300"/>
+            <a:ext cx="9906000" cy="400050"/>
           </a:xfrm>
           <a:prstGeom prst="rect">
             <a:avLst/>
@@ -14638,7 +15139,7 @@
               <a:buNone/>
             </a:pPr>
             <a:r>
-              <a:rPr lang="en-US" sz="2250" b="1" dirty="0" spc="-78" kern="0">
+              <a:rPr lang="en-US" sz="2100" b="1" dirty="0" spc="-77" kern="0">
                 <a:solidFill>
                   <a:srgbClr val="F3EEE3"/>
                 </a:solidFill>
@@ -14649,7 +15150,7 @@
               <a:t>Yêu</a:t>
             </a:r>
             <a:r>
-              <a:rPr lang="en-US" sz="2250" b="1" dirty="0" spc="2" kern="0">
+              <a:rPr lang="en-US" sz="2100" b="1" dirty="0" spc="-2" kern="0">
                 <a:solidFill>
                   <a:srgbClr val="F3EEE3"/>
                 </a:solidFill>
@@ -14660,7 +15161,7 @@
               <a:t> cầu</a:t>
             </a:r>
             <a:r>
-              <a:rPr lang="en-US" sz="2250" b="1" dirty="0" spc="4" kern="0">
+              <a:rPr lang="en-US" sz="2100" b="1" dirty="0" spc="1" kern="0">
                 <a:solidFill>
                   <a:srgbClr val="F3EEE3"/>
                 </a:solidFill>
@@ -14670,19 +15171,99 @@
               </a:rPr>
               <a:t> HTTP</a:t>
             </a:r>
-            <a:endParaRPr lang="en-US" sz="2250" dirty="0"/>
+            <a:pPr algn="l" indent="0" marL="0">
+              <a:buNone/>
+            </a:pPr>
+            <a:r>
+              <a:rPr lang="en-US" sz="2100" dirty="0" spc="0" kern="0">
+                <a:solidFill>
+                  <a:srgbClr val="3DD6A0"/>
+                </a:solidFill>
+                <a:latin typeface="Be Vietnam Pro SemiBold" pitchFamily="34" charset="0"/>
+                <a:ea typeface="Be Vietnam Pro SemiBold" pitchFamily="34" charset="-122"/>
+                <a:cs typeface="Be Vietnam Pro SemiBold" pitchFamily="34" charset="-120"/>
+              </a:rPr>
+              <a:t> ·</a:t>
+            </a:r>
+            <a:r>
+              <a:rPr lang="en-US" sz="2100" dirty="0" spc="-3" kern="0">
+                <a:solidFill>
+                  <a:srgbClr val="3DD6A0"/>
+                </a:solidFill>
+                <a:latin typeface="Be Vietnam Pro SemiBold" pitchFamily="34" charset="0"/>
+                <a:ea typeface="Be Vietnam Pro SemiBold" pitchFamily="34" charset="-122"/>
+                <a:cs typeface="Be Vietnam Pro SemiBold" pitchFamily="34" charset="-120"/>
+              </a:rPr>
+              <a:t> mã</a:t>
+            </a:r>
+            <a:r>
+              <a:rPr lang="en-US" sz="2100" dirty="0" spc="-7" kern="0">
+                <a:solidFill>
+                  <a:srgbClr val="3DD6A0"/>
+                </a:solidFill>
+                <a:latin typeface="Be Vietnam Pro SemiBold" pitchFamily="34" charset="0"/>
+                <a:ea typeface="Be Vietnam Pro SemiBold" pitchFamily="34" charset="-122"/>
+                <a:cs typeface="Be Vietnam Pro SemiBold" pitchFamily="34" charset="-120"/>
+              </a:rPr>
+              <a:t> hóa</a:t>
+            </a:r>
+            <a:r>
+              <a:rPr lang="en-US" sz="2100" dirty="0" spc="-4" kern="0">
+                <a:solidFill>
+                  <a:srgbClr val="3DD6A0"/>
+                </a:solidFill>
+                <a:latin typeface="Be Vietnam Pro SemiBold" pitchFamily="34" charset="0"/>
+                <a:ea typeface="Be Vietnam Pro SemiBold" pitchFamily="34" charset="-122"/>
+                <a:cs typeface="Be Vietnam Pro SemiBold" pitchFamily="34" charset="-120"/>
+              </a:rPr>
+              <a:t> bằng</a:t>
+            </a:r>
+            <a:r>
+              <a:rPr lang="en-US" sz="2100" dirty="0" spc="-5" kern="0">
+                <a:solidFill>
+                  <a:srgbClr val="3DD6A0"/>
+                </a:solidFill>
+                <a:latin typeface="Be Vietnam Pro SemiBold" pitchFamily="34" charset="0"/>
+                <a:ea typeface="Be Vietnam Pro SemiBold" pitchFamily="34" charset="-122"/>
+                <a:cs typeface="Be Vietnam Pro SemiBold" pitchFamily="34" charset="-120"/>
+              </a:rPr>
+              <a:t> khóa</a:t>
+            </a:r>
+            <a:r>
+              <a:rPr lang="en-US" sz="2100" dirty="0" spc="-2" kern="0">
+                <a:solidFill>
+                  <a:srgbClr val="3DD6A0"/>
+                </a:solidFill>
+                <a:latin typeface="Be Vietnam Pro SemiBold" pitchFamily="34" charset="0"/>
+                <a:ea typeface="Be Vietnam Pro SemiBold" pitchFamily="34" charset="-122"/>
+                <a:cs typeface="Be Vietnam Pro SemiBold" pitchFamily="34" charset="-120"/>
+              </a:rPr>
+              <a:t> chiều</a:t>
+            </a:r>
+            <a:r>
+              <a:rPr lang="en-US" sz="2100" dirty="0" spc="19" kern="0">
+                <a:solidFill>
+                  <a:srgbClr val="3DD6A0"/>
+                </a:solidFill>
+                <a:latin typeface="Be Vietnam Pro SemiBold" pitchFamily="34" charset="0"/>
+                <a:ea typeface="Be Vietnam Pro SemiBold" pitchFamily="34" charset="-122"/>
+                <a:cs typeface="Be Vietnam Pro SemiBold" pitchFamily="34" charset="-120"/>
+              </a:rPr>
+              <a:t> đi</a:t>
+            </a:r>
+            <a:endParaRPr lang="en-US" sz="2100" dirty="0"/>
           </a:p>
         </p:txBody>
       </p:sp>
       <p:sp>
         <p:nvSpPr>
-          <p:cNvPr id="22" name="Connector line-1792334677941-730384498"/>
-          <p:cNvSpPr/>
-          <p:nvPr/>
-        </p:nvSpPr>
-        <p:spPr>
-          <a:xfrm>
-            <a:off x="4191000" y="4838700"/>
+          <p:cNvPr id="32" name="Connector line-1792337927721-204121472"/>
+          <p:cNvSpPr/>
+          <p:nvPr/>
+        </p:nvSpPr>
+        <p:spPr>
+          <a:xfrm>
+            <a:off x="4191000" y="4667250"/>
             <a:ext cx="9906000" cy="0"/>
           </a:xfrm>
           <a:prstGeom prst="line">
@@ -14701,13 +15282,13 @@
       </p:sp>
       <p:sp>
         <p:nvSpPr>
-          <p:cNvPr id="23" name="Shape 21"/>
-          <p:cNvSpPr/>
-          <p:nvPr/>
-        </p:nvSpPr>
-        <p:spPr>
-          <a:xfrm>
-            <a:off x="6096000" y="4629150"/>
+          <p:cNvPr id="33" name="Shape 31"/>
+          <p:cNvSpPr/>
+          <p:nvPr/>
+        </p:nvSpPr>
+        <p:spPr>
+          <a:xfrm>
+            <a:off x="6096000" y="4457700"/>
             <a:ext cx="1238250" cy="419100"/>
           </a:xfrm>
           <a:prstGeom prst="roundRect">
@@ -14728,13 +15309,13 @@
       </p:sp>
       <p:sp>
         <p:nvSpPr>
-          <p:cNvPr id="24" name="Shape 22"/>
-          <p:cNvSpPr/>
-          <p:nvPr/>
-        </p:nvSpPr>
-        <p:spPr>
-          <a:xfrm>
-            <a:off x="7905750" y="4629150"/>
+          <p:cNvPr id="34" name="Shape 32"/>
+          <p:cNvSpPr/>
+          <p:nvPr/>
+        </p:nvSpPr>
+        <p:spPr>
+          <a:xfrm>
+            <a:off x="7905750" y="4457700"/>
             <a:ext cx="1238250" cy="419100"/>
           </a:xfrm>
           <a:prstGeom prst="roundRect">
@@ -14755,13 +15336,13 @@
       </p:sp>
       <p:sp>
         <p:nvSpPr>
-          <p:cNvPr id="25" name="Shape 23"/>
-          <p:cNvSpPr/>
-          <p:nvPr/>
-        </p:nvSpPr>
-        <p:spPr>
-          <a:xfrm>
-            <a:off x="9715500" y="4629150"/>
+          <p:cNvPr id="35" name="Shape 33"/>
+          <p:cNvSpPr/>
+          <p:nvPr/>
+        </p:nvSpPr>
+        <p:spPr>
+          <a:xfrm>
+            <a:off x="9715500" y="4457700"/>
             <a:ext cx="1238250" cy="419100"/>
           </a:xfrm>
           <a:prstGeom prst="roundRect">
@@ -14782,14 +15363,14 @@
       </p:sp>
       <p:sp>
         <p:nvSpPr>
-          <p:cNvPr id="26" name="Text 24"/>
-          <p:cNvSpPr/>
-          <p:nvPr/>
-        </p:nvSpPr>
-        <p:spPr>
-          <a:xfrm>
-            <a:off x="4191000" y="5314950"/>
-            <a:ext cx="3810000" cy="381000"/>
+          <p:cNvPr id="36" name="Text 34"/>
+          <p:cNvSpPr/>
+          <p:nvPr/>
+        </p:nvSpPr>
+        <p:spPr>
+          <a:xfrm>
+            <a:off x="4191000" y="5105400"/>
+            <a:ext cx="9906000" cy="400050"/>
           </a:xfrm>
           <a:prstGeom prst="rect">
             <a:avLst/>
@@ -14805,7 +15386,7 @@
               <a:buNone/>
             </a:pPr>
             <a:r>
-              <a:rPr lang="en-US" sz="2250" b="1" dirty="0" spc="0" kern="0">
+              <a:rPr lang="en-US" sz="2100" b="1" dirty="0" spc="2" kern="0">
                 <a:solidFill>
                   <a:srgbClr val="F3EEE3"/>
                 </a:solidFill>
@@ -14816,7 +15397,7 @@
               <a:t>Phản</a:t>
             </a:r>
             <a:r>
-              <a:rPr lang="en-US" sz="2250" b="1" dirty="0" spc="2" kern="0">
+              <a:rPr lang="en-US" sz="2100" b="1" dirty="0" spc="-6" kern="0">
                 <a:solidFill>
                   <a:srgbClr val="F3EEE3"/>
                 </a:solidFill>
@@ -14827,7 +15408,7 @@
               <a:t> hồi</a:t>
             </a:r>
             <a:r>
-              <a:rPr lang="en-US" sz="2250" b="1" dirty="0" spc="3" kern="0">
+              <a:rPr lang="en-US" sz="2100" b="1" dirty="0" spc="0" kern="0">
                 <a:solidFill>
                   <a:srgbClr val="F3EEE3"/>
                 </a:solidFill>
@@ -14837,19 +15418,99 @@
               </a:rPr>
               <a:t> HTTP</a:t>
             </a:r>
-            <a:endParaRPr lang="en-US" sz="2250" dirty="0"/>
+            <a:pPr algn="l" indent="0" marL="0">
+              <a:buNone/>
+            </a:pPr>
+            <a:r>
+              <a:rPr lang="en-US" sz="2100" dirty="0" spc="0" kern="0">
+                <a:solidFill>
+                  <a:srgbClr val="3DD6A0"/>
+                </a:solidFill>
+                <a:latin typeface="Be Vietnam Pro SemiBold" pitchFamily="34" charset="0"/>
+                <a:ea typeface="Be Vietnam Pro SemiBold" pitchFamily="34" charset="-122"/>
+                <a:cs typeface="Be Vietnam Pro SemiBold" pitchFamily="34" charset="-120"/>
+              </a:rPr>
+              <a:t> ·</a:t>
+            </a:r>
+            <a:r>
+              <a:rPr lang="en-US" sz="2100" dirty="0" spc="-3" kern="0">
+                <a:solidFill>
+                  <a:srgbClr val="3DD6A0"/>
+                </a:solidFill>
+                <a:latin typeface="Be Vietnam Pro SemiBold" pitchFamily="34" charset="0"/>
+                <a:ea typeface="Be Vietnam Pro SemiBold" pitchFamily="34" charset="-122"/>
+                <a:cs typeface="Be Vietnam Pro SemiBold" pitchFamily="34" charset="-120"/>
+              </a:rPr>
+              <a:t> mã</a:t>
+            </a:r>
+            <a:r>
+              <a:rPr lang="en-US" sz="2100" dirty="0" spc="-7" kern="0">
+                <a:solidFill>
+                  <a:srgbClr val="3DD6A0"/>
+                </a:solidFill>
+                <a:latin typeface="Be Vietnam Pro SemiBold" pitchFamily="34" charset="0"/>
+                <a:ea typeface="Be Vietnam Pro SemiBold" pitchFamily="34" charset="-122"/>
+                <a:cs typeface="Be Vietnam Pro SemiBold" pitchFamily="34" charset="-120"/>
+              </a:rPr>
+              <a:t> hóa</a:t>
+            </a:r>
+            <a:r>
+              <a:rPr lang="en-US" sz="2100" dirty="0" spc="-4" kern="0">
+                <a:solidFill>
+                  <a:srgbClr val="3DD6A0"/>
+                </a:solidFill>
+                <a:latin typeface="Be Vietnam Pro SemiBold" pitchFamily="34" charset="0"/>
+                <a:ea typeface="Be Vietnam Pro SemiBold" pitchFamily="34" charset="-122"/>
+                <a:cs typeface="Be Vietnam Pro SemiBold" pitchFamily="34" charset="-120"/>
+              </a:rPr>
+              <a:t> bằng</a:t>
+            </a:r>
+            <a:r>
+              <a:rPr lang="en-US" sz="2100" dirty="0" spc="-5" kern="0">
+                <a:solidFill>
+                  <a:srgbClr val="3DD6A0"/>
+                </a:solidFill>
+                <a:latin typeface="Be Vietnam Pro SemiBold" pitchFamily="34" charset="0"/>
+                <a:ea typeface="Be Vietnam Pro SemiBold" pitchFamily="34" charset="-122"/>
+                <a:cs typeface="Be Vietnam Pro SemiBold" pitchFamily="34" charset="-120"/>
+              </a:rPr>
+              <a:t> khóa</a:t>
+            </a:r>
+            <a:r>
+              <a:rPr lang="en-US" sz="2100" dirty="0" spc="-2" kern="0">
+                <a:solidFill>
+                  <a:srgbClr val="3DD6A0"/>
+                </a:solidFill>
+                <a:latin typeface="Be Vietnam Pro SemiBold" pitchFamily="34" charset="0"/>
+                <a:ea typeface="Be Vietnam Pro SemiBold" pitchFamily="34" charset="-122"/>
+                <a:cs typeface="Be Vietnam Pro SemiBold" pitchFamily="34" charset="-120"/>
+              </a:rPr>
+              <a:t> chiều</a:t>
+            </a:r>
+            <a:r>
+              <a:rPr lang="en-US" sz="2100" dirty="0" spc="-19" kern="0">
+                <a:solidFill>
+                  <a:srgbClr val="3DD6A0"/>
+                </a:solidFill>
+                <a:latin typeface="Be Vietnam Pro SemiBold" pitchFamily="34" charset="0"/>
+                <a:ea typeface="Be Vietnam Pro SemiBold" pitchFamily="34" charset="-122"/>
+                <a:cs typeface="Be Vietnam Pro SemiBold" pitchFamily="34" charset="-120"/>
+              </a:rPr>
+              <a:t> về</a:t>
+            </a:r>
+            <a:endParaRPr lang="en-US" sz="2100" dirty="0"/>
           </a:p>
         </p:txBody>
       </p:sp>
       <p:sp>
         <p:nvSpPr>
-          <p:cNvPr id="27" name="Connector line-1792334677944-659270358"/>
+          <p:cNvPr id="37" name="Connector line-1792337927726-79653347"/>
           <p:cNvSpPr/>
           <p:nvPr/>
         </p:nvSpPr>
         <p:spPr>
           <a:xfrm flipH="1">
-            <a:off x="4191000" y="6000750"/>
+            <a:off x="4191000" y="5829300"/>
             <a:ext cx="9906000" cy="0"/>
           </a:xfrm>
           <a:prstGeom prst="line">
@@ -14868,13 +15529,13 @@
       </p:sp>
       <p:sp>
         <p:nvSpPr>
-          <p:cNvPr id="28" name="Shape 26"/>
-          <p:cNvSpPr/>
-          <p:nvPr/>
-        </p:nvSpPr>
-        <p:spPr>
-          <a:xfrm>
-            <a:off x="6096000" y="5791200"/>
+          <p:cNvPr id="38" name="Shape 36"/>
+          <p:cNvSpPr/>
+          <p:nvPr/>
+        </p:nvSpPr>
+        <p:spPr>
+          <a:xfrm>
+            <a:off x="6096000" y="5619750"/>
             <a:ext cx="1238250" cy="419100"/>
           </a:xfrm>
           <a:prstGeom prst="roundRect">
@@ -14895,13 +15556,13 @@
       </p:sp>
       <p:sp>
         <p:nvSpPr>
-          <p:cNvPr id="29" name="Shape 27"/>
-          <p:cNvSpPr/>
-          <p:nvPr/>
-        </p:nvSpPr>
-        <p:spPr>
-          <a:xfrm>
-            <a:off x="7905750" y="5791200"/>
+          <p:cNvPr id="39" name="Shape 37"/>
+          <p:cNvSpPr/>
+          <p:nvPr/>
+        </p:nvSpPr>
+        <p:spPr>
+          <a:xfrm>
+            <a:off x="7905750" y="5619750"/>
             <a:ext cx="1238250" cy="419100"/>
           </a:xfrm>
           <a:prstGeom prst="roundRect">
@@ -14922,13 +15583,13 @@
       </p:sp>
       <p:sp>
         <p:nvSpPr>
-          <p:cNvPr id="30" name="Shape 28"/>
-          <p:cNvSpPr/>
-          <p:nvPr/>
-        </p:nvSpPr>
-        <p:spPr>
-          <a:xfrm>
-            <a:off x="9715500" y="5791200"/>
+          <p:cNvPr id="40" name="Shape 38"/>
+          <p:cNvSpPr/>
+          <p:nvPr/>
+        </p:nvSpPr>
+        <p:spPr>
+          <a:xfrm>
+            <a:off x="9715500" y="5619750"/>
             <a:ext cx="1238250" cy="419100"/>
           </a:xfrm>
           <a:prstGeom prst="roundRect">
@@ -14949,18 +15610,18 @@
       </p:sp>
       <p:sp>
         <p:nvSpPr>
-          <p:cNvPr id="31" name="Shape 29"/>
-          <p:cNvSpPr/>
-          <p:nvPr/>
-        </p:nvSpPr>
-        <p:spPr>
-          <a:xfrm>
-            <a:off x="914400" y="6934200"/>
-            <a:ext cx="8001000" cy="1428750"/>
+          <p:cNvPr id="41" name="Shape 39"/>
+          <p:cNvSpPr/>
+          <p:nvPr/>
+        </p:nvSpPr>
+        <p:spPr>
+          <a:xfrm>
+            <a:off x="914400" y="6438900"/>
+            <a:ext cx="5257800" cy="2419350"/>
           </a:xfrm>
           <a:prstGeom prst="roundRect">
             <a:avLst>
-              <a:gd name="adj" fmla="val 16000"/>
+              <a:gd name="adj" fmla="val 9449"/>
             </a:avLst>
           </a:prstGeom>
           <a:solidFill>
@@ -14971,14 +15632,14 @@
       </p:sp>
       <p:sp>
         <p:nvSpPr>
-          <p:cNvPr id="32" name="Text 30"/>
-          <p:cNvSpPr/>
-          <p:nvPr/>
-        </p:nvSpPr>
-        <p:spPr>
-          <a:xfrm>
-            <a:off x="1219200" y="7162800"/>
-            <a:ext cx="7239000" cy="285750"/>
+          <p:cNvPr id="42" name="Text 40"/>
+          <p:cNvSpPr/>
+          <p:nvPr/>
+        </p:nvSpPr>
+        <p:spPr>
+          <a:xfrm>
+            <a:off x="1219200" y="6667500"/>
+            <a:ext cx="4648200" cy="285750"/>
           </a:xfrm>
           <a:prstGeom prst="rect">
             <a:avLst/>
@@ -14994,7 +15655,7 @@
               <a:buNone/>
             </a:pPr>
             <a:r>
-              <a:rPr lang="en-US" sz="1650" b="1" spc="205" kern="0" dirty="0">
+              <a:rPr lang="en-US" sz="1650" b="1" spc="225" kern="0" dirty="0">
                 <a:solidFill>
                   <a:srgbClr val="3DD6A0"/>
                 </a:solidFill>
@@ -15002,10 +15663,10 @@
                 <a:ea typeface="Be Vietnam Pro" pitchFamily="34" charset="-122"/>
                 <a:cs typeface="Be Vietnam Pro" pitchFamily="34" charset="-120"/>
               </a:rPr>
-              <a:t>KHÓA</a:t>
-            </a:r>
-            <a:r>
-              <a:rPr lang="en-US" sz="1650" b="1" spc="230" kern="0" dirty="0">
+              <a:t>TỪ</a:t>
+            </a:r>
+            <a:r>
+              <a:rPr lang="en-US" sz="1650" b="1" spc="226" kern="0" dirty="0">
                 <a:solidFill>
                   <a:srgbClr val="3DD6A0"/>
                 </a:solidFill>
@@ -15013,10 +15674,10 @@
                 <a:ea typeface="Be Vietnam Pro" pitchFamily="34" charset="-122"/>
                 <a:cs typeface="Be Vietnam Pro" pitchFamily="34" charset="-120"/>
               </a:rPr>
-              <a:t> ĐỐI</a:t>
-            </a:r>
-            <a:r>
-              <a:rPr lang="en-US" sz="1650" b="1" spc="243" kern="0" dirty="0">
+              <a:t> BÍ</a:t>
+            </a:r>
+            <a:r>
+              <a:rPr lang="en-US" sz="1650" b="1" spc="182" kern="0" dirty="0">
                 <a:solidFill>
                   <a:srgbClr val="3DD6A0"/>
                 </a:solidFill>
@@ -15024,7 +15685,18 @@
                 <a:ea typeface="Be Vietnam Pro" pitchFamily="34" charset="-122"/>
                 <a:cs typeface="Be Vietnam Pro" pitchFamily="34" charset="-120"/>
               </a:rPr>
-              <a:t> XỨNG</a:t>
+              <a:t> MẬT</a:t>
+            </a:r>
+            <a:r>
+              <a:rPr lang="en-US" sz="1650" b="1" spc="226" kern="0" dirty="0">
+                <a:solidFill>
+                  <a:srgbClr val="3DD6A0"/>
+                </a:solidFill>
+                <a:latin typeface="Be Vietnam Pro" pitchFamily="34" charset="0"/>
+                <a:ea typeface="Be Vietnam Pro" pitchFamily="34" charset="-122"/>
+                <a:cs typeface="Be Vietnam Pro" pitchFamily="34" charset="-120"/>
+              </a:rPr>
+              <a:t> CHUNG</a:t>
             </a:r>
             <a:endParaRPr lang="en-US" sz="1650" dirty="0"/>
           </a:p>
@@ -15032,14 +15704,175 @@
       </p:sp>
       <p:sp>
         <p:nvSpPr>
-          <p:cNvPr id="33" name="Text 31"/>
-          <p:cNvSpPr/>
-          <p:nvPr/>
-        </p:nvSpPr>
-        <p:spPr>
-          <a:xfrm>
-            <a:off x="1219200" y="7581900"/>
-            <a:ext cx="7391400" cy="476250"/>
+          <p:cNvPr id="43" name="Text 41"/>
+          <p:cNvSpPr/>
+          <p:nvPr/>
+        </p:nvSpPr>
+        <p:spPr>
+          <a:xfrm>
+            <a:off x="1219200" y="7086600"/>
+            <a:ext cx="4648200" cy="1524000"/>
+          </a:xfrm>
+          <a:prstGeom prst="rect">
+            <a:avLst/>
+          </a:prstGeom>
+          <a:noFill/>
+          <a:ln/>
+        </p:spPr>
+        <p:txBody>
+          <a:bodyPr wrap="square" lIns="0" tIns="12144" rIns="0" bIns="-12144" rtlCol="0" anchor="t"/>
+          <a:lstStyle/>
+          <a:p>
+            <a:pPr algn="l" indent="0" marL="0">
+              <a:lnSpc>
+                <a:spcPts val="2925"/>
+              </a:lnSpc>
+              <a:buNone/>
+            </a:pPr>
+            <a:r>
+              <a:rPr lang="en-US" sz="2250" dirty="0" spc="-2" kern="0">
+                <a:solidFill>
+                  <a:srgbClr val="F3EEE3"/>
+                </a:solidFill>
+                <a:latin typeface="Be Vietnam Pro" pitchFamily="34" charset="0"/>
+                <a:ea typeface="Be Vietnam Pro" pitchFamily="34" charset="-122"/>
+                <a:cs typeface="Be Vietnam Pro" pitchFamily="34" charset="-120"/>
+              </a:rPr>
+              <a:t>Mỗi bên</a:t>
+            </a:r>
+            <a:r>
+              <a:rPr lang="en-US" sz="2250" dirty="0" spc="1" kern="0">
+                <a:solidFill>
+                  <a:srgbClr val="F3EEE3"/>
+                </a:solidFill>
+                <a:latin typeface="Be Vietnam Pro" pitchFamily="34" charset="0"/>
+                <a:ea typeface="Be Vietnam Pro" pitchFamily="34" charset="-122"/>
+                <a:cs typeface="Be Vietnam Pro" pitchFamily="34" charset="-120"/>
+              </a:rPr>
+              <a:t> tính</a:t>
+            </a:r>
+            <a:r>
+              <a:rPr lang="en-US" sz="2250" dirty="0" spc="-2" kern="0">
+                <a:solidFill>
+                  <a:srgbClr val="F3EEE3"/>
+                </a:solidFill>
+                <a:latin typeface="Be Vietnam Pro" pitchFamily="34" charset="0"/>
+                <a:ea typeface="Be Vietnam Pro" pitchFamily="34" charset="-122"/>
+                <a:cs typeface="Be Vietnam Pro" pitchFamily="34" charset="-120"/>
+              </a:rPr>
+              <a:t> khóa</a:t>
+            </a:r>
+            <a:r>
+              <a:rPr lang="en-US" sz="2250" dirty="0" spc="13" kern="0">
+                <a:solidFill>
+                  <a:srgbClr val="F3EEE3"/>
+                </a:solidFill>
+                <a:latin typeface="Be Vietnam Pro" pitchFamily="34" charset="0"/>
+                <a:ea typeface="Be Vietnam Pro" pitchFamily="34" charset="-122"/>
+                <a:cs typeface="Be Vietnam Pro" pitchFamily="34" charset="-120"/>
+              </a:rPr>
+              <a:t> đối</a:t>
+            </a:r>
+            <a:r>
+              <a:rPr lang="en-US" sz="2250" dirty="0" spc="14" kern="0">
+                <a:solidFill>
+                  <a:srgbClr val="F3EEE3"/>
+                </a:solidFill>
+                <a:latin typeface="Be Vietnam Pro" pitchFamily="34" charset="0"/>
+                <a:ea typeface="Be Vietnam Pro" pitchFamily="34" charset="-122"/>
+                <a:cs typeface="Be Vietnam Pro" pitchFamily="34" charset="-120"/>
+              </a:rPr>
+              <a:t> xứng,</a:t>
+            </a:r>
+            <a:endParaRPr lang="en-US" sz="2250" dirty="0"/>
+          </a:p>
+          <a:p>
+            <a:pPr algn="l" indent="0" marL="0">
+              <a:lnSpc>
+                <a:spcPts val="2925"/>
+              </a:lnSpc>
+              <a:buNone/>
+            </a:pPr>
+            <a:r>
+              <a:rPr lang="en-US" sz="2250" dirty="0" spc="-2" kern="0">
+                <a:solidFill>
+                  <a:srgbClr val="F3EEE3"/>
+                </a:solidFill>
+                <a:latin typeface="Be Vietnam Pro" pitchFamily="34" charset="0"/>
+                <a:ea typeface="Be Vietnam Pro" pitchFamily="34" charset="-122"/>
+                <a:cs typeface="Be Vietnam Pro" pitchFamily="34" charset="-120"/>
+              </a:rPr>
+              <a:t>mỗi</a:t>
+            </a:r>
+            <a:r>
+              <a:rPr lang="en-US" sz="2250" dirty="0" spc="0" kern="0">
+                <a:solidFill>
+                  <a:srgbClr val="F3EEE3"/>
+                </a:solidFill>
+                <a:latin typeface="Be Vietnam Pro" pitchFamily="34" charset="0"/>
+                <a:ea typeface="Be Vietnam Pro" pitchFamily="34" charset="-122"/>
+                <a:cs typeface="Be Vietnam Pro" pitchFamily="34" charset="-120"/>
+              </a:rPr>
+              <a:t> chiều</a:t>
+            </a:r>
+            <a:r>
+              <a:rPr lang="en-US" sz="2250" dirty="0" spc="-5" kern="0">
+                <a:solidFill>
+                  <a:srgbClr val="F3EEE3"/>
+                </a:solidFill>
+                <a:latin typeface="Be Vietnam Pro" pitchFamily="34" charset="0"/>
+                <a:ea typeface="Be Vietnam Pro" pitchFamily="34" charset="-122"/>
+                <a:cs typeface="Be Vietnam Pro" pitchFamily="34" charset="-120"/>
+              </a:rPr>
+              <a:t> một</a:t>
+            </a:r>
+            <a:r>
+              <a:rPr lang="en-US" sz="2250" dirty="0" spc="0" kern="0">
+                <a:solidFill>
+                  <a:srgbClr val="F3EEE3"/>
+                </a:solidFill>
+                <a:latin typeface="Be Vietnam Pro" pitchFamily="34" charset="0"/>
+                <a:ea typeface="Be Vietnam Pro" pitchFamily="34" charset="-122"/>
+                <a:cs typeface="Be Vietnam Pro" pitchFamily="34" charset="-120"/>
+              </a:rPr>
+              <a:t> khóa.</a:t>
+            </a:r>
+            <a:endParaRPr lang="en-US" sz="2250" dirty="0"/>
+          </a:p>
+        </p:txBody>
+      </p:sp>
+      <p:sp>
+        <p:nvSpPr>
+          <p:cNvPr id="44" name="Shape 42"/>
+          <p:cNvSpPr/>
+          <p:nvPr/>
+        </p:nvSpPr>
+        <p:spPr>
+          <a:xfrm>
+            <a:off x="6515100" y="6438900"/>
+            <a:ext cx="5257800" cy="2419350"/>
+          </a:xfrm>
+          <a:prstGeom prst="roundRect">
+            <a:avLst>
+              <a:gd name="adj" fmla="val 9449"/>
+            </a:avLst>
+          </a:prstGeom>
+          <a:solidFill>
+            <a:srgbClr val="1E212B"/>
+          </a:solidFill>
+          <a:ln/>
+        </p:spPr>
+      </p:sp>
+      <p:sp>
+        <p:nvSpPr>
+          <p:cNvPr id="45" name="Text 43"/>
+          <p:cNvSpPr/>
+          <p:nvPr/>
+        </p:nvSpPr>
+        <p:spPr>
+          <a:xfrm>
+            <a:off x="6819900" y="6667500"/>
+            <a:ext cx="4648200" cy="285750"/>
           </a:xfrm>
           <a:prstGeom prst="rect">
             <a:avLst/>
@@ -15055,7 +15888,60 @@
               <a:buNone/>
             </a:pPr>
             <a:r>
-              <a:rPr lang="en-US" sz="2550" dirty="0" spc="-1" kern="0">
+              <a:rPr lang="en-US" sz="1650" b="1" spc="229" kern="0" dirty="0">
+                <a:solidFill>
+                  <a:srgbClr val="3DD6A0"/>
+                </a:solidFill>
+                <a:latin typeface="Be Vietnam Pro" pitchFamily="34" charset="0"/>
+                <a:ea typeface="Be Vietnam Pro" pitchFamily="34" charset="-122"/>
+                <a:cs typeface="Be Vietnam Pro" pitchFamily="34" charset="-120"/>
+              </a:rPr>
+              <a:t>ĐỐI</a:t>
+            </a:r>
+            <a:r>
+              <a:rPr lang="en-US" sz="1650" b="1" spc="244" kern="0" dirty="0">
+                <a:solidFill>
+                  <a:srgbClr val="3DD6A0"/>
+                </a:solidFill>
+                <a:latin typeface="Be Vietnam Pro" pitchFamily="34" charset="0"/>
+                <a:ea typeface="Be Vietnam Pro" pitchFamily="34" charset="-122"/>
+                <a:cs typeface="Be Vietnam Pro" pitchFamily="34" charset="-120"/>
+              </a:rPr>
+              <a:t> XỨNG</a:t>
+            </a:r>
+            <a:endParaRPr lang="en-US" sz="1650" dirty="0"/>
+          </a:p>
+        </p:txBody>
+      </p:sp>
+      <p:sp>
+        <p:nvSpPr>
+          <p:cNvPr id="46" name="Text 44"/>
+          <p:cNvSpPr/>
+          <p:nvPr/>
+        </p:nvSpPr>
+        <p:spPr>
+          <a:xfrm>
+            <a:off x="6819900" y="7086600"/>
+            <a:ext cx="4648200" cy="1524000"/>
+          </a:xfrm>
+          <a:prstGeom prst="rect">
+            <a:avLst/>
+          </a:prstGeom>
+          <a:noFill/>
+          <a:ln/>
+        </p:spPr>
+        <p:txBody>
+          <a:bodyPr wrap="square" lIns="0" tIns="12144" rIns="0" bIns="-12144" rtlCol="0" anchor="t"/>
+          <a:lstStyle/>
+          <a:p>
+            <a:pPr algn="l" indent="0" marL="0">
+              <a:lnSpc>
+                <a:spcPts val="2925"/>
+              </a:lnSpc>
+              <a:buNone/>
+            </a:pPr>
+            <a:r>
+              <a:rPr lang="en-US" sz="2250" dirty="0" spc="48" kern="0">
                 <a:solidFill>
                   <a:srgbClr val="F3EEE3"/>
                 </a:solidFill>
@@ -15063,10 +15949,10 @@
                 <a:ea typeface="Be Vietnam Pro" pitchFamily="34" charset="-122"/>
                 <a:cs typeface="Be Vietnam Pro" pitchFamily="34" charset="-120"/>
               </a:rPr>
-              <a:t>Cùng</a:t>
-            </a:r>
-            <a:r>
-              <a:rPr lang="en-US" sz="2550" dirty="0" spc="-5" kern="0">
+              <a:t>Gửi</a:t>
+            </a:r>
+            <a:r>
+              <a:rPr lang="en-US" sz="2250" dirty="0" spc="-1" kern="0">
                 <a:solidFill>
                   <a:srgbClr val="F3EEE3"/>
                 </a:solidFill>
@@ -15074,10 +15960,10 @@
                 <a:ea typeface="Be Vietnam Pro" pitchFamily="34" charset="-122"/>
                 <a:cs typeface="Be Vietnam Pro" pitchFamily="34" charset="-120"/>
               </a:rPr>
-              <a:t> một</a:t>
-            </a:r>
-            <a:r>
-              <a:rPr lang="en-US" sz="2550" dirty="0" spc="-2" kern="0">
+              <a:t> mã</a:t>
+            </a:r>
+            <a:r>
+              <a:rPr lang="en-US" sz="2250" dirty="0" spc="-3" kern="0">
                 <a:solidFill>
                   <a:srgbClr val="F3EEE3"/>
                 </a:solidFill>
@@ -15085,10 +15971,85 @@
                 <a:ea typeface="Be Vietnam Pro" pitchFamily="34" charset="-122"/>
                 <a:cs typeface="Be Vietnam Pro" pitchFamily="34" charset="-120"/>
               </a:rPr>
+              <a:t> hóa,</a:t>
+            </a:r>
+            <a:r>
+              <a:rPr lang="en-US" sz="2250" dirty="0" spc="0" kern="0">
+                <a:solidFill>
+                  <a:srgbClr val="F3EEE3"/>
+                </a:solidFill>
+                <a:latin typeface="Be Vietnam Pro" pitchFamily="34" charset="0"/>
+                <a:ea typeface="Be Vietnam Pro" pitchFamily="34" charset="-122"/>
+                <a:cs typeface="Be Vietnam Pro" pitchFamily="34" charset="-120"/>
+              </a:rPr>
+              <a:t> nhận</a:t>
+            </a:r>
+            <a:r>
+              <a:rPr lang="en-US" sz="2250" dirty="0" spc="-3" kern="0">
+                <a:solidFill>
+                  <a:srgbClr val="F3EEE3"/>
+                </a:solidFill>
+                <a:latin typeface="Be Vietnam Pro" pitchFamily="34" charset="0"/>
+                <a:ea typeface="Be Vietnam Pro" pitchFamily="34" charset="-122"/>
+                <a:cs typeface="Be Vietnam Pro" pitchFamily="34" charset="-120"/>
+              </a:rPr>
+              <a:t> giải</a:t>
+            </a:r>
+            <a:r>
+              <a:rPr lang="en-US" sz="2250" dirty="0" spc="-1" kern="0">
+                <a:solidFill>
+                  <a:srgbClr val="F3EEE3"/>
+                </a:solidFill>
+                <a:latin typeface="Be Vietnam Pro" pitchFamily="34" charset="0"/>
+                <a:ea typeface="Be Vietnam Pro" pitchFamily="34" charset="-122"/>
+                <a:cs typeface="Be Vietnam Pro" pitchFamily="34" charset="-120"/>
+              </a:rPr>
+              <a:t> mã</a:t>
+            </a:r>
+            <a:endParaRPr lang="en-US" sz="2250" dirty="0"/>
+          </a:p>
+          <a:p>
+            <a:pPr algn="l" indent="0" marL="0">
+              <a:lnSpc>
+                <a:spcPts val="2925"/>
+              </a:lnSpc>
+              <a:buNone/>
+            </a:pPr>
+            <a:r>
+              <a:rPr lang="en-US" sz="2250" dirty="0" spc="-4" kern="0">
+                <a:solidFill>
+                  <a:srgbClr val="F3EEE3"/>
+                </a:solidFill>
+                <a:latin typeface="Be Vietnam Pro" pitchFamily="34" charset="0"/>
+                <a:ea typeface="Be Vietnam Pro" pitchFamily="34" charset="-122"/>
+                <a:cs typeface="Be Vietnam Pro" pitchFamily="34" charset="-120"/>
+              </a:rPr>
+              <a:t>bằng</a:t>
+            </a:r>
+            <a:r>
+              <a:rPr lang="en-US" sz="2250" dirty="0" spc="1" kern="0">
+                <a:solidFill>
+                  <a:srgbClr val="F3EEE3"/>
+                </a:solidFill>
+                <a:latin typeface="Be Vietnam Pro" pitchFamily="34" charset="0"/>
+                <a:ea typeface="Be Vietnam Pro" pitchFamily="34" charset="-122"/>
+                <a:cs typeface="Be Vietnam Pro" pitchFamily="34" charset="-120"/>
+              </a:rPr>
+              <a:t> chính</a:t>
+            </a:r>
+            <a:r>
+              <a:rPr lang="en-US" sz="2250" dirty="0" spc="-2" kern="0">
+                <a:solidFill>
+                  <a:srgbClr val="F3EEE3"/>
+                </a:solidFill>
+                <a:latin typeface="Be Vietnam Pro" pitchFamily="34" charset="0"/>
+                <a:ea typeface="Be Vietnam Pro" pitchFamily="34" charset="-122"/>
+                <a:cs typeface="Be Vietnam Pro" pitchFamily="34" charset="-120"/>
+              </a:rPr>
               <a:t> khóa</a:t>
             </a:r>
             <a:r>
-              <a:rPr lang="en-US" sz="2550" dirty="0" spc="17" kern="0">
+              <a:rPr lang="en-US" sz="2250" dirty="0" spc="-7" kern="0">
                 <a:solidFill>
                   <a:srgbClr val="F3EEE3"/>
                 </a:solidFill>
@@ -15096,81 +16057,26 @@
                 <a:ea typeface="Be Vietnam Pro" pitchFamily="34" charset="-122"/>
                 <a:cs typeface="Be Vietnam Pro" pitchFamily="34" charset="-120"/>
               </a:rPr>
-              <a:t> để</a:t>
-            </a:r>
-            <a:r>
-              <a:rPr lang="en-US" sz="2550" dirty="0" spc="1" kern="0">
-                <a:solidFill>
-                  <a:srgbClr val="F3EEE3"/>
-                </a:solidFill>
-                <a:latin typeface="Be Vietnam Pro" pitchFamily="34" charset="0"/>
-                <a:ea typeface="Be Vietnam Pro" pitchFamily="34" charset="-122"/>
-                <a:cs typeface="Be Vietnam Pro" pitchFamily="34" charset="-120"/>
-              </a:rPr>
-              <a:t> mã</a:t>
-            </a:r>
-            <a:r>
-              <a:rPr lang="en-US" sz="2550" dirty="0" spc="-3" kern="0">
-                <a:solidFill>
-                  <a:srgbClr val="F3EEE3"/>
-                </a:solidFill>
-                <a:latin typeface="Be Vietnam Pro" pitchFamily="34" charset="0"/>
-                <a:ea typeface="Be Vietnam Pro" pitchFamily="34" charset="-122"/>
-                <a:cs typeface="Be Vietnam Pro" pitchFamily="34" charset="-120"/>
-              </a:rPr>
-              <a:t> hóa</a:t>
-            </a:r>
-            <a:r>
-              <a:rPr lang="en-US" sz="2550" dirty="0" spc="-19" kern="0">
-                <a:solidFill>
-                  <a:srgbClr val="F3EEE3"/>
-                </a:solidFill>
-                <a:latin typeface="Be Vietnam Pro" pitchFamily="34" charset="0"/>
-                <a:ea typeface="Be Vietnam Pro" pitchFamily="34" charset="-122"/>
-                <a:cs typeface="Be Vietnam Pro" pitchFamily="34" charset="-120"/>
-              </a:rPr>
-              <a:t> và</a:t>
-            </a:r>
-            <a:r>
-              <a:rPr lang="en-US" sz="2550" dirty="0" spc="0" kern="0">
-                <a:solidFill>
-                  <a:srgbClr val="F3EEE3"/>
-                </a:solidFill>
-                <a:latin typeface="Be Vietnam Pro" pitchFamily="34" charset="0"/>
-                <a:ea typeface="Be Vietnam Pro" pitchFamily="34" charset="-122"/>
-                <a:cs typeface="Be Vietnam Pro" pitchFamily="34" charset="-120"/>
-              </a:rPr>
-              <a:t> giải</a:t>
-            </a:r>
-            <a:r>
-              <a:rPr lang="en-US" sz="2550" dirty="0" spc="2" kern="0">
-                <a:solidFill>
-                  <a:srgbClr val="F3EEE3"/>
-                </a:solidFill>
-                <a:latin typeface="Be Vietnam Pro" pitchFamily="34" charset="0"/>
-                <a:ea typeface="Be Vietnam Pro" pitchFamily="34" charset="-122"/>
-                <a:cs typeface="Be Vietnam Pro" pitchFamily="34" charset="-120"/>
-              </a:rPr>
-              <a:t> mã.</a:t>
-            </a:r>
-            <a:endParaRPr lang="en-US" sz="2550" dirty="0"/>
+              <a:t> ấy.</a:t>
+            </a:r>
+            <a:endParaRPr lang="en-US" sz="2250" dirty="0"/>
           </a:p>
         </p:txBody>
       </p:sp>
       <p:sp>
         <p:nvSpPr>
-          <p:cNvPr id="34" name="Shape 32"/>
-          <p:cNvSpPr/>
-          <p:nvPr/>
-        </p:nvSpPr>
-        <p:spPr>
-          <a:xfrm>
-            <a:off x="9372600" y="6934200"/>
-            <a:ext cx="8001000" cy="1428750"/>
+          <p:cNvPr id="47" name="Shape 45"/>
+          <p:cNvSpPr/>
+          <p:nvPr/>
+        </p:nvSpPr>
+        <p:spPr>
+          <a:xfrm>
+            <a:off x="12115800" y="6438900"/>
+            <a:ext cx="5257800" cy="2419350"/>
           </a:xfrm>
           <a:prstGeom prst="roundRect">
             <a:avLst>
-              <a:gd name="adj" fmla="val 16000"/>
+              <a:gd name="adj" fmla="val 9449"/>
             </a:avLst>
           </a:prstGeom>
           <a:solidFill>
@@ -15181,14 +16087,14 @@
       </p:sp>
       <p:sp>
         <p:nvSpPr>
-          <p:cNvPr id="35" name="Text 33"/>
-          <p:cNvSpPr/>
-          <p:nvPr/>
-        </p:nvSpPr>
-        <p:spPr>
-          <a:xfrm>
-            <a:off x="9677400" y="7162800"/>
-            <a:ext cx="7239000" cy="285750"/>
+          <p:cNvPr id="48" name="Text 46"/>
+          <p:cNvSpPr/>
+          <p:nvPr/>
+        </p:nvSpPr>
+        <p:spPr>
+          <a:xfrm>
+            <a:off x="12420600" y="6667500"/>
+            <a:ext cx="4648200" cy="285750"/>
           </a:xfrm>
           <a:prstGeom prst="rect">
             <a:avLst/>
@@ -15204,6 +16110,39 @@
               <a:buNone/>
             </a:pPr>
             <a:r>
+              <a:rPr lang="en-US" sz="1650" b="1" spc="178" kern="0" dirty="0">
+                <a:solidFill>
+                  <a:srgbClr val="3DD6A0"/>
+                </a:solidFill>
+                <a:latin typeface="Be Vietnam Pro" pitchFamily="34" charset="0"/>
+                <a:ea typeface="Be Vietnam Pro" pitchFamily="34" charset="-122"/>
+                <a:cs typeface="Be Vietnam Pro" pitchFamily="34" charset="-120"/>
+              </a:rPr>
+              <a:t>NHẬT</a:t>
+            </a:r>
+            <a:r>
+              <a:rPr lang="en-US" sz="1650" b="1" spc="224" kern="0" dirty="0">
+                <a:solidFill>
+                  <a:srgbClr val="3DD6A0"/>
+                </a:solidFill>
+                <a:latin typeface="Be Vietnam Pro" pitchFamily="34" charset="0"/>
+                <a:ea typeface="Be Vietnam Pro" pitchFamily="34" charset="-122"/>
+                <a:cs typeface="Be Vietnam Pro" pitchFamily="34" charset="-120"/>
+              </a:rPr>
+              <a:t> KÝ</a:t>
+            </a:r>
+            <a:r>
+              <a:rPr lang="en-US" sz="1650" b="1" spc="210" kern="0" dirty="0">
+                <a:solidFill>
+                  <a:srgbClr val="3DD6A0"/>
+                </a:solidFill>
+                <a:latin typeface="Be Vietnam Pro" pitchFamily="34" charset="0"/>
+                <a:ea typeface="Be Vietnam Pro" pitchFamily="34" charset="-122"/>
+                <a:cs typeface="Be Vietnam Pro" pitchFamily="34" charset="-120"/>
+              </a:rPr>
+              <a:t> KHÓA</a:t>
+            </a:r>
+            <a:r>
               <a:rPr lang="en-US" sz="1650" b="1" spc="229" kern="0" dirty="0">
                 <a:solidFill>
                   <a:srgbClr val="3DD6A0"/>
@@ -15212,10 +16151,10 @@
                 <a:ea typeface="Be Vietnam Pro" pitchFamily="34" charset="-122"/>
                 <a:cs typeface="Be Vietnam Pro" pitchFamily="34" charset="-120"/>
               </a:rPr>
-              <a:t>VÌ</a:t>
-            </a:r>
-            <a:r>
-              <a:rPr lang="en-US" sz="1650" b="1" spc="201" kern="0" dirty="0">
+              <a:t> ·</a:t>
+            </a:r>
+            <a:r>
+              <a:rPr lang="en-US" sz="1650" b="1" spc="207" kern="0" dirty="0">
                 <a:solidFill>
                   <a:srgbClr val="3DD6A0"/>
                 </a:solidFill>
@@ -15223,10 +16162,10 @@
                 <a:ea typeface="Be Vietnam Pro" pitchFamily="34" charset="-122"/>
                 <a:cs typeface="Be Vietnam Pro" pitchFamily="34" charset="-120"/>
               </a:rPr>
-              <a:t> SAO</a:t>
-            </a:r>
-            <a:r>
-              <a:rPr lang="en-US" sz="1650" b="1" spc="227" kern="0" dirty="0">
+              <a:t> MỘT</a:t>
+            </a:r>
+            <a:r>
+              <a:rPr lang="en-US" sz="1650" b="1" spc="224" kern="0" dirty="0">
                 <a:solidFill>
                   <a:srgbClr val="3DD6A0"/>
                 </a:solidFill>
@@ -15234,7 +16173,18 @@
                 <a:ea typeface="Be Vietnam Pro" pitchFamily="34" charset="-122"/>
                 <a:cs typeface="Be Vietnam Pro" pitchFamily="34" charset="-120"/>
               </a:rPr>
-              <a:t> DÙNG</a:t>
+              <a:t> LẦN</a:t>
+            </a:r>
+            <a:r>
+              <a:rPr lang="en-US" sz="1650" b="1" spc="191" kern="0" dirty="0">
+                <a:solidFill>
+                  <a:srgbClr val="3DD6A0"/>
+                </a:solidFill>
+                <a:latin typeface="Be Vietnam Pro" pitchFamily="34" charset="0"/>
+                <a:ea typeface="Be Vietnam Pro" pitchFamily="34" charset="-122"/>
+                <a:cs typeface="Be Vietnam Pro" pitchFamily="34" charset="-120"/>
+              </a:rPr>
+              <a:t> CHẠY</a:t>
             </a:r>
             <a:endParaRPr lang="en-US" sz="1650" dirty="0"/>
           </a:p>
@@ -15242,14 +16192,14 @@
       </p:sp>
       <p:sp>
         <p:nvSpPr>
-          <p:cNvPr id="36" name="Text 34"/>
-          <p:cNvSpPr/>
-          <p:nvPr/>
-        </p:nvSpPr>
-        <p:spPr>
-          <a:xfrm>
-            <a:off x="9677400" y="7581900"/>
-            <a:ext cx="7391400" cy="476250"/>
+          <p:cNvPr id="49" name="Text 47"/>
+          <p:cNvSpPr/>
+          <p:nvPr/>
+        </p:nvSpPr>
+        <p:spPr>
+          <a:xfrm>
+            <a:off x="12420600" y="7086600"/>
+            <a:ext cx="4648200" cy="1619250"/>
           </a:xfrm>
           <a:prstGeom prst="rect">
             <a:avLst/>
@@ -15258,14 +16208,17 @@
           <a:ln/>
         </p:spPr>
         <p:txBody>
-          <a:bodyPr wrap="square" lIns="0" tIns="0" rIns="0" bIns="0" rtlCol="0" anchor="t"/>
+          <a:bodyPr wrap="square" lIns="0" tIns="12144" rIns="0" bIns="-12144" rtlCol="0" anchor="t"/>
           <a:lstStyle/>
           <a:p>
             <a:pPr algn="l" indent="0" marL="0">
+              <a:lnSpc>
+                <a:spcPts val="2925"/>
+              </a:lnSpc>
               <a:buNone/>
             </a:pPr>
             <a:r>
-              <a:rPr lang="en-US" sz="2550" dirty="0" spc="-9" kern="0">
+              <a:rPr lang="en-US" sz="2250" b="1" dirty="0" spc="0" kern="0">
                 <a:solidFill>
                   <a:srgbClr val="F3EEE3"/>
                 </a:solidFill>
@@ -15273,10 +16226,10 @@
                 <a:ea typeface="Be Vietnam Pro" pitchFamily="34" charset="-122"/>
                 <a:cs typeface="Be Vietnam Pro" pitchFamily="34" charset="-120"/>
               </a:rPr>
-              <a:t>Chạy</a:t>
-            </a:r>
-            <a:r>
-              <a:rPr lang="en-US" sz="2550" dirty="0" spc="1" kern="0">
+              <a:t>TLS</a:t>
+            </a:r>
+            <a:r>
+              <a:rPr lang="en-US" sz="2250" b="1" dirty="0" spc="3" kern="0">
                 <a:solidFill>
                   <a:srgbClr val="F3EEE3"/>
                 </a:solidFill>
@@ -15284,10 +16237,16 @@
                 <a:ea typeface="Be Vietnam Pro" pitchFamily="34" charset="-122"/>
                 <a:cs typeface="Be Vietnam Pro" pitchFamily="34" charset="-120"/>
               </a:rPr>
-              <a:t> hiệu quả,</a:t>
-            </a:r>
-            <a:r>
-              <a:rPr lang="en-US" sz="2550" dirty="0" spc="0" kern="0">
+              <a:t> 1.3:</a:t>
+            </a:r>
+            <a:pPr algn="l" indent="0" marL="0">
+              <a:lnSpc>
+                <a:spcPts val="2925"/>
+              </a:lnSpc>
+              <a:buNone/>
+            </a:pPr>
+            <a:r>
+              <a:rPr lang="en-US" sz="2250" dirty="0" spc="-2" kern="0">
                 <a:solidFill>
                   <a:srgbClr val="F3EEE3"/>
                 </a:solidFill>
@@ -15295,10 +16254,10 @@
                 <a:ea typeface="Be Vietnam Pro" pitchFamily="34" charset="-122"/>
                 <a:cs typeface="Be Vietnam Pro" pitchFamily="34" charset="-120"/>
               </a:rPr>
-              <a:t> hợp</a:t>
-            </a:r>
-            <a:r>
-              <a:rPr lang="en-US" sz="2550" dirty="0" spc="-15" kern="0">
+              <a:t> hai</a:t>
+            </a:r>
+            <a:r>
+              <a:rPr lang="en-US" sz="2250" dirty="0" spc="2" kern="0">
                 <a:solidFill>
                   <a:srgbClr val="F3EEE3"/>
                 </a:solidFill>
@@ -15306,10 +16265,10 @@
                 <a:ea typeface="Be Vietnam Pro" pitchFamily="34" charset="-122"/>
                 <a:cs typeface="Be Vietnam Pro" pitchFamily="34" charset="-120"/>
               </a:rPr>
-              <a:t> với</a:t>
-            </a:r>
-            <a:r>
-              <a:rPr lang="en-US" sz="2550" dirty="0" spc="-3" kern="0">
+              <a:t> bí</a:t>
+            </a:r>
+            <a:r>
+              <a:rPr lang="en-US" sz="2250" dirty="0" spc="-12" kern="0">
                 <a:solidFill>
                   <a:srgbClr val="F3EEE3"/>
                 </a:solidFill>
@@ -15317,10 +16276,19 @@
                 <a:ea typeface="Be Vietnam Pro" pitchFamily="34" charset="-122"/>
                 <a:cs typeface="Be Vietnam Pro" pitchFamily="34" charset="-120"/>
               </a:rPr>
-              <a:t> dữ</a:t>
-            </a:r>
-            <a:r>
-              <a:rPr lang="en-US" sz="2550" dirty="0" spc="2" kern="0">
+              <a:t> mật</a:t>
+            </a:r>
+            <a:endParaRPr lang="en-US" sz="2250" dirty="0"/>
+          </a:p>
+          <a:p>
+            <a:pPr algn="l" indent="0" marL="0">
+              <a:lnSpc>
+                <a:spcPts val="2925"/>
+              </a:lnSpc>
+              <a:buNone/>
+            </a:pPr>
+            <a:r>
+              <a:rPr lang="en-US" sz="2250" dirty="0" spc="-1" kern="0">
                 <a:solidFill>
                   <a:srgbClr val="F3EEE3"/>
                 </a:solidFill>
@@ -15328,10 +16296,10 @@
                 <a:ea typeface="Be Vietnam Pro" pitchFamily="34" charset="-122"/>
                 <a:cs typeface="Be Vietnam Pro" pitchFamily="34" charset="-120"/>
               </a:rPr>
-              <a:t> liệu</a:t>
-            </a:r>
-            <a:r>
-              <a:rPr lang="en-US" sz="2550" dirty="0" spc="0" kern="0">
+              <a:t>cho</a:t>
+            </a:r>
+            <a:r>
+              <a:rPr lang="en-US" sz="2250" dirty="0" spc="-2" kern="0">
                 <a:solidFill>
                   <a:srgbClr val="F3EEE3"/>
                 </a:solidFill>
@@ -15339,15 +16307,138 @@
                 <a:ea typeface="Be Vietnam Pro" pitchFamily="34" charset="-122"/>
                 <a:cs typeface="Be Vietnam Pro" pitchFamily="34" charset="-120"/>
               </a:rPr>
-              <a:t> lớn.</a:t>
-            </a:r>
-            <a:endParaRPr lang="en-US" sz="2550" dirty="0"/>
+              <a:t> hai</a:t>
+            </a:r>
+            <a:r>
+              <a:rPr lang="en-US" sz="2250" dirty="0" spc="1" kern="0">
+                <a:solidFill>
+                  <a:srgbClr val="F3EEE3"/>
+                </a:solidFill>
+                <a:latin typeface="Be Vietnam Pro" pitchFamily="34" charset="0"/>
+                <a:ea typeface="Be Vietnam Pro" pitchFamily="34" charset="-122"/>
+                <a:cs typeface="Be Vietnam Pro" pitchFamily="34" charset="-120"/>
+              </a:rPr>
+              <a:t> chiều.</a:t>
+            </a:r>
+            <a:endParaRPr lang="en-US" sz="2250" dirty="0"/>
+          </a:p>
+          <a:p>
+            <a:pPr algn="l" indent="0" marL="0">
+              <a:lnSpc>
+                <a:spcPts val="2925"/>
+              </a:lnSpc>
+              <a:buNone/>
+            </a:pPr>
+            <a:r>
+              <a:rPr lang="en-US" sz="2250" b="1" dirty="0" kern="0">
+                <a:solidFill>
+                  <a:srgbClr val="F3EEE3"/>
+                </a:solidFill>
+                <a:latin typeface="Be Vietnam Pro" pitchFamily="34" charset="0"/>
+                <a:ea typeface="Be Vietnam Pro" pitchFamily="34" charset="-122"/>
+                <a:cs typeface="Be Vietnam Pro" pitchFamily="34" charset="-120"/>
+              </a:rPr>
+              <a:t>TLS 1.2:</a:t>
+            </a:r>
+            <a:pPr algn="l" indent="0" marL="0">
+              <a:lnSpc>
+                <a:spcPts val="2925"/>
+              </a:lnSpc>
+              <a:buNone/>
+            </a:pPr>
+            <a:r>
+              <a:rPr lang="en-US" sz="2250" dirty="0" spc="-4" kern="0">
+                <a:solidFill>
+                  <a:srgbClr val="F3EEE3"/>
+                </a:solidFill>
+                <a:latin typeface="Be Vietnam Pro" pitchFamily="34" charset="0"/>
+                <a:ea typeface="Be Vietnam Pro" pitchFamily="34" charset="-122"/>
+                <a:cs typeface="Be Vietnam Pro" pitchFamily="34" charset="-120"/>
+              </a:rPr>
+              <a:t> một</a:t>
+            </a:r>
+            <a:r>
+              <a:rPr lang="en-US" sz="2250" dirty="0" spc="2" kern="0">
+                <a:solidFill>
+                  <a:srgbClr val="F3EEE3"/>
+                </a:solidFill>
+                <a:latin typeface="Be Vietnam Pro" pitchFamily="34" charset="0"/>
+                <a:ea typeface="Be Vietnam Pro" pitchFamily="34" charset="-122"/>
+                <a:cs typeface="Be Vietnam Pro" pitchFamily="34" charset="-120"/>
+              </a:rPr>
+              <a:t> bí</a:t>
+            </a:r>
+            <a:r>
+              <a:rPr lang="en-US" sz="2250" dirty="0" spc="-11" kern="0">
+                <a:solidFill>
+                  <a:srgbClr val="F3EEE3"/>
+                </a:solidFill>
+                <a:latin typeface="Be Vietnam Pro" pitchFamily="34" charset="0"/>
+                <a:ea typeface="Be Vietnam Pro" pitchFamily="34" charset="-122"/>
+                <a:cs typeface="Be Vietnam Pro" pitchFamily="34" charset="-120"/>
+              </a:rPr>
+              <a:t> mật,</a:t>
+            </a:r>
+            <a:endParaRPr lang="en-US" sz="2250" dirty="0"/>
+          </a:p>
+          <a:p>
+            <a:pPr algn="l" indent="0" marL="0">
+              <a:lnSpc>
+                <a:spcPts val="2925"/>
+              </a:lnSpc>
+              <a:buNone/>
+            </a:pPr>
+            <a:r>
+              <a:rPr lang="en-US" sz="2250" dirty="0" spc="0" kern="0">
+                <a:solidFill>
+                  <a:srgbClr val="F3EEE3"/>
+                </a:solidFill>
+                <a:latin typeface="Be Vietnam Pro" pitchFamily="34" charset="0"/>
+                <a:ea typeface="Be Vietnam Pro" pitchFamily="34" charset="-122"/>
+                <a:cs typeface="Be Vietnam Pro" pitchFamily="34" charset="-120"/>
+              </a:rPr>
+              <a:t>không</a:t>
+            </a:r>
+            <a:r>
+              <a:rPr lang="en-US" sz="2250" dirty="0" spc="-7" kern="0">
+                <a:solidFill>
+                  <a:srgbClr val="F3EEE3"/>
+                </a:solidFill>
+                <a:latin typeface="Be Vietnam Pro" pitchFamily="34" charset="0"/>
+                <a:ea typeface="Be Vietnam Pro" pitchFamily="34" charset="-122"/>
+                <a:cs typeface="Be Vietnam Pro" pitchFamily="34" charset="-120"/>
+              </a:rPr>
+              <a:t> thấy</a:t>
+            </a:r>
+            <a:r>
+              <a:rPr lang="en-US" sz="2250" dirty="0" spc="20" kern="0">
+                <a:solidFill>
+                  <a:srgbClr val="F3EEE3"/>
+                </a:solidFill>
+                <a:latin typeface="Be Vietnam Pro" pitchFamily="34" charset="0"/>
+                <a:ea typeface="Be Vietnam Pro" pitchFamily="34" charset="-122"/>
+                <a:cs typeface="Be Vietnam Pro" pitchFamily="34" charset="-120"/>
+              </a:rPr>
+              <a:t> từng</a:t>
+            </a:r>
+            <a:r>
+              <a:rPr lang="en-US" sz="2250" dirty="0" spc="0" kern="0">
+                <a:solidFill>
+                  <a:srgbClr val="F3EEE3"/>
+                </a:solidFill>
+                <a:latin typeface="Be Vietnam Pro" pitchFamily="34" charset="0"/>
+                <a:ea typeface="Be Vietnam Pro" pitchFamily="34" charset="-122"/>
+                <a:cs typeface="Be Vietnam Pro" pitchFamily="34" charset="-120"/>
+              </a:rPr>
+              <a:t> chiều.</a:t>
+            </a:r>
+            <a:endParaRPr lang="en-US" sz="2250" dirty="0"/>
           </a:p>
         </p:txBody>
       </p:sp>
       <p:sp>
         <p:nvSpPr>
-          <p:cNvPr id="37" name="Connector line-1792334677955-985564121"/>
+          <p:cNvPr id="50" name="Connector line-1792337927746-206257836"/>
           <p:cNvSpPr/>
           <p:nvPr/>
         </p:nvSpPr>
@@ -15374,7 +16465,7 @@
       </p:sp>
       <p:sp>
         <p:nvSpPr>
-          <p:cNvPr id="38" name="Shape 36"/>
+          <p:cNvPr id="51" name="Shape 49"/>
           <p:cNvSpPr/>
           <p:nvPr/>
         </p:nvSpPr>
@@ -15394,7 +16485,7 @@
       </p:sp>
       <p:sp>
         <p:nvSpPr>
-          <p:cNvPr id="39" name="Shape 37"/>
+          <p:cNvPr id="52" name="Shape 50"/>
           <p:cNvSpPr/>
           <p:nvPr/>
         </p:nvSpPr>
@@ -15414,7 +16505,7 @@
       </p:sp>
       <p:sp>
         <p:nvSpPr>
-          <p:cNvPr id="40" name="Shape 38"/>
+          <p:cNvPr id="53" name="Shape 51"/>
           <p:cNvSpPr/>
           <p:nvPr/>
         </p:nvSpPr>
@@ -15434,7 +16525,7 @@
       </p:sp>
       <p:sp>
         <p:nvSpPr>
-          <p:cNvPr id="41" name="Shape 39"/>
+          <p:cNvPr id="54" name="Shape 52"/>
           <p:cNvSpPr/>
           <p:nvPr/>
         </p:nvSpPr>
@@ -15454,7 +16545,7 @@
       </p:sp>
       <p:sp>
         <p:nvSpPr>
-          <p:cNvPr id="42" name="Shape 40"/>
+          <p:cNvPr id="55" name="Shape 53"/>
           <p:cNvSpPr/>
           <p:nvPr/>
         </p:nvSpPr>
@@ -15474,7 +16565,7 @@
       </p:sp>
       <p:sp>
         <p:nvSpPr>
-          <p:cNvPr id="43" name="Shape 41"/>
+          <p:cNvPr id="56" name="Shape 54"/>
           <p:cNvSpPr/>
           <p:nvPr/>
         </p:nvSpPr>
@@ -15499,7 +16590,7 @@
       </p:sp>
       <p:sp>
         <p:nvSpPr>
-          <p:cNvPr id="44" name="Shape 42"/>
+          <p:cNvPr id="57" name="Shape 55"/>
           <p:cNvSpPr/>
           <p:nvPr/>
         </p:nvSpPr>
@@ -15524,7 +16615,7 @@
       </p:sp>
       <p:sp>
         <p:nvSpPr>
-          <p:cNvPr id="45" name="Shape 43"/>
+          <p:cNvPr id="58" name="Shape 56"/>
           <p:cNvSpPr/>
           <p:nvPr/>
         </p:nvSpPr>
@@ -15549,7 +16640,7 @@
       </p:sp>
       <p:sp>
         <p:nvSpPr>
-          <p:cNvPr id="46" name="Shape 44"/>
+          <p:cNvPr id="59" name="Shape 57"/>
           <p:cNvSpPr/>
           <p:nvPr/>
         </p:nvSpPr>
@@ -15574,7 +16665,7 @@
       </p:sp>
       <p:sp>
         <p:nvSpPr>
-          <p:cNvPr id="47" name="Shape 45"/>
+          <p:cNvPr id="60" name="Shape 58"/>
           <p:cNvSpPr/>
           <p:nvPr/>
         </p:nvSpPr>
@@ -15599,7 +16690,7 @@
       </p:sp>
       <p:sp>
         <p:nvSpPr>
-          <p:cNvPr id="48" name="Text 46"/>
+          <p:cNvPr id="61" name="Text 59"/>
           <p:cNvSpPr/>
           <p:nvPr/>
         </p:nvSpPr>
@@ -15715,7 +16806,7 @@
       </p:sp>
       <p:sp>
         <p:nvSpPr>
-          <p:cNvPr id="49" name="Shape 47"/>
+          <p:cNvPr id="62" name="Shape 60"/>
           <p:cNvSpPr/>
           <p:nvPr/>
         </p:nvSpPr>
@@ -15739,7 +16830,7 @@
       </p:sp>
       <p:pic>
         <p:nvPicPr>
-          <p:cNvPr id="50" name="Moda image moda-export-watermark-886ccefe-c737-4bf9-9016-0d936bf3a6d5" descr="">    </p:cNvPr>
+          <p:cNvPr id="63" name="Moda image moda-export-watermark-886ccefe-c737-4bf9-9016-0d936bf3a6d5" descr="">    </p:cNvPr>
           <p:cNvPicPr>
             <a:picLocks noChangeAspect="1"/>
           </p:cNvPicPr>
@@ -17502,7 +18593,7 @@
         <p:spPr>
           <a:xfrm>
             <a:off x="914400" y="8420100"/>
-            <a:ext cx="9525000" cy="285750"/>
+            <a:ext cx="11430000" cy="609600"/>
           </a:xfrm>
           <a:prstGeom prst="rect">
             <a:avLst/>
@@ -17511,10 +18602,13 @@
           <a:ln/>
         </p:spPr>
         <p:txBody>
-          <a:bodyPr wrap="square" lIns="0" tIns="0" rIns="0" bIns="0" rtlCol="0" anchor="t"/>
+          <a:bodyPr wrap="square" lIns="0" tIns="8906" rIns="0" bIns="-8906" rtlCol="0" anchor="t"/>
           <a:lstStyle/>
           <a:p>
             <a:pPr algn="l" indent="0" marL="0">
+              <a:lnSpc>
+                <a:spcPts val="2145"/>
+              </a:lnSpc>
               <a:buNone/>
             </a:pPr>
             <a:r>
@@ -17659,6 +18753,103 @@
                 <a:cs typeface="Be Vietnam Pro" pitchFamily="34" charset="-120"/>
               </a:rPr>
               <a:t> gửi</a:t>
+            </a:r>
+            <a:endParaRPr lang="en-US" sz="1650" dirty="0"/>
+          </a:p>
+          <a:p>
+            <a:pPr algn="l" indent="0" marL="0">
+              <a:lnSpc>
+                <a:spcPts val="2145"/>
+              </a:lnSpc>
+              <a:buNone/>
+            </a:pPr>
+            <a:r>
+              <a:rPr lang="en-US" sz="1650" dirty="0" spc="-1" kern="0">
+                <a:solidFill>
+                  <a:srgbClr val="6B6A66"/>
+                </a:solidFill>
+                <a:latin typeface="Be Vietnam Pro" pitchFamily="34" charset="0"/>
+                <a:ea typeface="Be Vietnam Pro" pitchFamily="34" charset="-122"/>
+                <a:cs typeface="Be Vietnam Pro" pitchFamily="34" charset="-120"/>
+              </a:rPr>
+              <a:t>Hình bỏ</a:t>
+            </a:r>
+            <a:r>
+              <a:rPr lang="en-US" sz="1650" dirty="0" spc="0" kern="0">
+                <a:solidFill>
+                  <a:srgbClr val="6B6A66"/>
+                </a:solidFill>
+                <a:latin typeface="Be Vietnam Pro" pitchFamily="34" charset="0"/>
+                <a:ea typeface="Be Vietnam Pro" pitchFamily="34" charset="-122"/>
+                <a:cs typeface="Be Vietnam Pro" pitchFamily="34" charset="-120"/>
+              </a:rPr>
+              <a:t> qua</a:t>
+            </a:r>
+            <a:r>
+              <a:rPr lang="en-US" sz="1650" dirty="0" spc="1" kern="0">
+                <a:solidFill>
+                  <a:srgbClr val="6B6A66"/>
+                </a:solidFill>
+                <a:latin typeface="Be Vietnam Pro" pitchFamily="34" charset="0"/>
+                <a:ea typeface="Be Vietnam Pro" pitchFamily="34" charset="-122"/>
+                <a:cs typeface="Be Vietnam Pro" pitchFamily="34" charset="-120"/>
+              </a:rPr>
+              <a:t> các</a:t>
+            </a:r>
+            <a:r>
+              <a:rPr lang="en-US" sz="1650" dirty="0" spc="-1" kern="0">
+                <a:solidFill>
+                  <a:srgbClr val="6B6A66"/>
+                </a:solidFill>
+                <a:latin typeface="Be Vietnam Pro" pitchFamily="34" charset="0"/>
+                <a:ea typeface="Be Vietnam Pro" pitchFamily="34" charset="-122"/>
+                <a:cs typeface="Be Vietnam Pro" pitchFamily="34" charset="-120"/>
+              </a:rPr>
+              <a:t> bản</a:t>
+            </a:r>
+            <a:r>
+              <a:rPr lang="en-US" sz="1650" dirty="0" spc="0" kern="0">
+                <a:solidFill>
+                  <a:srgbClr val="6B6A66"/>
+                </a:solidFill>
+                <a:latin typeface="Be Vietnam Pro" pitchFamily="34" charset="0"/>
+                <a:ea typeface="Be Vietnam Pro" pitchFamily="34" charset="-122"/>
+                <a:cs typeface="Be Vietnam Pro" pitchFamily="34" charset="-120"/>
+              </a:rPr>
+              <a:t> ghi</a:t>
+            </a:r>
+            <a:r>
+              <a:rPr lang="en-US" sz="1650" dirty="0" spc="-3" kern="0">
+                <a:solidFill>
+                  <a:srgbClr val="6B6A66"/>
+                </a:solidFill>
+                <a:latin typeface="Be Vietnam Pro" pitchFamily="34" charset="0"/>
+                <a:ea typeface="Be Vietnam Pro" pitchFamily="34" charset="-122"/>
+                <a:cs typeface="Be Vietnam Pro" pitchFamily="34" charset="-120"/>
+              </a:rPr>
+              <a:t> ChangeCipherSpec</a:t>
+            </a:r>
+            <a:r>
+              <a:rPr lang="en-US" sz="1650" dirty="0" spc="0" kern="0">
+                <a:solidFill>
+                  <a:srgbClr val="6B6A66"/>
+                </a:solidFill>
+                <a:latin typeface="Be Vietnam Pro" pitchFamily="34" charset="0"/>
+                <a:ea typeface="Be Vietnam Pro" pitchFamily="34" charset="-122"/>
+                <a:cs typeface="Be Vietnam Pro" pitchFamily="34" charset="-120"/>
+              </a:rPr>
+              <a:t> 1</a:t>
+            </a:r>
+            <a:r>
+              <a:rPr lang="en-US" sz="1650" dirty="0" spc="-8" kern="0">
+                <a:solidFill>
+                  <a:srgbClr val="6B6A66"/>
+                </a:solidFill>
+                <a:latin typeface="Be Vietnam Pro" pitchFamily="34" charset="0"/>
+                <a:ea typeface="Be Vietnam Pro" pitchFamily="34" charset="-122"/>
+                <a:cs typeface="Be Vietnam Pro" pitchFamily="34" charset="-120"/>
+              </a:rPr>
+              <a:t> byte.</a:t>
             </a:r>
             <a:endParaRPr lang="en-US" sz="1650" dirty="0"/>
           </a:p>
@@ -23420,7 +24611,7 @@
       </p:sp>
       <p:sp>
         <p:nvSpPr>
-          <p:cNvPr id="8" name="Connector line-1792334951379-28420562"/>
+          <p:cNvPr id="8" name="Connector line-1792337970389-233973811"/>
           <p:cNvSpPr/>
           <p:nvPr/>
         </p:nvSpPr>
@@ -23691,7 +24882,7 @@
       </p:sp>
       <p:sp>
         <p:nvSpPr>
-          <p:cNvPr id="16" name="Connector line-1792334951384-978475154"/>
+          <p:cNvPr id="16" name="Connector line-1792337970393-680932354"/>
           <p:cNvSpPr/>
           <p:nvPr/>
         </p:nvSpPr>
@@ -24328,13 +25519,13 @@
       </p:sp>
       <p:sp>
         <p:nvSpPr>
-          <p:cNvPr id="28" name="Connector line-1792334951409-535887878"/>
-          <p:cNvSpPr/>
-          <p:nvPr/>
-        </p:nvSpPr>
-        <p:spPr>
-          <a:xfrm>
-            <a:off x="10934700" y="4667250"/>
+          <p:cNvPr id="28" name="Connector line-1792337970406-135501588"/>
+          <p:cNvSpPr/>
+          <p:nvPr/>
+        </p:nvSpPr>
+        <p:spPr>
+          <a:xfrm>
+            <a:off x="10934700" y="4514850"/>
             <a:ext cx="5981700" cy="0"/>
           </a:xfrm>
           <a:prstGeom prst="line">
@@ -24361,8 +25552,8 @@
         </p:nvSpPr>
         <p:spPr>
           <a:xfrm>
-            <a:off x="10934700" y="4895850"/>
-            <a:ext cx="6000750" cy="914400"/>
+            <a:off x="10934700" y="4705350"/>
+            <a:ext cx="6000750" cy="1238250"/>
           </a:xfrm>
           <a:prstGeom prst="rect">
             <a:avLst/>
@@ -24437,7 +25628,60 @@
                 <a:ea typeface="Be Vietnam Pro" pitchFamily="34" charset="-122"/>
                 <a:cs typeface="Be Vietnam Pro" pitchFamily="34" charset="-120"/>
               </a:rPr>
-              <a:t>ServerHello, IP,</a:t>
+              <a:t>ServerHello,</a:t>
+            </a:r>
+            <a:r>
+              <a:rPr lang="en-US" sz="2400" dirty="0" spc="-4" kern="0">
+                <a:solidFill>
+                  <a:srgbClr val="FFFFFF"/>
+                </a:solidFill>
+                <a:latin typeface="Be Vietnam Pro" pitchFamily="34" charset="0"/>
+                <a:ea typeface="Be Vietnam Pro" pitchFamily="34" charset="-122"/>
+                <a:cs typeface="Be Vietnam Pro" pitchFamily="34" charset="-120"/>
+              </a:rPr>
+              <a:t> ChangeCipherSpec</a:t>
+            </a:r>
+            <a:endParaRPr lang="en-US" sz="2400" dirty="0"/>
+          </a:p>
+          <a:p>
+            <a:pPr algn="l" indent="0" marL="0">
+              <a:lnSpc>
+                <a:spcPts val="3120"/>
+              </a:lnSpc>
+              <a:buNone/>
+            </a:pPr>
+            <a:r>
+              <a:rPr lang="en-US" sz="2400" dirty="0" spc="-1" kern="0">
+                <a:solidFill>
+                  <a:srgbClr val="FFFFFF"/>
+                </a:solidFill>
+                <a:latin typeface="Be Vietnam Pro" pitchFamily="34" charset="0"/>
+                <a:ea typeface="Be Vietnam Pro" pitchFamily="34" charset="-122"/>
+                <a:cs typeface="Be Vietnam Pro" pitchFamily="34" charset="-120"/>
+              </a:rPr>
+              <a:t>1</a:t>
+            </a:r>
+            <a:r>
+              <a:rPr lang="en-US" sz="2400" dirty="0" spc="-13" kern="0">
+                <a:solidFill>
+                  <a:srgbClr val="FFFFFF"/>
+                </a:solidFill>
+                <a:latin typeface="Be Vietnam Pro" pitchFamily="34" charset="0"/>
+                <a:ea typeface="Be Vietnam Pro" pitchFamily="34" charset="-122"/>
+                <a:cs typeface="Be Vietnam Pro" pitchFamily="34" charset="-120"/>
+              </a:rPr>
+              <a:t> byte,</a:t>
+            </a:r>
+            <a:r>
+              <a:rPr lang="en-US" sz="2400" dirty="0" spc="-1" kern="0">
+                <a:solidFill>
+                  <a:srgbClr val="FFFFFF"/>
+                </a:solidFill>
+                <a:latin typeface="Be Vietnam Pro" pitchFamily="34" charset="0"/>
+                <a:ea typeface="Be Vietnam Pro" pitchFamily="34" charset="-122"/>
+                <a:cs typeface="Be Vietnam Pro" pitchFamily="34" charset="-120"/>
+              </a:rPr>
+              <a:t> IP,</a:t>
             </a:r>
             <a:r>
               <a:rPr lang="en-US" sz="2400" dirty="0" spc="18" kern="0">
@@ -24467,13 +25711,13 @@
       </p:sp>
       <p:sp>
         <p:nvSpPr>
-          <p:cNvPr id="30" name="Connector line-1792334951415-551467830"/>
-          <p:cNvSpPr/>
-          <p:nvPr/>
-        </p:nvSpPr>
-        <p:spPr>
-          <a:xfrm>
-            <a:off x="10934700" y="6057900"/>
+          <p:cNvPr id="30" name="Connector line-1792337970409-593126373"/>
+          <p:cNvSpPr/>
+          <p:nvPr/>
+        </p:nvSpPr>
+        <p:spPr>
+          <a:xfrm>
+            <a:off x="10934700" y="6134100"/>
             <a:ext cx="5981700" cy="0"/>
           </a:xfrm>
           <a:prstGeom prst="line">
@@ -24500,7 +25744,7 @@
         </p:nvSpPr>
         <p:spPr>
           <a:xfrm>
-            <a:off x="10934700" y="6286500"/>
+            <a:off x="10934700" y="6324600"/>
             <a:ext cx="6000750" cy="914400"/>
           </a:xfrm>
           <a:prstGeom prst="rect">
@@ -24628,13 +25872,13 @@
       </p:sp>
       <p:sp>
         <p:nvSpPr>
-          <p:cNvPr id="32" name="Connector line-1792334951418-165694885"/>
-          <p:cNvSpPr/>
-          <p:nvPr/>
-        </p:nvSpPr>
-        <p:spPr>
-          <a:xfrm>
-            <a:off x="10934700" y="7448550"/>
+          <p:cNvPr id="32" name="Connector line-1792337970411-439442497"/>
+          <p:cNvSpPr/>
+          <p:nvPr/>
+        </p:nvSpPr>
+        <p:spPr>
+          <a:xfrm>
+            <a:off x="10934700" y="7410450"/>
             <a:ext cx="5981700" cy="0"/>
           </a:xfrm>
           <a:prstGeom prst="line">
@@ -24661,7 +25905,7 @@
         </p:nvSpPr>
         <p:spPr>
           <a:xfrm>
-            <a:off x="10934700" y="7677150"/>
+            <a:off x="10934700" y="7600950"/>
             <a:ext cx="6000750" cy="914400"/>
           </a:xfrm>
           <a:prstGeom prst="rect">
@@ -24789,7 +26033,7 @@
       </p:sp>
       <p:sp>
         <p:nvSpPr>
-          <p:cNvPr id="34" name="Connector line-1792334951422-248260399"/>
+          <p:cNvPr id="34" name="Connector line-1792337970413-166759737"/>
           <p:cNvSpPr/>
           <p:nvPr/>
         </p:nvSpPr>

</xml_diff>

<commit_message>
System Design vi: sd-14-017 deck qualifies SNI exposure when ECH is not used
Co-Authored-By: Claude Sonnet 5.5 <noreply@anthropic.com>
Claude-Session: https://claude.ai/code/session_01WnjciXNJBLEd8jy3HrG49S
</commit_message>
<xml_diff>
--- a/system-design-101/vi/lessons/sd-14-017/slides/sd-14-017.pptx
+++ b/system-design-101/vi/lessons/sd-14-017/slides/sd-14-017.pptx
@@ -5930,7 +5930,7 @@
           <a:noFill/>
           <a:ln w="28575">
             <a:solidFill>
-              <a:srgbClr val="D8D3C4"/>
+              <a:srgbClr val="3DD6A0"/>
             </a:solidFill>
             <a:prstDash val="solid"/>
             <a:headEnd type="none"/>
@@ -5957,7 +5957,7 @@
           </a:solidFill>
           <a:ln w="28575">
             <a:solidFill>
-              <a:srgbClr val="D8D3C4"/>
+              <a:srgbClr val="3DD6A0"/>
             </a:solidFill>
             <a:prstDash val="solid"/>
           </a:ln>
@@ -5988,15 +5988,15 @@
               <a:buNone/>
             </a:pPr>
             <a:r>
-              <a:rPr lang="en-US" sz="3750" dirty="0" spc="-2" kern="0">
-                <a:solidFill>
-                  <a:srgbClr val="D8D3C4"/>
+              <a:rPr lang="en-US" sz="3750" dirty="0" spc="-30" kern="0">
+                <a:solidFill>
+                  <a:srgbClr val="3DD6A0"/>
                 </a:solidFill>
                 <a:latin typeface="Bricolage Grotesque ExtraBold" pitchFamily="34" charset="0"/>
                 <a:ea typeface="Bricolage Grotesque ExtraBold" pitchFamily="34" charset="-122"/>
                 <a:cs typeface="Bricolage Grotesque ExtraBold" pitchFamily="34" charset="-120"/>
               </a:rPr>
-              <a:t>HTML</a:t>
+              <a:t>ECH</a:t>
             </a:r>
             <a:endParaRPr lang="en-US" sz="3750" dirty="0"/>
           </a:p>
@@ -6030,7 +6030,7 @@
               <a:buNone/>
             </a:pPr>
             <a:r>
-              <a:rPr lang="en-US" sz="1650" dirty="0" spc="-31" kern="0">
+              <a:rPr lang="en-US" sz="1650" dirty="0" spc="-7" kern="0">
                 <a:solidFill>
                   <a:srgbClr val="9A98A0"/>
                 </a:solidFill>
@@ -6038,10 +6038,10 @@
                 <a:ea typeface="Be Vietnam Pro" pitchFamily="34" charset="-122"/>
                 <a:cs typeface="Be Vietnam Pro" pitchFamily="34" charset="-120"/>
               </a:rPr>
-              <a:t>HyperText</a:t>
-            </a:r>
-            <a:r>
-              <a:rPr lang="en-US" sz="1650" dirty="0" spc="-1" kern="0">
+              <a:t>Encrypted</a:t>
+            </a:r>
+            <a:r>
+              <a:rPr lang="en-US" sz="1650" dirty="0" spc="-4" kern="0">
                 <a:solidFill>
                   <a:srgbClr val="9A98A0"/>
                 </a:solidFill>
@@ -6049,10 +6049,10 @@
                 <a:ea typeface="Be Vietnam Pro" pitchFamily="34" charset="-122"/>
                 <a:cs typeface="Be Vietnam Pro" pitchFamily="34" charset="-120"/>
               </a:rPr>
-              <a:t> Markup</a:t>
-            </a:r>
-            <a:r>
-              <a:rPr lang="en-US" sz="1650" dirty="0" spc="-12" kern="0">
+              <a:t> Client</a:t>
+            </a:r>
+            <a:r>
+              <a:rPr lang="en-US" sz="1650" dirty="0" spc="-2" kern="0">
                 <a:solidFill>
                   <a:srgbClr val="9A98A0"/>
                 </a:solidFill>
@@ -6060,7 +6060,7 @@
                 <a:ea typeface="Be Vietnam Pro" pitchFamily="34" charset="-122"/>
                 <a:cs typeface="Be Vietnam Pro" pitchFamily="34" charset="-120"/>
               </a:rPr>
-              <a:t> Language</a:t>
+              <a:t> Hello</a:t>
             </a:r>
             <a:endParaRPr lang="en-US" sz="1650" dirty="0"/>
           </a:p>
@@ -6094,7 +6094,7 @@
               <a:buNone/>
             </a:pPr>
             <a:r>
-              <a:rPr lang="en-US" sz="1950" dirty="0" spc="-1" kern="0">
+              <a:rPr lang="en-US" sz="1950" dirty="0" spc="0" kern="0">
                 <a:solidFill>
                   <a:srgbClr val="D8D3C4"/>
                 </a:solidFill>
@@ -6102,10 +6102,10 @@
                 <a:ea typeface="Be Vietnam Pro" pitchFamily="34" charset="-122"/>
                 <a:cs typeface="Be Vietnam Pro" pitchFamily="34" charset="-120"/>
               </a:rPr>
-              <a:t>Mô</a:t>
-            </a:r>
-            <a:r>
-              <a:rPr lang="en-US" sz="1950" dirty="0" spc="-15" kern="0">
+              <a:t>Mã</a:t>
+            </a:r>
+            <a:r>
+              <a:rPr lang="en-US" sz="1950" dirty="0" spc="-4" kern="0">
                 <a:solidFill>
                   <a:srgbClr val="D8D3C4"/>
                 </a:solidFill>
@@ -6113,10 +6113,10 @@
                 <a:ea typeface="Be Vietnam Pro" pitchFamily="34" charset="-122"/>
                 <a:cs typeface="Be Vietnam Pro" pitchFamily="34" charset="-120"/>
               </a:rPr>
-              <a:t> tả</a:t>
-            </a:r>
-            <a:r>
-              <a:rPr lang="en-US" sz="1950" dirty="0" spc="-1" kern="0">
+              <a:t> hóa</a:t>
+            </a:r>
+            <a:r>
+              <a:rPr lang="en-US" sz="1950" dirty="0" spc="-3" kern="0">
                 <a:solidFill>
                   <a:srgbClr val="D8D3C4"/>
                 </a:solidFill>
@@ -6124,7 +6124,29 @@
                 <a:ea typeface="Be Vietnam Pro" pitchFamily="34" charset="-122"/>
                 <a:cs typeface="Be Vietnam Pro" pitchFamily="34" charset="-120"/>
               </a:rPr>
-              <a:t> cấu trúc</a:t>
+              <a:t> ClientHello,</a:t>
+            </a:r>
+            <a:r>
+              <a:rPr lang="en-US" sz="1950" dirty="0" spc="-29" kern="0">
+                <a:solidFill>
+                  <a:srgbClr val="D8D3C4"/>
+                </a:solidFill>
+                <a:latin typeface="Be Vietnam Pro" pitchFamily="34" charset="0"/>
+                <a:ea typeface="Be Vietnam Pro" pitchFamily="34" charset="-122"/>
+                <a:cs typeface="Be Vietnam Pro" pitchFamily="34" charset="-120"/>
+              </a:rPr>
+              <a:t> kể</a:t>
+            </a:r>
+            <a:r>
+              <a:rPr lang="en-US" sz="1950" dirty="0" spc="-3" kern="0">
+                <a:solidFill>
+                  <a:srgbClr val="D8D3C4"/>
+                </a:solidFill>
+                <a:latin typeface="Be Vietnam Pro" pitchFamily="34" charset="0"/>
+                <a:ea typeface="Be Vietnam Pro" pitchFamily="34" charset="-122"/>
+                <a:cs typeface="Be Vietnam Pro" pitchFamily="34" charset="-120"/>
+              </a:rPr>
+              <a:t> cả</a:t>
             </a:r>
             <a:r>
               <a:rPr lang="en-US" sz="1950" dirty="0" spc="-10" kern="0">
@@ -6135,10 +6157,10 @@
                 <a:ea typeface="Be Vietnam Pro" pitchFamily="34" charset="-122"/>
                 <a:cs typeface="Be Vietnam Pro" pitchFamily="34" charset="-120"/>
               </a:rPr>
-              <a:t> trang,</a:t>
-            </a:r>
-            <a:r>
-              <a:rPr lang="en-US" sz="1950" dirty="0" spc="0" kern="0">
+              <a:t> tên</a:t>
+            </a:r>
+            <a:r>
+              <a:rPr lang="en-US" sz="1950" dirty="0" spc="-7" kern="0">
                 <a:solidFill>
                   <a:srgbClr val="D8D3C4"/>
                 </a:solidFill>
@@ -6146,10 +6168,10 @@
                 <a:ea typeface="Be Vietnam Pro" pitchFamily="34" charset="-122"/>
                 <a:cs typeface="Be Vietnam Pro" pitchFamily="34" charset="-120"/>
               </a:rPr>
-              <a:t> không</a:t>
-            </a:r>
-            <a:r>
-              <a:rPr lang="en-US" sz="1950" dirty="0" spc="1" kern="0">
+              <a:t> máy</a:t>
+            </a:r>
+            <a:r>
+              <a:rPr lang="en-US" sz="1950" dirty="0" spc="-2" kern="0">
                 <a:solidFill>
                   <a:srgbClr val="D8D3C4"/>
                 </a:solidFill>
@@ -6157,29 +6179,7 @@
                 <a:ea typeface="Be Vietnam Pro" pitchFamily="34" charset="-122"/>
                 <a:cs typeface="Be Vietnam Pro" pitchFamily="34" charset="-120"/>
               </a:rPr>
-              <a:t> liên quan</a:t>
-            </a:r>
-            <a:r>
-              <a:rPr lang="en-US" sz="1950" dirty="0" spc="0" kern="0">
-                <a:solidFill>
-                  <a:srgbClr val="D8D3C4"/>
-                </a:solidFill>
-                <a:latin typeface="Be Vietnam Pro" pitchFamily="34" charset="0"/>
-                <a:ea typeface="Be Vietnam Pro" pitchFamily="34" charset="-122"/>
-                <a:cs typeface="Be Vietnam Pro" pitchFamily="34" charset="-120"/>
-              </a:rPr>
-              <a:t> mã</a:t>
-            </a:r>
-            <a:r>
-              <a:rPr lang="en-US" sz="1950" dirty="0" spc="-4" kern="0">
-                <a:solidFill>
-                  <a:srgbClr val="D8D3C4"/>
-                </a:solidFill>
-                <a:latin typeface="Be Vietnam Pro" pitchFamily="34" charset="0"/>
-                <a:ea typeface="Be Vietnam Pro" pitchFamily="34" charset="-122"/>
-                <a:cs typeface="Be Vietnam Pro" pitchFamily="34" charset="-120"/>
-              </a:rPr>
-              <a:t> hóa.</a:t>
+              <a:t> chủ.</a:t>
             </a:r>
             <a:endParaRPr lang="en-US" sz="1950" dirty="0"/>
           </a:p>
@@ -9979,7 +9979,7 @@
         <p:spPr>
           <a:xfrm>
             <a:off x="9144000" y="2171700"/>
-            <a:ext cx="5715000" cy="285750"/>
+            <a:ext cx="7905750" cy="285750"/>
           </a:xfrm>
           <a:prstGeom prst="rect">
             <a:avLst/>
@@ -10037,6 +10037,61 @@
                 <a:cs typeface="Be Vietnam Pro" pitchFamily="34" charset="-120"/>
               </a:rPr>
               <a:t> ĐƯỜNG</a:t>
+            </a:r>
+            <a:r>
+              <a:rPr lang="en-US" sz="1650" b="1" spc="230" kern="0" dirty="0">
+                <a:solidFill>
+                  <a:srgbClr val="FFB454"/>
+                </a:solidFill>
+                <a:latin typeface="Be Vietnam Pro" pitchFamily="34" charset="0"/>
+                <a:ea typeface="Be Vietnam Pro" pitchFamily="34" charset="-122"/>
+                <a:cs typeface="Be Vietnam Pro" pitchFamily="34" charset="-120"/>
+              </a:rPr>
+              <a:t> ·</a:t>
+            </a:r>
+            <a:r>
+              <a:rPr lang="en-US" sz="1650" b="1" spc="224" kern="0" dirty="0">
+                <a:solidFill>
+                  <a:srgbClr val="FFB454"/>
+                </a:solidFill>
+                <a:latin typeface="Be Vietnam Pro" pitchFamily="34" charset="0"/>
+                <a:ea typeface="Be Vietnam Pro" pitchFamily="34" charset="-122"/>
+                <a:cs typeface="Be Vietnam Pro" pitchFamily="34" charset="-120"/>
+              </a:rPr>
+              <a:t> KHI</a:t>
+            </a:r>
+            <a:r>
+              <a:rPr lang="en-US" sz="1650" b="1" spc="225" kern="0" dirty="0">
+                <a:solidFill>
+                  <a:srgbClr val="FFB454"/>
+                </a:solidFill>
+                <a:latin typeface="Be Vietnam Pro" pitchFamily="34" charset="0"/>
+                <a:ea typeface="Be Vietnam Pro" pitchFamily="34" charset="-122"/>
+                <a:cs typeface="Be Vietnam Pro" pitchFamily="34" charset="-120"/>
+              </a:rPr>
+              <a:t> KHÔNG</a:t>
+            </a:r>
+            <a:r>
+              <a:rPr lang="en-US" sz="1650" b="1" spc="228" kern="0" dirty="0">
+                <a:solidFill>
+                  <a:srgbClr val="FFB454"/>
+                </a:solidFill>
+                <a:latin typeface="Be Vietnam Pro" pitchFamily="34" charset="0"/>
+                <a:ea typeface="Be Vietnam Pro" pitchFamily="34" charset="-122"/>
+                <a:cs typeface="Be Vietnam Pro" pitchFamily="34" charset="-120"/>
+              </a:rPr>
+              <a:t> DÙNG</a:t>
+            </a:r>
+            <a:r>
+              <a:rPr lang="en-US" sz="1650" b="1" spc="219" kern="0" dirty="0">
+                <a:solidFill>
+                  <a:srgbClr val="FFB454"/>
+                </a:solidFill>
+                <a:latin typeface="Be Vietnam Pro" pitchFamily="34" charset="0"/>
+                <a:ea typeface="Be Vietnam Pro" pitchFamily="34" charset="-122"/>
+                <a:cs typeface="Be Vietnam Pro" pitchFamily="34" charset="-120"/>
+              </a:rPr>
+              <a:t> ECH</a:t>
             </a:r>
             <a:endParaRPr lang="en-US" sz="1650" dirty="0"/>
           </a:p>
@@ -20039,7 +20094,40 @@
                 <a:ea typeface="Be Vietnam Pro" pitchFamily="34" charset="-122"/>
                 <a:cs typeface="Be Vietnam Pro" pitchFamily="34" charset="-120"/>
               </a:rPr>
-              <a:t> bộ</a:t>
+              <a:t> bộ,</a:t>
+            </a:r>
+            <a:r>
+              <a:rPr lang="en-US" sz="1650" dirty="0" spc="1" kern="0">
+                <a:solidFill>
+                  <a:srgbClr val="6B6A66"/>
+                </a:solidFill>
+                <a:latin typeface="Be Vietnam Pro" pitchFamily="34" charset="0"/>
+                <a:ea typeface="Be Vietnam Pro" pitchFamily="34" charset="-122"/>
+                <a:cs typeface="Be Vietnam Pro" pitchFamily="34" charset="-120"/>
+              </a:rPr>
+              <a:t> không</a:t>
+            </a:r>
+            <a:r>
+              <a:rPr lang="en-US" sz="1650" dirty="0" spc="-1" kern="0">
+                <a:solidFill>
+                  <a:srgbClr val="6B6A66"/>
+                </a:solidFill>
+                <a:latin typeface="Be Vietnam Pro" pitchFamily="34" charset="0"/>
+                <a:ea typeface="Be Vietnam Pro" pitchFamily="34" charset="-122"/>
+                <a:cs typeface="Be Vietnam Pro" pitchFamily="34" charset="-120"/>
+              </a:rPr>
+              <a:t> dùng</a:t>
+            </a:r>
+            <a:r>
+              <a:rPr lang="en-US" sz="1650" dirty="0" spc="1" kern="0">
+                <a:solidFill>
+                  <a:srgbClr val="6B6A66"/>
+                </a:solidFill>
+                <a:latin typeface="Be Vietnam Pro" pitchFamily="34" charset="0"/>
+                <a:ea typeface="Be Vietnam Pro" pitchFamily="34" charset="-122"/>
+                <a:cs typeface="Be Vietnam Pro" pitchFamily="34" charset="-120"/>
+              </a:rPr>
+              <a:t> ECH</a:t>
             </a:r>
             <a:endParaRPr lang="en-US" sz="1650" dirty="0"/>
           </a:p>
@@ -20220,11 +20308,11 @@
         <p:spPr>
           <a:xfrm>
             <a:off x="8191500" y="914400"/>
-            <a:ext cx="9182100" cy="2495550"/>
+            <a:ext cx="9182100" cy="2857500"/>
           </a:xfrm>
           <a:prstGeom prst="roundRect">
             <a:avLst>
-              <a:gd name="adj" fmla="val 10687"/>
+              <a:gd name="adj" fmla="val 9333"/>
             </a:avLst>
           </a:prstGeom>
           <a:solidFill>
@@ -20301,7 +20389,7 @@
         <p:spPr>
           <a:xfrm>
             <a:off x="9296400" y="1219200"/>
-            <a:ext cx="7620000" cy="476250"/>
+            <a:ext cx="7905750" cy="476250"/>
           </a:xfrm>
           <a:prstGeom prst="rect">
             <a:avLst/>
@@ -20350,7 +20438,7 @@
               <a:t> chủ</a:t>
             </a:r>
             <a:r>
-              <a:rPr lang="en-US" sz="2850" b="1" dirty="0" spc="-20" kern="0">
+              <a:rPr lang="en-US" sz="2850" b="1" dirty="0" spc="7" kern="0">
                 <a:solidFill>
                   <a:srgbClr val="14161C"/>
                 </a:solidFill>
@@ -20358,7 +20446,18 @@
                 <a:ea typeface="Be Vietnam Pro" pitchFamily="34" charset="-122"/>
                 <a:cs typeface="Be Vietnam Pro" pitchFamily="34" charset="-120"/>
               </a:rPr>
-              <a:t> và</a:t>
+              <a:t> thường</a:t>
+            </a:r>
+            <a:r>
+              <a:rPr lang="en-US" sz="2850" b="1" dirty="0" spc="-4" kern="0">
+                <a:solidFill>
+                  <a:srgbClr val="14161C"/>
+                </a:solidFill>
+                <a:latin typeface="Be Vietnam Pro" pitchFamily="34" charset="0"/>
+                <a:ea typeface="Be Vietnam Pro" pitchFamily="34" charset="-122"/>
+                <a:cs typeface="Be Vietnam Pro" pitchFamily="34" charset="-120"/>
+              </a:rPr>
+              <a:t> lộ,</a:t>
             </a:r>
             <a:r>
               <a:rPr lang="en-US" sz="2850" b="1" dirty="0" spc="9" kern="0">
@@ -20383,7 +20482,7 @@
               <a:t> dài</a:t>
             </a:r>
             <a:r>
-              <a:rPr lang="en-US" sz="2850" b="1" dirty="0" spc="-12" kern="0">
+              <a:rPr lang="en-US" sz="2850" b="1" dirty="0" spc="1" kern="0">
                 <a:solidFill>
                   <a:srgbClr val="14161C"/>
                 </a:solidFill>
@@ -20391,10 +20490,10 @@
                 <a:ea typeface="Be Vietnam Pro" pitchFamily="34" charset="-122"/>
                 <a:cs typeface="Be Vietnam Pro" pitchFamily="34" charset="-120"/>
               </a:rPr>
-              <a:t> vẫn</a:t>
-            </a:r>
-            <a:r>
-              <a:rPr lang="en-US" sz="2850" b="1" dirty="0" spc="-5" kern="0">
+              <a:t> cũng</a:t>
+            </a:r>
+            <a:r>
+              <a:rPr lang="en-US" sz="2850" b="1" dirty="0" spc="-6" kern="0">
                 <a:solidFill>
                   <a:srgbClr val="14161C"/>
                 </a:solidFill>
@@ -20417,7 +20516,7 @@
         <p:spPr>
           <a:xfrm>
             <a:off x="9296400" y="1866900"/>
-            <a:ext cx="7620000" cy="1143000"/>
+            <a:ext cx="7620000" cy="914400"/>
           </a:xfrm>
           <a:prstGeom prst="rect">
             <a:avLst/>
@@ -20436,7 +20535,7 @@
               <a:buNone/>
             </a:pPr>
             <a:r>
-              <a:rPr lang="en-US" sz="2550" dirty="0" spc="7" kern="0">
+              <a:rPr lang="en-US" sz="2550" dirty="0" spc="-3" kern="0">
                 <a:solidFill>
                   <a:srgbClr val="14161C"/>
                 </a:solidFill>
@@ -20444,7 +20543,62 @@
                 <a:ea typeface="Be Vietnam Pro" pitchFamily="34" charset="-122"/>
                 <a:cs typeface="Be Vietnam Pro" pitchFamily="34" charset="-120"/>
               </a:rPr>
-              <a:t>Người</a:t>
+              <a:t>Khi</a:t>
+            </a:r>
+            <a:r>
+              <a:rPr lang="en-US" sz="2550" dirty="0" spc="0" kern="0">
+                <a:solidFill>
+                  <a:srgbClr val="14161C"/>
+                </a:solidFill>
+                <a:latin typeface="Be Vietnam Pro" pitchFamily="34" charset="0"/>
+                <a:ea typeface="Be Vietnam Pro" pitchFamily="34" charset="-122"/>
+                <a:cs typeface="Be Vietnam Pro" pitchFamily="34" charset="-120"/>
+              </a:rPr>
+              <a:t> không</a:t>
+            </a:r>
+            <a:r>
+              <a:rPr lang="en-US" sz="2550" dirty="0" spc="-1" kern="0">
+                <a:solidFill>
+                  <a:srgbClr val="14161C"/>
+                </a:solidFill>
+                <a:latin typeface="Be Vietnam Pro" pitchFamily="34" charset="0"/>
+                <a:ea typeface="Be Vietnam Pro" pitchFamily="34" charset="-122"/>
+                <a:cs typeface="Be Vietnam Pro" pitchFamily="34" charset="-120"/>
+              </a:rPr>
+              <a:t> dùng</a:t>
+            </a:r>
+            <a:r>
+              <a:rPr lang="en-US" sz="2550" dirty="0" spc="0" kern="0">
+                <a:solidFill>
+                  <a:srgbClr val="14161C"/>
+                </a:solidFill>
+                <a:latin typeface="Be Vietnam Pro" pitchFamily="34" charset="0"/>
+                <a:ea typeface="Be Vietnam Pro" pitchFamily="34" charset="-122"/>
+                <a:cs typeface="Be Vietnam Pro" pitchFamily="34" charset="-120"/>
+              </a:rPr>
+              <a:t> ECH,</a:t>
+            </a:r>
+            <a:r>
+              <a:rPr lang="en-US" sz="2550" dirty="0" spc="5" kern="0">
+                <a:solidFill>
+                  <a:srgbClr val="14161C"/>
+                </a:solidFill>
+                <a:latin typeface="Be Vietnam Pro" pitchFamily="34" charset="0"/>
+                <a:ea typeface="Be Vietnam Pro" pitchFamily="34" charset="-122"/>
+                <a:cs typeface="Be Vietnam Pro" pitchFamily="34" charset="-120"/>
+              </a:rPr>
+              <a:t> người</a:t>
+            </a:r>
+            <a:r>
+              <a:rPr lang="en-US" sz="2550" dirty="0" spc="0" kern="0">
+                <a:solidFill>
+                  <a:srgbClr val="14161C"/>
+                </a:solidFill>
+                <a:latin typeface="Be Vietnam Pro" pitchFamily="34" charset="0"/>
+                <a:ea typeface="Be Vietnam Pro" pitchFamily="34" charset="-122"/>
+                <a:cs typeface="Be Vietnam Pro" pitchFamily="34" charset="-120"/>
+              </a:rPr>
+              <a:t> nghe</a:t>
             </a:r>
             <a:r>
               <a:rPr lang="en-US" sz="2550" dirty="0" spc="1" kern="0">
@@ -20455,62 +20609,7 @@
                 <a:ea typeface="Be Vietnam Pro" pitchFamily="34" charset="-122"/>
                 <a:cs typeface="Be Vietnam Pro" pitchFamily="34" charset="-120"/>
               </a:rPr>
-              <a:t> nghe</a:t>
-            </a:r>
-            <a:r>
-              <a:rPr lang="en-US" sz="2550" dirty="0" spc="0" kern="0">
-                <a:solidFill>
-                  <a:srgbClr val="14161C"/>
-                </a:solidFill>
-                <a:latin typeface="Be Vietnam Pro" pitchFamily="34" charset="0"/>
-                <a:ea typeface="Be Vietnam Pro" pitchFamily="34" charset="-122"/>
-                <a:cs typeface="Be Vietnam Pro" pitchFamily="34" charset="-120"/>
-              </a:rPr>
               <a:t> lén</a:t>
-            </a:r>
-            <a:r>
-              <a:rPr lang="en-US" sz="2550" dirty="0" spc="-7" kern="0">
-                <a:solidFill>
-                  <a:srgbClr val="14161C"/>
-                </a:solidFill>
-                <a:latin typeface="Be Vietnam Pro" pitchFamily="34" charset="0"/>
-                <a:ea typeface="Be Vietnam Pro" pitchFamily="34" charset="-122"/>
-                <a:cs typeface="Be Vietnam Pro" pitchFamily="34" charset="-120"/>
-              </a:rPr>
-              <a:t> thấy</a:t>
-            </a:r>
-            <a:r>
-              <a:rPr lang="en-US" sz="2550" dirty="0" spc="-12" kern="0">
-                <a:solidFill>
-                  <a:srgbClr val="14161C"/>
-                </a:solidFill>
-                <a:latin typeface="Be Vietnam Pro" pitchFamily="34" charset="0"/>
-                <a:ea typeface="Be Vietnam Pro" pitchFamily="34" charset="-122"/>
-                <a:cs typeface="Be Vietnam Pro" pitchFamily="34" charset="-120"/>
-              </a:rPr>
-              <a:t> tên</a:t>
-            </a:r>
-            <a:r>
-              <a:rPr lang="en-US" sz="2550" dirty="0" spc="-9" kern="0">
-                <a:solidFill>
-                  <a:srgbClr val="14161C"/>
-                </a:solidFill>
-                <a:latin typeface="Be Vietnam Pro" pitchFamily="34" charset="0"/>
-                <a:ea typeface="Be Vietnam Pro" pitchFamily="34" charset="-122"/>
-                <a:cs typeface="Be Vietnam Pro" pitchFamily="34" charset="-120"/>
-              </a:rPr>
-              <a:t> máy</a:t>
-            </a:r>
-            <a:r>
-              <a:rPr lang="en-US" sz="2550" dirty="0" spc="-1" kern="0">
-                <a:solidFill>
-                  <a:srgbClr val="14161C"/>
-                </a:solidFill>
-                <a:latin typeface="Be Vietnam Pro" pitchFamily="34" charset="0"/>
-                <a:ea typeface="Be Vietnam Pro" pitchFamily="34" charset="-122"/>
-                <a:cs typeface="Be Vietnam Pro" pitchFamily="34" charset="-120"/>
-              </a:rPr>
-              <a:t> chủ</a:t>
             </a:r>
             <a:endParaRPr lang="en-US" sz="2550" dirty="0"/>
           </a:p>
@@ -20522,6 +20621,50 @@
               <a:buNone/>
             </a:pPr>
             <a:r>
+              <a:rPr lang="en-US" sz="2550" dirty="0" spc="-8" kern="0">
+                <a:solidFill>
+                  <a:srgbClr val="14161C"/>
+                </a:solidFill>
+                <a:latin typeface="Be Vietnam Pro" pitchFamily="34" charset="0"/>
+                <a:ea typeface="Be Vietnam Pro" pitchFamily="34" charset="-122"/>
+                <a:cs typeface="Be Vietnam Pro" pitchFamily="34" charset="-120"/>
+              </a:rPr>
+              <a:t>thấy</a:t>
+            </a:r>
+            <a:r>
+              <a:rPr lang="en-US" sz="2550" dirty="0" spc="-12" kern="0">
+                <a:solidFill>
+                  <a:srgbClr val="14161C"/>
+                </a:solidFill>
+                <a:latin typeface="Be Vietnam Pro" pitchFamily="34" charset="0"/>
+                <a:ea typeface="Be Vietnam Pro" pitchFamily="34" charset="-122"/>
+                <a:cs typeface="Be Vietnam Pro" pitchFamily="34" charset="-120"/>
+              </a:rPr>
+              <a:t> tên</a:t>
+            </a:r>
+            <a:r>
+              <a:rPr lang="en-US" sz="2550" dirty="0" spc="-9" kern="0">
+                <a:solidFill>
+                  <a:srgbClr val="14161C"/>
+                </a:solidFill>
+                <a:latin typeface="Be Vietnam Pro" pitchFamily="34" charset="0"/>
+                <a:ea typeface="Be Vietnam Pro" pitchFamily="34" charset="-122"/>
+                <a:cs typeface="Be Vietnam Pro" pitchFamily="34" charset="-120"/>
+              </a:rPr>
+              <a:t> máy</a:t>
+            </a:r>
+            <a:r>
+              <a:rPr lang="en-US" sz="2550" dirty="0" spc="-1" kern="0">
+                <a:solidFill>
+                  <a:srgbClr val="14161C"/>
+                </a:solidFill>
+                <a:latin typeface="Be Vietnam Pro" pitchFamily="34" charset="0"/>
+                <a:ea typeface="Be Vietnam Pro" pitchFamily="34" charset="-122"/>
+                <a:cs typeface="Be Vietnam Pro" pitchFamily="34" charset="-120"/>
+              </a:rPr>
+              <a:t> chủ</a:t>
+            </a:r>
+            <a:r>
               <a:rPr lang="en-US" sz="2550" dirty="0" spc="-3" kern="0">
                 <a:solidFill>
                   <a:srgbClr val="14161C"/>
@@ -20530,10 +20673,10 @@
                 <a:ea typeface="Be Vietnam Pro" pitchFamily="34" charset="-122"/>
                 <a:cs typeface="Be Vietnam Pro" pitchFamily="34" charset="-120"/>
               </a:rPr>
-              <a:t>(SNI)</a:t>
-            </a:r>
-            <a:r>
-              <a:rPr lang="en-US" sz="2550" dirty="0" spc="-19" kern="0">
+              <a:t> (SNI),</a:t>
+            </a:r>
+            <a:r>
+              <a:rPr lang="en-US" sz="2550" dirty="0" spc="16" kern="0">
                 <a:solidFill>
                   <a:srgbClr val="14161C"/>
                 </a:solidFill>
@@ -20541,10 +20684,10 @@
                 <a:ea typeface="Be Vietnam Pro" pitchFamily="34" charset="-122"/>
                 <a:cs typeface="Be Vietnam Pro" pitchFamily="34" charset="-120"/>
               </a:rPr>
-              <a:t> và</a:t>
-            </a:r>
-            <a:r>
-              <a:rPr lang="en-US" sz="2550" dirty="0" spc="17" kern="0">
+              <a:t> độ</a:t>
+            </a:r>
+            <a:r>
+              <a:rPr lang="en-US" sz="2550" dirty="0" spc="0" kern="0">
                 <a:solidFill>
                   <a:srgbClr val="14161C"/>
                 </a:solidFill>
@@ -20552,10 +20695,10 @@
                 <a:ea typeface="Be Vietnam Pro" pitchFamily="34" charset="-122"/>
                 <a:cs typeface="Be Vietnam Pro" pitchFamily="34" charset="-120"/>
               </a:rPr>
-              <a:t> độ</a:t>
-            </a:r>
-            <a:r>
-              <a:rPr lang="en-US" sz="2550" dirty="0" spc="0" kern="0">
+              <a:t> dài</a:t>
+            </a:r>
+            <a:r>
+              <a:rPr lang="en-US" sz="2550" dirty="0" spc="-3" kern="0">
                 <a:solidFill>
                   <a:srgbClr val="14161C"/>
                 </a:solidFill>
@@ -20563,10 +20706,10 @@
                 <a:ea typeface="Be Vietnam Pro" pitchFamily="34" charset="-122"/>
                 <a:cs typeface="Be Vietnam Pro" pitchFamily="34" charset="-120"/>
               </a:rPr>
-              <a:t> dài</a:t>
-            </a:r>
-            <a:r>
-              <a:rPr lang="en-US" sz="2550" dirty="0" spc="-3" kern="0">
+              <a:t> bản</a:t>
+            </a:r>
+            <a:r>
+              <a:rPr lang="en-US" sz="2550" dirty="0" spc="1" kern="0">
                 <a:solidFill>
                   <a:srgbClr val="14161C"/>
                 </a:solidFill>
@@ -20574,17 +20717,6 @@
                 <a:ea typeface="Be Vietnam Pro" pitchFamily="34" charset="-122"/>
                 <a:cs typeface="Be Vietnam Pro" pitchFamily="34" charset="-120"/>
               </a:rPr>
-              <a:t> bản</a:t>
-            </a:r>
-            <a:r>
-              <a:rPr lang="en-US" sz="2550" dirty="0" spc="0" kern="0">
-                <a:solidFill>
-                  <a:srgbClr val="14161C"/>
-                </a:solidFill>
-                <a:latin typeface="Be Vietnam Pro" pitchFamily="34" charset="0"/>
-                <a:ea typeface="Be Vietnam Pro" pitchFamily="34" charset="-122"/>
-                <a:cs typeface="Be Vietnam Pro" pitchFamily="34" charset="-120"/>
-              </a:rPr>
               <a:t> ghi.</a:t>
             </a:r>
             <a:endParaRPr lang="en-US" sz="2550" dirty="0"/>
@@ -20599,12 +20731,12 @@
         </p:nvSpPr>
         <p:spPr>
           <a:xfrm>
-            <a:off x="8191500" y="3600450"/>
-            <a:ext cx="9182100" cy="2495550"/>
+            <a:off x="8191500" y="3962400"/>
+            <a:ext cx="9182100" cy="2314575"/>
           </a:xfrm>
           <a:prstGeom prst="roundRect">
             <a:avLst>
-              <a:gd name="adj" fmla="val 10687"/>
+              <a:gd name="adj" fmla="val 11523"/>
             </a:avLst>
           </a:prstGeom>
           <a:solidFill>
@@ -20621,7 +20753,7 @@
         </p:nvSpPr>
         <p:spPr>
           <a:xfrm>
-            <a:off x="8477250" y="3886200"/>
+            <a:off x="8477250" y="4248150"/>
             <a:ext cx="571500" cy="571500"/>
           </a:xfrm>
           <a:prstGeom prst="ellipse">
@@ -20641,7 +20773,7 @@
         </p:nvSpPr>
         <p:spPr>
           <a:xfrm>
-            <a:off x="8477250" y="4000500"/>
+            <a:off x="8477250" y="4362450"/>
             <a:ext cx="571500" cy="381000"/>
           </a:xfrm>
           <a:prstGeom prst="rect">
@@ -20680,7 +20812,7 @@
         </p:nvSpPr>
         <p:spPr>
           <a:xfrm>
-            <a:off x="9296400" y="3905250"/>
+            <a:off x="9296400" y="4267200"/>
             <a:ext cx="7620000" cy="476250"/>
           </a:xfrm>
           <a:prstGeom prst="rect">
@@ -20785,7 +20917,7 @@
         </p:nvSpPr>
         <p:spPr>
           <a:xfrm>
-            <a:off x="9296400" y="4552950"/>
+            <a:off x="9296400" y="4914900"/>
             <a:ext cx="7620000" cy="1143000"/>
           </a:xfrm>
           <a:prstGeom prst="rect">
@@ -20935,12 +21067,12 @@
         </p:nvSpPr>
         <p:spPr>
           <a:xfrm>
-            <a:off x="8191500" y="6286500"/>
-            <a:ext cx="9182100" cy="2495550"/>
+            <a:off x="8191500" y="6467475"/>
+            <a:ext cx="9182100" cy="2314575"/>
           </a:xfrm>
           <a:prstGeom prst="roundRect">
             <a:avLst>
-              <a:gd name="adj" fmla="val 10687"/>
+              <a:gd name="adj" fmla="val 11523"/>
             </a:avLst>
           </a:prstGeom>
           <a:solidFill>
@@ -20957,7 +21089,7 @@
         </p:nvSpPr>
         <p:spPr>
           <a:xfrm>
-            <a:off x="8477250" y="6572250"/>
+            <a:off x="8477250" y="6753225"/>
             <a:ext cx="571500" cy="571500"/>
           </a:xfrm>
           <a:prstGeom prst="ellipse">
@@ -20977,7 +21109,7 @@
         </p:nvSpPr>
         <p:spPr>
           <a:xfrm>
-            <a:off x="8477250" y="6686550"/>
+            <a:off x="8477250" y="6867525"/>
             <a:ext cx="571500" cy="381000"/>
           </a:xfrm>
           <a:prstGeom prst="rect">
@@ -21016,7 +21148,7 @@
         </p:nvSpPr>
         <p:spPr>
           <a:xfrm>
-            <a:off x="9296400" y="6591300"/>
+            <a:off x="9296400" y="6772275"/>
             <a:ext cx="7620000" cy="476250"/>
           </a:xfrm>
           <a:prstGeom prst="rect">
@@ -21099,7 +21231,7 @@
         </p:nvSpPr>
         <p:spPr>
           <a:xfrm>
-            <a:off x="9296400" y="7239000"/>
+            <a:off x="9296400" y="7419975"/>
             <a:ext cx="7620000" cy="1143000"/>
           </a:xfrm>
           <a:prstGeom prst="rect">
@@ -21645,7 +21777,234 @@
       </p:sp>
       <p:sp>
         <p:nvSpPr>
-          <p:cNvPr id="46" name="Shape 44"/>
+          <p:cNvPr id="46" name="Text 44"/>
+          <p:cNvSpPr/>
+          <p:nvPr/>
+        </p:nvSpPr>
+        <p:spPr>
+          <a:xfrm>
+            <a:off x="9296400" y="2895600"/>
+            <a:ext cx="7848600" cy="666750"/>
+          </a:xfrm>
+          <a:prstGeom prst="rect">
+            <a:avLst/>
+          </a:prstGeom>
+          <a:noFill/>
+          <a:ln/>
+        </p:spPr>
+        <p:txBody>
+          <a:bodyPr wrap="square" lIns="0" tIns="10525" rIns="0" bIns="-10525" rtlCol="0" anchor="t"/>
+          <a:lstStyle/>
+          <a:p>
+            <a:pPr algn="l" indent="0" marL="0">
+              <a:lnSpc>
+                <a:spcPts val="2535"/>
+              </a:lnSpc>
+              <a:buNone/>
+            </a:pPr>
+            <a:r>
+              <a:rPr lang="en-US" sz="1950" dirty="0" spc="-4" kern="0">
+                <a:solidFill>
+                  <a:srgbClr val="0F766E"/>
+                </a:solidFill>
+                <a:latin typeface="Be Vietnam Pro SemiBold" pitchFamily="34" charset="0"/>
+                <a:ea typeface="Be Vietnam Pro SemiBold" pitchFamily="34" charset="-122"/>
+                <a:cs typeface="Be Vietnam Pro SemiBold" pitchFamily="34" charset="-120"/>
+              </a:rPr>
+              <a:t>ECH mã</a:t>
+            </a:r>
+            <a:r>
+              <a:rPr lang="en-US" sz="1950" dirty="0" spc="-6" kern="0">
+                <a:solidFill>
+                  <a:srgbClr val="0F766E"/>
+                </a:solidFill>
+                <a:latin typeface="Be Vietnam Pro SemiBold" pitchFamily="34" charset="0"/>
+                <a:ea typeface="Be Vietnam Pro SemiBold" pitchFamily="34" charset="-122"/>
+                <a:cs typeface="Be Vietnam Pro SemiBold" pitchFamily="34" charset="-120"/>
+              </a:rPr>
+              <a:t> hóa</a:t>
+            </a:r>
+            <a:r>
+              <a:rPr lang="en-US" sz="1950" dirty="0" spc="-3" kern="0">
+                <a:solidFill>
+                  <a:srgbClr val="0F766E"/>
+                </a:solidFill>
+                <a:latin typeface="Be Vietnam Pro SemiBold" pitchFamily="34" charset="0"/>
+                <a:ea typeface="Be Vietnam Pro SemiBold" pitchFamily="34" charset="-122"/>
+                <a:cs typeface="Be Vietnam Pro SemiBold" pitchFamily="34" charset="-120"/>
+              </a:rPr>
+              <a:t> ClientHello,</a:t>
+            </a:r>
+            <a:r>
+              <a:rPr lang="en-US" sz="1950" dirty="0" spc="-27" kern="0">
+                <a:solidFill>
+                  <a:srgbClr val="0F766E"/>
+                </a:solidFill>
+                <a:latin typeface="Be Vietnam Pro SemiBold" pitchFamily="34" charset="0"/>
+                <a:ea typeface="Be Vietnam Pro SemiBold" pitchFamily="34" charset="-122"/>
+                <a:cs typeface="Be Vietnam Pro SemiBold" pitchFamily="34" charset="-120"/>
+              </a:rPr>
+              <a:t> kể</a:t>
+            </a:r>
+            <a:r>
+              <a:rPr lang="en-US" sz="1950" dirty="0" spc="-2" kern="0">
+                <a:solidFill>
+                  <a:srgbClr val="0F766E"/>
+                </a:solidFill>
+                <a:latin typeface="Be Vietnam Pro SemiBold" pitchFamily="34" charset="0"/>
+                <a:ea typeface="Be Vietnam Pro SemiBold" pitchFamily="34" charset="-122"/>
+                <a:cs typeface="Be Vietnam Pro SemiBold" pitchFamily="34" charset="-120"/>
+              </a:rPr>
+              <a:t> cả</a:t>
+            </a:r>
+            <a:r>
+              <a:rPr lang="en-US" sz="1950" dirty="0" spc="-9" kern="0">
+                <a:solidFill>
+                  <a:srgbClr val="0F766E"/>
+                </a:solidFill>
+                <a:latin typeface="Be Vietnam Pro SemiBold" pitchFamily="34" charset="0"/>
+                <a:ea typeface="Be Vietnam Pro SemiBold" pitchFamily="34" charset="-122"/>
+                <a:cs typeface="Be Vietnam Pro SemiBold" pitchFamily="34" charset="-120"/>
+              </a:rPr>
+              <a:t> tên máy</a:t>
+            </a:r>
+            <a:r>
+              <a:rPr lang="en-US" sz="1950" dirty="0" spc="0" kern="0">
+                <a:solidFill>
+                  <a:srgbClr val="0F766E"/>
+                </a:solidFill>
+                <a:latin typeface="Be Vietnam Pro SemiBold" pitchFamily="34" charset="0"/>
+                <a:ea typeface="Be Vietnam Pro SemiBold" pitchFamily="34" charset="-122"/>
+                <a:cs typeface="Be Vietnam Pro SemiBold" pitchFamily="34" charset="-120"/>
+              </a:rPr>
+              <a:t> chủ.</a:t>
+            </a:r>
+            <a:endParaRPr lang="en-US" sz="1950" dirty="0"/>
+          </a:p>
+          <a:p>
+            <a:pPr algn="l" indent="0" marL="0">
+              <a:lnSpc>
+                <a:spcPts val="2535"/>
+              </a:lnSpc>
+              <a:buNone/>
+            </a:pPr>
+            <a:r>
+              <a:rPr lang="en-US" sz="1950" dirty="0" spc="15" kern="0">
+                <a:solidFill>
+                  <a:srgbClr val="0F766E"/>
+                </a:solidFill>
+                <a:latin typeface="Be Vietnam Pro SemiBold" pitchFamily="34" charset="0"/>
+                <a:ea typeface="Be Vietnam Pro SemiBold" pitchFamily="34" charset="-122"/>
+                <a:cs typeface="Be Vietnam Pro SemiBold" pitchFamily="34" charset="-120"/>
+              </a:rPr>
+              <a:t>Nhưng</a:t>
+            </a:r>
+            <a:r>
+              <a:rPr lang="en-US" sz="1950" dirty="0" spc="-2" kern="0">
+                <a:solidFill>
+                  <a:srgbClr val="0F766E"/>
+                </a:solidFill>
+                <a:latin typeface="Be Vietnam Pro SemiBold" pitchFamily="34" charset="0"/>
+                <a:ea typeface="Be Vietnam Pro SemiBold" pitchFamily="34" charset="-122"/>
+                <a:cs typeface="Be Vietnam Pro SemiBold" pitchFamily="34" charset="-120"/>
+              </a:rPr>
+              <a:t> IP</a:t>
+            </a:r>
+            <a:r>
+              <a:rPr lang="en-US" sz="1950" dirty="0" spc="-17" kern="0">
+                <a:solidFill>
+                  <a:srgbClr val="0F766E"/>
+                </a:solidFill>
+                <a:latin typeface="Be Vietnam Pro SemiBold" pitchFamily="34" charset="0"/>
+                <a:ea typeface="Be Vietnam Pro SemiBold" pitchFamily="34" charset="-122"/>
+                <a:cs typeface="Be Vietnam Pro SemiBold" pitchFamily="34" charset="-120"/>
+              </a:rPr>
+              <a:t> và</a:t>
+            </a:r>
+            <a:r>
+              <a:rPr lang="en-US" sz="1950" dirty="0" spc="-16" kern="0">
+                <a:solidFill>
+                  <a:srgbClr val="0F766E"/>
+                </a:solidFill>
+                <a:latin typeface="Be Vietnam Pro SemiBold" pitchFamily="34" charset="0"/>
+                <a:ea typeface="Be Vietnam Pro SemiBold" pitchFamily="34" charset="-122"/>
+                <a:cs typeface="Be Vietnam Pro SemiBold" pitchFamily="34" charset="-120"/>
+              </a:rPr>
+              <a:t> tra</a:t>
+            </a:r>
+            <a:r>
+              <a:rPr lang="en-US" sz="1950" dirty="0" spc="23" kern="0">
+                <a:solidFill>
+                  <a:srgbClr val="0F766E"/>
+                </a:solidFill>
+                <a:latin typeface="Be Vietnam Pro SemiBold" pitchFamily="34" charset="0"/>
+                <a:ea typeface="Be Vietnam Pro SemiBold" pitchFamily="34" charset="-122"/>
+                <a:cs typeface="Be Vietnam Pro SemiBold" pitchFamily="34" charset="-120"/>
+              </a:rPr>
+              <a:t> cứu</a:t>
+            </a:r>
+            <a:r>
+              <a:rPr lang="en-US" sz="1950" dirty="0" spc="-9" kern="0">
+                <a:solidFill>
+                  <a:srgbClr val="0F766E"/>
+                </a:solidFill>
+                <a:latin typeface="Be Vietnam Pro SemiBold" pitchFamily="34" charset="0"/>
+                <a:ea typeface="Be Vietnam Pro SemiBold" pitchFamily="34" charset="-122"/>
+                <a:cs typeface="Be Vietnam Pro SemiBold" pitchFamily="34" charset="-120"/>
+              </a:rPr>
+              <a:t> tên</a:t>
+            </a:r>
+            <a:r>
+              <a:rPr lang="en-US" sz="1950" dirty="0" spc="-2" kern="0">
+                <a:solidFill>
+                  <a:srgbClr val="0F766E"/>
+                </a:solidFill>
+                <a:latin typeface="Be Vietnam Pro SemiBold" pitchFamily="34" charset="0"/>
+                <a:ea typeface="Be Vietnam Pro SemiBold" pitchFamily="34" charset="-122"/>
+                <a:cs typeface="Be Vietnam Pro SemiBold" pitchFamily="34" charset="-120"/>
+              </a:rPr>
+              <a:t> miền</a:t>
+            </a:r>
+            <a:r>
+              <a:rPr lang="en-US" sz="1950" dirty="0" spc="0" kern="0">
+                <a:solidFill>
+                  <a:srgbClr val="0F766E"/>
+                </a:solidFill>
+                <a:latin typeface="Be Vietnam Pro SemiBold" pitchFamily="34" charset="0"/>
+                <a:ea typeface="Be Vietnam Pro SemiBold" pitchFamily="34" charset="-122"/>
+                <a:cs typeface="Be Vietnam Pro SemiBold" pitchFamily="34" charset="-120"/>
+              </a:rPr>
+              <a:t> có</a:t>
+            </a:r>
+            <a:r>
+              <a:rPr lang="en-US" sz="1950" dirty="0" spc="-5" kern="0">
+                <a:solidFill>
+                  <a:srgbClr val="0F766E"/>
+                </a:solidFill>
+                <a:latin typeface="Be Vietnam Pro SemiBold" pitchFamily="34" charset="0"/>
+                <a:ea typeface="Be Vietnam Pro SemiBold" pitchFamily="34" charset="-122"/>
+                <a:cs typeface="Be Vietnam Pro SemiBold" pitchFamily="34" charset="-120"/>
+              </a:rPr>
+              <a:t> thể</a:t>
+            </a:r>
+            <a:r>
+              <a:rPr lang="en-US" sz="1950" dirty="0" spc="-1" kern="0">
+                <a:solidFill>
+                  <a:srgbClr val="0F766E"/>
+                </a:solidFill>
+                <a:latin typeface="Be Vietnam Pro SemiBold" pitchFamily="34" charset="0"/>
+                <a:ea typeface="Be Vietnam Pro SemiBold" pitchFamily="34" charset="-122"/>
+                <a:cs typeface="Be Vietnam Pro SemiBold" pitchFamily="34" charset="-120"/>
+              </a:rPr>
+              <a:t> lộ.</a:t>
+            </a:r>
+            <a:endParaRPr lang="en-US" sz="1950" dirty="0"/>
+          </a:p>
+        </p:txBody>
+      </p:sp>
+      <p:sp>
+        <p:nvSpPr>
+          <p:cNvPr id="47" name="Shape 45"/>
           <p:cNvSpPr/>
           <p:nvPr/>
         </p:nvSpPr>
@@ -21669,7 +22028,7 @@
       </p:sp>
       <p:pic>
         <p:nvPicPr>
-          <p:cNvPr id="47" name="Moda image moda-export-watermark-4d33b8a5-9aa0-4666-ae8b-c7763bf6c663" descr="">    </p:cNvPr>
+          <p:cNvPr id="48" name="Moda image moda-export-watermark-4d33b8a5-9aa0-4666-ae8b-c7763bf6c663" descr="">    </p:cNvPr>
           <p:cNvPicPr>
             <a:picLocks noChangeAspect="1"/>
           </p:cNvPicPr>
@@ -25397,7 +25756,7 @@
               <a:buNone/>
             </a:pPr>
             <a:r>
-              <a:rPr lang="en-US" sz="4350" dirty="0" spc="-4" kern="0">
+              <a:rPr lang="en-US" sz="4350" dirty="0" spc="-50" kern="0">
                 <a:solidFill>
                   <a:srgbClr val="FFFFFF"/>
                 </a:solidFill>
@@ -25405,10 +25764,10 @@
                 <a:ea typeface="Bricolage Grotesque ExtraBold" pitchFamily="34" charset="-122"/>
                 <a:cs typeface="Bricolage Grotesque ExtraBold" pitchFamily="34" charset="-120"/>
               </a:rPr>
-              <a:t>Thấy</a:t>
-            </a:r>
-            <a:r>
-              <a:rPr lang="en-US" sz="4350" dirty="0" spc="-16" kern="0">
+              <a:t>Thường</a:t>
+            </a:r>
+            <a:r>
+              <a:rPr lang="en-US" sz="4350" dirty="0" spc="-3" kern="0">
                 <a:solidFill>
                   <a:srgbClr val="FFFFFF"/>
                 </a:solidFill>
@@ -25416,10 +25775,10 @@
                 <a:ea typeface="Bricolage Grotesque ExtraBold" pitchFamily="34" charset="-122"/>
                 <a:cs typeface="Bricolage Grotesque ExtraBold" pitchFamily="34" charset="-120"/>
               </a:rPr>
-              <a:t> tên</a:t>
-            </a:r>
-            <a:r>
-              <a:rPr lang="en-US" sz="4350" dirty="0" spc="0" kern="0">
+              <a:t> thấy</a:t>
+            </a:r>
+            <a:r>
+              <a:rPr lang="en-US" sz="4350" dirty="0" spc="-15" kern="0">
                 <a:solidFill>
                   <a:srgbClr val="FFFFFF"/>
                 </a:solidFill>
@@ -25427,18 +25786,7 @@
                 <a:ea typeface="Bricolage Grotesque ExtraBold" pitchFamily="34" charset="-122"/>
                 <a:cs typeface="Bricolage Grotesque ExtraBold" pitchFamily="34" charset="-120"/>
               </a:rPr>
-              <a:t> máy</a:t>
-            </a:r>
-            <a:r>
-              <a:rPr lang="en-US" sz="4350" dirty="0" spc="-5" kern="0">
-                <a:solidFill>
-                  <a:srgbClr val="FFFFFF"/>
-                </a:solidFill>
-                <a:latin typeface="Bricolage Grotesque ExtraBold" pitchFamily="34" charset="0"/>
-                <a:ea typeface="Bricolage Grotesque ExtraBold" pitchFamily="34" charset="-122"/>
-                <a:cs typeface="Bricolage Grotesque ExtraBold" pitchFamily="34" charset="-120"/>
-              </a:rPr>
-              <a:t> chủ,</a:t>
+              <a:t> tên</a:t>
             </a:r>
             <a:endParaRPr lang="en-US" sz="4350" dirty="0"/>
           </a:p>
@@ -25450,7 +25798,7 @@
               <a:buNone/>
             </a:pPr>
             <a:r>
-              <a:rPr lang="en-US" sz="4350" dirty="0" spc="-1" kern="0">
+              <a:rPr lang="en-US" sz="4350" dirty="0" spc="1" kern="0">
                 <a:solidFill>
                   <a:srgbClr val="FFFFFF"/>
                 </a:solidFill>
@@ -25458,10 +25806,32 @@
                 <a:ea typeface="Bricolage Grotesque ExtraBold" pitchFamily="34" charset="-122"/>
                 <a:cs typeface="Bricolage Grotesque ExtraBold" pitchFamily="34" charset="-120"/>
               </a:rPr>
-              <a:t>không</a:t>
-            </a:r>
-            <a:r>
-              <a:rPr lang="en-US" sz="4350" dirty="0" spc="-2" kern="0">
+              <a:t>máy</a:t>
+            </a:r>
+            <a:r>
+              <a:rPr lang="en-US" sz="4350" dirty="0" spc="-5" kern="0">
+                <a:solidFill>
+                  <a:srgbClr val="FFFFFF"/>
+                </a:solidFill>
+                <a:latin typeface="Bricolage Grotesque ExtraBold" pitchFamily="34" charset="0"/>
+                <a:ea typeface="Bricolage Grotesque ExtraBold" pitchFamily="34" charset="-122"/>
+                <a:cs typeface="Bricolage Grotesque ExtraBold" pitchFamily="34" charset="-120"/>
+              </a:rPr>
+              <a:t> chủ,</a:t>
+            </a:r>
+            <a:r>
+              <a:rPr lang="en-US" sz="4350" dirty="0" spc="-1" kern="0">
+                <a:solidFill>
+                  <a:srgbClr val="FFFFFF"/>
+                </a:solidFill>
+                <a:latin typeface="Bricolage Grotesque ExtraBold" pitchFamily="34" charset="0"/>
+                <a:ea typeface="Bricolage Grotesque ExtraBold" pitchFamily="34" charset="-122"/>
+                <a:cs typeface="Bricolage Grotesque ExtraBold" pitchFamily="34" charset="-120"/>
+              </a:rPr>
+              <a:t> không</a:t>
+            </a:r>
+            <a:r>
+              <a:rPr lang="en-US" sz="4350" dirty="0" spc="-3" kern="0">
                 <a:solidFill>
                   <a:srgbClr val="FFFFFF"/>
                 </a:solidFill>
@@ -25600,7 +25970,7 @@
               <a:buNone/>
             </a:pPr>
             <a:r>
-              <a:rPr lang="en-US" sz="2400" dirty="0" spc="-3" kern="0">
+              <a:rPr lang="en-US" sz="2400" dirty="0" spc="-4" kern="0">
                 <a:solidFill>
                   <a:srgbClr val="FFFFFF"/>
                 </a:solidFill>
@@ -25608,7 +25978,29 @@
                 <a:ea typeface="Be Vietnam Pro" pitchFamily="34" charset="-122"/>
                 <a:cs typeface="Be Vietnam Pro" pitchFamily="34" charset="-120"/>
               </a:rPr>
-              <a:t> ClientHello,</a:t>
+              <a:t> ClientHello</a:t>
+            </a:r>
+            <a:r>
+              <a:rPr lang="en-US" sz="2400" dirty="0" spc="-1" kern="0">
+                <a:solidFill>
+                  <a:srgbClr val="FFFFFF"/>
+                </a:solidFill>
+                <a:latin typeface="Be Vietnam Pro" pitchFamily="34" charset="0"/>
+                <a:ea typeface="Be Vietnam Pro" pitchFamily="34" charset="-122"/>
+                <a:cs typeface="Be Vietnam Pro" pitchFamily="34" charset="-120"/>
+              </a:rPr>
+              <a:t> (khi</a:t>
+            </a:r>
+            <a:r>
+              <a:rPr lang="en-US" sz="2400" dirty="0" spc="1" kern="0">
+                <a:solidFill>
+                  <a:srgbClr val="FFFFFF"/>
+                </a:solidFill>
+                <a:latin typeface="Be Vietnam Pro" pitchFamily="34" charset="0"/>
+                <a:ea typeface="Be Vietnam Pro" pitchFamily="34" charset="-122"/>
+                <a:cs typeface="Be Vietnam Pro" pitchFamily="34" charset="-120"/>
+              </a:rPr>
+              <a:t> không</a:t>
             </a:r>
             <a:endParaRPr lang="en-US" sz="2400" dirty="0"/>
           </a:p>
@@ -25620,6 +26012,28 @@
               <a:buNone/>
             </a:pPr>
             <a:r>
+              <a:rPr lang="en-US" sz="2400" dirty="0" spc="4" kern="0">
+                <a:solidFill>
+                  <a:srgbClr val="FFFFFF"/>
+                </a:solidFill>
+                <a:latin typeface="Be Vietnam Pro" pitchFamily="34" charset="0"/>
+                <a:ea typeface="Be Vietnam Pro" pitchFamily="34" charset="-122"/>
+                <a:cs typeface="Be Vietnam Pro" pitchFamily="34" charset="-120"/>
+              </a:rPr>
+              <a:t>dùng</a:t>
+            </a:r>
+            <a:r>
+              <a:rPr lang="en-US" sz="2400" dirty="0" spc="1" kern="0">
+                <a:solidFill>
+                  <a:srgbClr val="FFFFFF"/>
+                </a:solidFill>
+                <a:latin typeface="Be Vietnam Pro" pitchFamily="34" charset="0"/>
+                <a:ea typeface="Be Vietnam Pro" pitchFamily="34" charset="-122"/>
+                <a:cs typeface="Be Vietnam Pro" pitchFamily="34" charset="-120"/>
+              </a:rPr>
+              <a:t> ECH),</a:t>
+            </a:r>
+            <a:r>
               <a:rPr lang="en-US" sz="2400" dirty="0" spc="-3" kern="0">
                 <a:solidFill>
                   <a:srgbClr val="FFFFFF"/>
@@ -25628,7 +26042,7 @@
                 <a:ea typeface="Be Vietnam Pro" pitchFamily="34" charset="-122"/>
                 <a:cs typeface="Be Vietnam Pro" pitchFamily="34" charset="-120"/>
               </a:rPr>
-              <a:t>ServerHello,</a:t>
+              <a:t> ServerHello,</a:t>
             </a:r>
             <a:r>
               <a:rPr lang="en-US" sz="2400" dirty="0" spc="-4" kern="0">
@@ -25641,17 +26055,8 @@
               </a:rPr>
               <a:t> ChangeCipherSpec</a:t>
             </a:r>
-            <a:endParaRPr lang="en-US" sz="2400" dirty="0"/>
-          </a:p>
-          <a:p>
-            <a:pPr algn="l" indent="0" marL="0">
-              <a:lnSpc>
-                <a:spcPts val="3120"/>
-              </a:lnSpc>
-              <a:buNone/>
-            </a:pPr>
-            <a:r>
-              <a:rPr lang="en-US" sz="2400" dirty="0" spc="-1" kern="0">
+            <a:r>
+              <a:rPr lang="en-US" sz="2400" dirty="0" spc="0" kern="0">
                 <a:solidFill>
                   <a:srgbClr val="FFFFFF"/>
                 </a:solidFill>
@@ -25659,7 +26064,7 @@
                 <a:ea typeface="Be Vietnam Pro" pitchFamily="34" charset="-122"/>
                 <a:cs typeface="Be Vietnam Pro" pitchFamily="34" charset="-120"/>
               </a:rPr>
-              <a:t>1</a:t>
+              <a:t> 1</a:t>
             </a:r>
             <a:r>
               <a:rPr lang="en-US" sz="2400" dirty="0" spc="-13" kern="0">

</xml_diff>